<commit_message>
Présentation à jour (noms, dépôt, résultats, captures) et résultats des tests en PDF
</commit_message>
<xml_diff>
--- a/presentation/groupe3-si-wso2.pptx
+++ b/presentation/groupe3-si-wso2.pptx
@@ -15,6 +15,7 @@
     <p:sldId id="263" r:id="rId9"/>
     <p:sldId id="264" r:id="rId10"/>
     <p:sldId id="265" r:id="rId11"/>
+    <p:sldId id="269" r:id="rId20"/>
     <p:sldId id="266" r:id="rId12"/>
     <p:sldId id="267" r:id="rId13"/>
     <p:sldId id="268" r:id="rId14"/>
@@ -2443,7 +2444,7 @@
                   <a:schemeClr val="bg1"/>
                 </a:solidFill>
               </a:rPr>
-              <a:t>Membre 1 · Membre 2 · Membre 3 · Membre 4 · Membre 5</a:t>
+              <a:t>LOMPO Ephraim · OUOBA Arnaud · NIKIEMA Abdoul Fatahou · TIROUDA Leila · ROUAMBA Frank</a:t>
             </a:r>
             <a:endParaRPr lang="en-US" sz="1800" dirty="0"/>
           </a:p>
@@ -2538,6 +2539,10 @@
             <a:prstDash val="solid"/>
           </a:ln>
         </p:spPr>
+        <p:txBody>
+          <a:bodyPr/>
+          <a:p/>
+        </p:txBody>
       </p:sp>
       <p:sp>
         <p:nvSpPr>
@@ -2673,6 +2678,10 @@
             <a:prstDash val="solid"/>
           </a:ln>
         </p:spPr>
+        <p:txBody>
+          <a:bodyPr/>
+          <a:p/>
+        </p:txBody>
       </p:sp>
       <p:sp>
         <p:nvSpPr>
@@ -2808,6 +2817,10 @@
             <a:prstDash val="solid"/>
           </a:ln>
         </p:spPr>
+        <p:txBody>
+          <a:bodyPr/>
+          <a:p/>
+        </p:txBody>
       </p:sp>
       <p:sp>
         <p:nvSpPr>
@@ -2943,6 +2956,10 @@
             <a:prstDash val="solid"/>
           </a:ln>
         </p:spPr>
+        <p:txBody>
+          <a:bodyPr/>
+          <a:p/>
+        </p:txBody>
       </p:sp>
       <p:sp>
         <p:nvSpPr>
@@ -3078,6 +3095,10 @@
             <a:prstDash val="solid"/>
           </a:ln>
         </p:spPr>
+        <p:txBody>
+          <a:bodyPr/>
+          <a:p/>
+        </p:txBody>
       </p:sp>
       <p:sp>
         <p:nvSpPr>
@@ -3213,6 +3234,10 @@
             <a:prstDash val="solid"/>
           </a:ln>
         </p:spPr>
+        <p:txBody>
+          <a:bodyPr/>
+          <a:p/>
+        </p:txBody>
       </p:sp>
       <p:sp>
         <p:nvSpPr>
@@ -3348,6 +3373,10 @@
             <a:prstDash val="solid"/>
           </a:ln>
         </p:spPr>
+        <p:txBody>
+          <a:bodyPr/>
+          <a:p/>
+        </p:txBody>
       </p:sp>
       <p:sp>
         <p:nvSpPr>
@@ -3483,6 +3512,10 @@
             <a:prstDash val="solid"/>
           </a:ln>
         </p:spPr>
+        <p:txBody>
+          <a:bodyPr/>
+          <a:p/>
+        </p:txBody>
       </p:sp>
       <p:sp>
         <p:nvSpPr>
@@ -3618,6 +3651,10 @@
             <a:prstDash val="solid"/>
           </a:ln>
         </p:spPr>
+        <p:txBody>
+          <a:bodyPr/>
+          <a:p/>
+        </p:txBody>
       </p:sp>
       <p:sp>
         <p:nvSpPr>
@@ -3753,6 +3790,10 @@
             <a:prstDash val="solid"/>
           </a:ln>
         </p:spPr>
+        <p:txBody>
+          <a:bodyPr/>
+          <a:p/>
+        </p:txBody>
       </p:sp>
       <p:sp>
         <p:nvSpPr>
@@ -3888,6 +3929,10 @@
             <a:prstDash val="solid"/>
           </a:ln>
         </p:spPr>
+        <p:txBody>
+          <a:bodyPr/>
+          <a:p/>
+        </p:txBody>
       </p:sp>
       <p:sp>
         <p:nvSpPr>
@@ -3955,7 +4000,7 @@
                   <a:schemeClr val="tx2"/>
                 </a:solidFill>
               </a:rPr>
-              <a:t>5xx · 101503</a:t>
+              <a:t>500 · 101503</a:t>
             </a:r>
             <a:endParaRPr lang="en-US" sz="1200" dirty="0"/>
           </a:p>
@@ -4023,6 +4068,10 @@
             <a:prstDash val="solid"/>
           </a:ln>
         </p:spPr>
+        <p:txBody>
+          <a:bodyPr/>
+          <a:p/>
+        </p:txBody>
       </p:sp>
       <p:sp>
         <p:nvSpPr>
@@ -4158,6 +4207,10 @@
             <a:prstDash val="solid"/>
           </a:ln>
         </p:spPr>
+        <p:txBody>
+          <a:bodyPr/>
+          <a:p/>
+        </p:txBody>
       </p:sp>
       <p:sp>
         <p:nvSpPr>
@@ -4293,6 +4346,10 @@
             <a:prstDash val="solid"/>
           </a:ln>
         </p:spPr>
+        <p:txBody>
+          <a:bodyPr/>
+          <a:p/>
+        </p:txBody>
       </p:sp>
       <p:sp>
         <p:nvSpPr>
@@ -4344,7 +4401,7 @@
                   <a:schemeClr val="bg1"/>
                 </a:solidFill>
               </a:rPr>
-              <a:t>30 tests du backend</a:t>
+              <a:t>30 / 30 tests réussis</a:t>
             </a:r>
             <a:endParaRPr lang="en-US" sz="1400" dirty="0"/>
           </a:p>
@@ -4395,7 +4452,7 @@
                   <a:schemeClr val="bg1"/>
                 </a:solidFill>
               </a:rPr>
-              <a:t>démo manuelle, 6 dossiers</a:t>
+              <a:t>27 / 27 assertions réussies</a:t>
             </a:r>
             <a:endParaRPr lang="en-US" sz="1400" dirty="0"/>
           </a:p>
@@ -4446,7 +4503,41 @@
                   <a:schemeClr val="bg1"/>
                 </a:solidFill>
               </a:rPr>
-              <a:t>chaîne complète et rapport</a:t>
+              <a:t>16 / 16 scénarios réussis</a:t>
+            </a:r>
+            <a:endParaRPr lang="en-US" sz="1400" dirty="0"/>
+          </a:p>
+          <a:p>
+            <a:pPr indent="0" marL="0">
+              <a:spcAft>
+                <a:spcPts val="400"/>
+              </a:spcAft>
+              <a:buNone/>
+            </a:pPr>
+            <a:r>
+              <a:rPr lang="en-US" sz="800" dirty="0">
+                <a:solidFill>
+                  <a:schemeClr val="bg1"/>
+                </a:solidFill>
+              </a:rPr>
+              <a:t> </a:t>
+            </a:r>
+            <a:endParaRPr lang="en-US" sz="1400" dirty="0"/>
+          </a:p>
+          <a:p>
+            <a:pPr indent="0" marL="0">
+              <a:spcAft>
+                <a:spcPts val="400"/>
+              </a:spcAft>
+              <a:buNone/>
+            </a:pPr>
+            <a:r>
+              <a:rPr lang="en-US" sz="1200" dirty="0" i="1">
+                <a:solidFill>
+                  <a:schemeClr val="bg1"/>
+                </a:solidFill>
+              </a:rPr>
+              <a:t>Installation neuve du 29/10/2026</a:t>
             </a:r>
             <a:endParaRPr lang="en-US" sz="1400" dirty="0"/>
           </a:p>
@@ -4506,6 +4597,457 @@
 </file>
 
 <file path=ppt/slides/slide11.xml><?xml version="1.0" encoding="utf-8"?>
+<p:sld xmlns:a="http://schemas.openxmlformats.org/drawingml/2006/main" xmlns:p="http://schemas.openxmlformats.org/presentationml/2006/main" xmlns:r="http://schemas.openxmlformats.org/officeDocument/2006/relationships">
+  <p:cSld>
+    <p:spTree>
+      <p:nvGrpSpPr>
+        <p:cNvPr id="1" name=""/>
+        <p:cNvGrpSpPr/>
+        <p:nvPr/>
+      </p:nvGrpSpPr>
+      <p:grpSpPr/>
+      <p:sp>
+        <p:nvSpPr>
+          <p:cNvPr id="2" name="Text 0"/>
+          <p:cNvSpPr/>
+          <p:nvPr>
+            <p:ph idx="100" type="title" hasCustomPrompt="1"/>
+          </p:nvPr>
+        </p:nvSpPr>
+        <p:spPr>
+          <a:xfrm>
+            <a:off x="548640" y="320040"/>
+            <a:ext cx="11064240" cy="822960"/>
+          </a:xfrm>
+          <a:prstGeom prst="rect">
+            <a:avLst/>
+          </a:prstGeom>
+          <a:noFill/>
+          <a:ln/>
+        </p:spPr>
+        <p:txBody>
+          <a:bodyPr wrap="square" lIns="0" tIns="0" rIns="0" bIns="0" rtlCol="0" anchor="ctr"/>
+          <a:lstStyle/>
+          <a:p>
+            <a:pPr indent="0" marL="0">
+              <a:buNone/>
+            </a:pPr>
+            <a:r>
+              <a:rPr lang="en-US" sz="3200" b="1" dirty="0">
+                <a:solidFill>
+                  <a:schemeClr val="tx2"/>
+                </a:solidFill>
+              </a:rPr>
+              <a:t>Les preuves : captures réelles de WSO2</a:t>
+            </a:r>
+            <a:endParaRPr lang="en-US" sz="3200" dirty="0"/>
+          </a:p>
+        </p:txBody>
+      </p:sp>
+      <p:sp>
+        <p:nvSpPr>
+          <p:cNvPr id="25" name="Slide Number Placeholder 0"/>
+          <p:cNvSpPr>
+            <a:spLocks noGrp="1"/>
+          </p:cNvSpPr>
+          <p:nvPr>
+            <p:ph type="sldNum" sz="quarter" idx="4294967295"/>
+          </p:nvPr>
+        </p:nvSpPr>
+        <p:spPr>
+          <a:xfrm>
+            <a:off x="11155680" y="6400800"/>
+            <a:ext cx="457200" cy="274320"/>
+          </a:xfrm>
+          <a:prstGeom prst="rect">
+            <a:avLst/>
+          </a:prstGeom>
+          <a:extLst>
+            <a:ext uri="{C572A759-6A51-4108-AA02-DFA0A04FC94B}">
+              <ma14:wrappingTextBoxFlag xmlns:ma14="http://schemas.microsoft.com/office/mac/drawingml/2011/main" val="0"/>
+            </a:ext>
+          </a:extLst>
+        </p:spPr>
+        <p:txBody>
+          <a:bodyPr/>
+          <a:lstStyle>
+            <a:lvl1pPr>
+              <a:defRPr sz="1000">
+                <a:solidFill>
+                  <a:schemeClr val="accent4"/>
+                </a:solidFill>
+              </a:defRPr>
+            </a:lvl1pPr>
+          </a:lstStyle>
+          <a:p>
+            <a:pPr algn="r"/>
+            <a:fld id="{F7021451-1387-4CA6-816F-3879F97B5CBC}" type="slidenum">
+              <a:rPr b="0" lang="en-US"/>
+              <a:t>10</a:t>
+            </a:fld>
+            <a:endParaRPr lang="en-US"/>
+          </a:p>
+        </p:txBody>
+      </p:sp>
+      <p:pic>
+        <p:nvPicPr>
+          <p:cNvPr id="26" name="Picture 25" descr="03-cycle-de-vie-recadre.png"/>
+          <p:cNvPicPr>
+            <a:picLocks noChangeAspect="1"/>
+          </p:cNvPicPr>
+          <p:nvPr/>
+        </p:nvPicPr>
+        <p:blipFill>
+          <a:blip r:embed="rId2"/>
+          <a:stretch>
+            <a:fillRect/>
+          </a:stretch>
+        </p:blipFill>
+        <p:spPr>
+          <a:xfrm>
+            <a:off x="548640" y="1325880"/>
+            <a:ext cx="3520440" cy="2200275"/>
+          </a:xfrm>
+          <a:prstGeom prst="rect">
+            <a:avLst/>
+          </a:prstGeom>
+          <a:ln w="9525">
+            <a:solidFill>
+              <a:schemeClr val="accent1"/>
+            </a:solidFill>
+          </a:ln>
+        </p:spPr>
+      </p:pic>
+      <p:sp>
+        <p:nvSpPr>
+          <p:cNvPr id="27" name="TextBox 26"/>
+          <p:cNvSpPr txBox="1"/>
+          <p:nvPr/>
+        </p:nvSpPr>
+        <p:spPr>
+          <a:xfrm>
+            <a:off x="548640" y="3581019"/>
+            <a:ext cx="3520440" cy="292608"/>
+          </a:xfrm>
+          <a:prstGeom prst="rect">
+            <a:avLst/>
+          </a:prstGeom>
+          <a:noFill/>
+        </p:spPr>
+        <p:txBody>
+          <a:bodyPr wrap="square" lIns="0" rIns="0" tIns="0" bIns="0">
+            <a:spAutoFit/>
+          </a:bodyPr>
+          <a:lstStyle/>
+          <a:p>
+            <a:r>
+              <a:rPr sz="1200" b="1">
+                <a:solidFill>
+                  <a:schemeClr val="tx2"/>
+                </a:solidFill>
+              </a:rPr>
+              <a:t>Publisher : </a:t>
+            </a:r>
+            <a:r>
+              <a:rPr sz="1200">
+                <a:solidFill>
+                  <a:schemeClr val="accent4"/>
+                </a:solidFill>
+              </a:rPr>
+              <a:t>historique du cycle de vie de la v1</a:t>
+            </a:r>
+          </a:p>
+        </p:txBody>
+      </p:sp>
+      <p:pic>
+        <p:nvPicPr>
+          <p:cNvPr id="28" name="Picture 27" descr="06-admin-plan-quota.png"/>
+          <p:cNvPicPr>
+            <a:picLocks noChangeAspect="1"/>
+          </p:cNvPicPr>
+          <p:nvPr/>
+        </p:nvPicPr>
+        <p:blipFill>
+          <a:blip r:embed="rId3"/>
+          <a:stretch>
+            <a:fillRect/>
+          </a:stretch>
+        </p:blipFill>
+        <p:spPr>
+          <a:xfrm>
+            <a:off x="4343400" y="1325880"/>
+            <a:ext cx="3520440" cy="2200275"/>
+          </a:xfrm>
+          <a:prstGeom prst="rect">
+            <a:avLst/>
+          </a:prstGeom>
+          <a:ln w="9525">
+            <a:solidFill>
+              <a:schemeClr val="accent1"/>
+            </a:solidFill>
+          </a:ln>
+        </p:spPr>
+      </p:pic>
+      <p:sp>
+        <p:nvSpPr>
+          <p:cNvPr id="29" name="TextBox 28"/>
+          <p:cNvSpPr txBox="1"/>
+          <p:nvPr/>
+        </p:nvSpPr>
+        <p:spPr>
+          <a:xfrm>
+            <a:off x="4343400" y="3581019"/>
+            <a:ext cx="3520440" cy="292608"/>
+          </a:xfrm>
+          <a:prstGeom prst="rect">
+            <a:avLst/>
+          </a:prstGeom>
+          <a:noFill/>
+        </p:spPr>
+        <p:txBody>
+          <a:bodyPr wrap="square" lIns="0" rIns="0" tIns="0" bIns="0">
+            <a:spAutoFit/>
+          </a:bodyPr>
+          <a:lstStyle/>
+          <a:p>
+            <a:r>
+              <a:rPr sz="1200" b="1">
+                <a:solidFill>
+                  <a:schemeClr val="tx2"/>
+                </a:solidFill>
+              </a:rPr>
+              <a:t>Admin Portal : </a:t>
+            </a:r>
+            <a:r>
+              <a:rPr sz="1200">
+                <a:solidFill>
+                  <a:schemeClr val="accent4"/>
+                </a:solidFill>
+              </a:rPr>
+              <a:t>plan de 10 requêtes par minute</a:t>
+            </a:r>
+          </a:p>
+        </p:txBody>
+      </p:sp>
+      <p:pic>
+        <p:nvPicPr>
+          <p:cNvPr id="30" name="Picture 29" descr="09-devportal-souscriptions-app.png"/>
+          <p:cNvPicPr>
+            <a:picLocks noChangeAspect="1"/>
+          </p:cNvPicPr>
+          <p:nvPr/>
+        </p:nvPicPr>
+        <p:blipFill>
+          <a:blip r:embed="rId4"/>
+          <a:stretch>
+            <a:fillRect/>
+          </a:stretch>
+        </p:blipFill>
+        <p:spPr>
+          <a:xfrm>
+            <a:off x="8138160" y="1325880"/>
+            <a:ext cx="3520440" cy="2200275"/>
+          </a:xfrm>
+          <a:prstGeom prst="rect">
+            <a:avLst/>
+          </a:prstGeom>
+          <a:ln w="9525">
+            <a:solidFill>
+              <a:schemeClr val="accent1"/>
+            </a:solidFill>
+          </a:ln>
+        </p:spPr>
+      </p:pic>
+      <p:sp>
+        <p:nvSpPr>
+          <p:cNvPr id="31" name="TextBox 30"/>
+          <p:cNvSpPr txBox="1"/>
+          <p:nvPr/>
+        </p:nvSpPr>
+        <p:spPr>
+          <a:xfrm>
+            <a:off x="8138160" y="3581019"/>
+            <a:ext cx="3520440" cy="292608"/>
+          </a:xfrm>
+          <a:prstGeom prst="rect">
+            <a:avLst/>
+          </a:prstGeom>
+          <a:noFill/>
+        </p:spPr>
+        <p:txBody>
+          <a:bodyPr wrap="square" lIns="0" rIns="0" tIns="0" bIns="0">
+            <a:spAutoFit/>
+          </a:bodyPr>
+          <a:lstStyle/>
+          <a:p>
+            <a:r>
+              <a:rPr sz="1200" b="1">
+                <a:solidFill>
+                  <a:schemeClr val="tx2"/>
+                </a:solidFill>
+              </a:rPr>
+              <a:t>Developer Portal : </a:t>
+            </a:r>
+            <a:r>
+              <a:rPr sz="1200">
+                <a:solidFill>
+                  <a:schemeClr val="accent4"/>
+                </a:solidFill>
+              </a:rPr>
+              <a:t>souscriptions v1 et v2</a:t>
+            </a:r>
+          </a:p>
+        </p:txBody>
+      </p:sp>
+      <p:pic>
+        <p:nvPicPr>
+          <p:cNvPr id="32" name="Picture 31" descr="15-passerelle-t9-api-bloquee-503.png"/>
+          <p:cNvPicPr>
+            <a:picLocks noChangeAspect="1"/>
+          </p:cNvPicPr>
+          <p:nvPr/>
+        </p:nvPicPr>
+        <p:blipFill>
+          <a:blip r:embed="rId5"/>
+          <a:stretch>
+            <a:fillRect/>
+          </a:stretch>
+        </p:blipFill>
+        <p:spPr>
+          <a:xfrm>
+            <a:off x="548640" y="4069080"/>
+            <a:ext cx="5417820" cy="1503805"/>
+          </a:xfrm>
+          <a:prstGeom prst="rect">
+            <a:avLst/>
+          </a:prstGeom>
+          <a:ln w="9525">
+            <a:solidFill>
+              <a:schemeClr val="accent1"/>
+            </a:solidFill>
+          </a:ln>
+        </p:spPr>
+      </p:pic>
+      <p:sp>
+        <p:nvSpPr>
+          <p:cNvPr id="33" name="TextBox 32"/>
+          <p:cNvSpPr txBox="1"/>
+          <p:nvPr/>
+        </p:nvSpPr>
+        <p:spPr>
+          <a:xfrm>
+            <a:off x="548640" y="5735899"/>
+            <a:ext cx="5417820" cy="292608"/>
+          </a:xfrm>
+          <a:prstGeom prst="rect">
+            <a:avLst/>
+          </a:prstGeom>
+          <a:noFill/>
+        </p:spPr>
+        <p:txBody>
+          <a:bodyPr wrap="square" lIns="0" rIns="0" tIns="0" bIns="0">
+            <a:spAutoFit/>
+          </a:bodyPr>
+          <a:lstStyle/>
+          <a:p>
+            <a:r>
+              <a:rPr sz="1200" b="1">
+                <a:solidFill>
+                  <a:schemeClr val="tx2"/>
+                </a:solidFill>
+              </a:rPr>
+              <a:t>T9 : </a:t>
+            </a:r>
+            <a:r>
+              <a:rPr sz="1200">
+                <a:solidFill>
+                  <a:schemeClr val="accent4"/>
+                </a:solidFill>
+              </a:rPr>
+              <a:t>API bloquée, le backend tourne : 503 / 700700</a:t>
+            </a:r>
+          </a:p>
+        </p:txBody>
+      </p:sp>
+      <p:pic>
+        <p:nvPicPr>
+          <p:cNvPr id="34" name="Picture 33" descr="16-passerelle-t10-arret-technique-500.png"/>
+          <p:cNvPicPr>
+            <a:picLocks noChangeAspect="1"/>
+          </p:cNvPicPr>
+          <p:nvPr/>
+        </p:nvPicPr>
+        <p:blipFill>
+          <a:blip r:embed="rId6"/>
+          <a:stretch>
+            <a:fillRect/>
+          </a:stretch>
+        </p:blipFill>
+        <p:spPr>
+          <a:xfrm>
+            <a:off x="6240780" y="4069080"/>
+            <a:ext cx="5417820" cy="1611955"/>
+          </a:xfrm>
+          <a:prstGeom prst="rect">
+            <a:avLst/>
+          </a:prstGeom>
+          <a:ln w="9525">
+            <a:solidFill>
+              <a:schemeClr val="accent1"/>
+            </a:solidFill>
+          </a:ln>
+        </p:spPr>
+      </p:pic>
+      <p:sp>
+        <p:nvSpPr>
+          <p:cNvPr id="35" name="TextBox 34"/>
+          <p:cNvSpPr txBox="1"/>
+          <p:nvPr/>
+        </p:nvSpPr>
+        <p:spPr>
+          <a:xfrm>
+            <a:off x="6240780" y="5735899"/>
+            <a:ext cx="5417820" cy="292608"/>
+          </a:xfrm>
+          <a:prstGeom prst="rect">
+            <a:avLst/>
+          </a:prstGeom>
+          <a:noFill/>
+        </p:spPr>
+        <p:txBody>
+          <a:bodyPr wrap="square" lIns="0" rIns="0" tIns="0" bIns="0">
+            <a:spAutoFit/>
+          </a:bodyPr>
+          <a:lstStyle/>
+          <a:p>
+            <a:r>
+              <a:rPr sz="1200" b="1">
+                <a:solidFill>
+                  <a:schemeClr val="tx2"/>
+                </a:solidFill>
+              </a:rPr>
+              <a:t>T10 : </a:t>
+            </a:r>
+            <a:r>
+              <a:rPr sz="1200">
+                <a:solidFill>
+                  <a:schemeClr val="accent4"/>
+                </a:solidFill>
+              </a:rPr>
+              <a:t>backend arrêté, API toujours PUBLISHED : 500 / 101503</a:t>
+            </a:r>
+          </a:p>
+        </p:txBody>
+      </p:sp>
+    </p:spTree>
+  </p:cSld>
+  <p:clrMapOvr>
+    <a:masterClrMapping/>
+  </p:clrMapOvr>
+</p:sld>
+</file>
+
+<file path=ppt/slides/slide12.xml><?xml version="1.0" encoding="utf-8"?>
 <p:sld xmlns:a="http://schemas.openxmlformats.org/drawingml/2006/main" xmlns:r="http://schemas.openxmlformats.org/officeDocument/2006/relationships" xmlns:p="http://schemas.openxmlformats.org/presentationml/2006/main">
   <p:cSld name="Slide 11">
     <p:spTree>
@@ -4584,6 +5126,10 @@
             <a:prstDash val="solid"/>
           </a:ln>
         </p:spPr>
+        <p:txBody>
+          <a:bodyPr/>
+          <a:p/>
+        </p:txBody>
       </p:sp>
       <p:sp>
         <p:nvSpPr>
@@ -4647,6 +5193,10 @@
             <a:prstDash val="solid"/>
           </a:ln>
         </p:spPr>
+        <p:txBody>
+          <a:bodyPr/>
+          <a:p/>
+        </p:txBody>
       </p:sp>
       <p:sp>
         <p:nvSpPr>
@@ -4707,6 +5257,20 @@
         <p:txBody>
           <a:bodyPr wrap="square" lIns="0" tIns="0" rIns="0" bIns="0" rtlCol="0" anchor="ctr"/>
           <a:lstStyle/>
+          <a:p>
+            <a:pPr indent="0" marL="0">
+              <a:buNone/>
+            </a:pPr>
+            <a:r>
+              <a:rPr lang="en-US" sz="1200" dirty="0" b="1">
+                <a:solidFill>
+                  <a:schemeClr val="accent4"/>
+                </a:solidFill>
+              </a:rPr>
+              <a:t>github.com/leilatirouda/projet-dev-composant_Groupe3</a:t>
+            </a:r>
+            <a:endParaRPr lang="en-US" sz="1400" dirty="0"/>
+          </a:p>
           <a:p>
             <a:pPr indent="0" marL="0">
               <a:buNone/>
@@ -4747,6 +5311,10 @@
             <a:prstDash val="solid"/>
           </a:ln>
         </p:spPr>
+        <p:txBody>
+          <a:bodyPr/>
+          <a:p/>
+        </p:txBody>
       </p:sp>
       <p:sp>
         <p:nvSpPr>
@@ -4810,6 +5378,10 @@
             <a:prstDash val="solid"/>
           </a:ln>
         </p:spPr>
+        <p:txBody>
+          <a:bodyPr/>
+          <a:p/>
+        </p:txBody>
       </p:sp>
       <p:sp>
         <p:nvSpPr>
@@ -4910,6 +5482,10 @@
             <a:prstDash val="solid"/>
           </a:ln>
         </p:spPr>
+        <p:txBody>
+          <a:bodyPr/>
+          <a:p/>
+        </p:txBody>
       </p:sp>
       <p:sp>
         <p:nvSpPr>
@@ -4973,6 +5549,10 @@
             <a:prstDash val="solid"/>
           </a:ln>
         </p:spPr>
+        <p:txBody>
+          <a:bodyPr/>
+          <a:p/>
+        </p:txBody>
       </p:sp>
       <p:sp>
         <p:nvSpPr>
@@ -5073,6 +5653,10 @@
             <a:prstDash val="solid"/>
           </a:ln>
         </p:spPr>
+        <p:txBody>
+          <a:bodyPr/>
+          <a:p/>
+        </p:txBody>
       </p:sp>
       <p:sp>
         <p:nvSpPr>
@@ -5136,6 +5720,10 @@
             <a:prstDash val="solid"/>
           </a:ln>
         </p:spPr>
+        <p:txBody>
+          <a:bodyPr/>
+          <a:p/>
+        </p:txBody>
       </p:sp>
       <p:sp>
         <p:nvSpPr>
@@ -5206,7 +5794,7 @@
                   <a:schemeClr val="accent4"/>
                 </a:solidFill>
               </a:rPr>
-              <a:t>Scénarios T1 à T12 et rapport</a:t>
+              <a:t>16 / 16 scénarios réussis sur une installation neuve</a:t>
             </a:r>
             <a:endParaRPr lang="en-US" sz="1400" dirty="0"/>
           </a:p>
@@ -5265,7 +5853,7 @@
 </p:sld>
 </file>
 
-<file path=ppt/slides/slide12.xml><?xml version="1.0" encoding="utf-8"?>
+<file path=ppt/slides/slide13.xml><?xml version="1.0" encoding="utf-8"?>
 <p:sld xmlns:a="http://schemas.openxmlformats.org/drawingml/2006/main" xmlns:r="http://schemas.openxmlformats.org/officeDocument/2006/relationships" xmlns:p="http://schemas.openxmlformats.org/presentationml/2006/main">
   <p:cSld name="Slide 12">
     <p:spTree>
@@ -5417,6 +6005,56 @@
         <p:spPr>
           <a:xfrm>
             <a:off x="731520" y="3063240"/>
+            <a:ext cx="1691640" cy="658368"/>
+          </a:xfrm>
+          <a:prstGeom prst="rect">
+            <a:avLst/>
+          </a:prstGeom>
+          <a:noFill/>
+          <a:ln/>
+        </p:spPr>
+        <p:txBody>
+          <a:bodyPr wrap="square" lIns="0" tIns="0" rIns="0" bIns="0" rtlCol="0" anchor="t"/>
+          <a:lstStyle/>
+          <a:p>
+            <a:pPr algn="ctr" indent="0" marL="0">
+              <a:buNone/>
+            </a:pPr>
+            <a:r>
+              <a:rPr lang="en-US" sz="1700" b="1" dirty="0">
+                <a:solidFill>
+                  <a:schemeClr val="tx2"/>
+                </a:solidFill>
+              </a:rPr>
+              <a:t>LOMPO</a:t>
+            </a:r>
+            <a:endParaRPr lang="en-US" sz="1700" dirty="0"/>
+          </a:p>
+          <a:p>
+            <a:pPr algn="ctr" indent="0" marL="0">
+              <a:buNone/>
+            </a:pPr>
+            <a:r>
+              <a:rPr lang="en-US" sz="1500" b="1" dirty="0">
+                <a:solidFill>
+                  <a:schemeClr val="tx2"/>
+                </a:solidFill>
+              </a:rPr>
+              <a:t>Ephraim</a:t>
+            </a:r>
+            <a:endParaRPr lang="en-US" sz="1700" dirty="0"/>
+          </a:p>
+        </p:txBody>
+      </p:sp>
+      <p:sp>
+        <p:nvSpPr>
+          <p:cNvPr id="8" name="texte-238"/>
+          <p:cNvSpPr txBox="1"/>
+          <p:nvPr/>
+        </p:nvSpPr>
+        <p:spPr>
+          <a:xfrm>
+            <a:off x="731520" y="3794760"/>
             <a:ext cx="1691640" cy="365760"/>
           </a:xfrm>
           <a:prstGeom prst="rect">
@@ -5433,42 +6071,6 @@
               <a:buNone/>
             </a:pPr>
             <a:r>
-              <a:rPr lang="en-US" sz="1700" b="1" dirty="0">
-                <a:solidFill>
-                  <a:schemeClr val="tx2"/>
-                </a:solidFill>
-              </a:rPr>
-              <a:t>Membre 1</a:t>
-            </a:r>
-            <a:endParaRPr lang="en-US" sz="1700" dirty="0"/>
-          </a:p>
-        </p:txBody>
-      </p:sp>
-      <p:sp>
-        <p:nvSpPr>
-          <p:cNvPr id="8" name="texte-238"/>
-          <p:cNvSpPr txBox="1"/>
-          <p:nvPr/>
-        </p:nvSpPr>
-        <p:spPr>
-          <a:xfrm>
-            <a:off x="731520" y="3474720"/>
-            <a:ext cx="1691640" cy="365760"/>
-          </a:xfrm>
-          <a:prstGeom prst="rect">
-            <a:avLst/>
-          </a:prstGeom>
-          <a:noFill/>
-          <a:ln/>
-        </p:spPr>
-        <p:txBody>
-          <a:bodyPr wrap="square" lIns="0" tIns="0" rIns="0" bIns="0" rtlCol="0" anchor="t"/>
-          <a:lstStyle/>
-          <a:p>
-            <a:pPr algn="ctr" indent="0" marL="0">
-              <a:buNone/>
-            </a:pPr>
-            <a:r>
               <a:rPr lang="en-US" sz="1400" b="1" dirty="0">
                 <a:solidFill>
                   <a:schemeClr val="accent1"/>
@@ -5488,7 +6090,7 @@
         </p:nvSpPr>
         <p:spPr>
           <a:xfrm>
-            <a:off x="731520" y="3931920"/>
+            <a:off x="731520" y="4224528"/>
             <a:ext cx="1691640" cy="1463040"/>
           </a:xfrm>
           <a:prstGeom prst="rect">
@@ -5613,6 +6215,56 @@
         <p:spPr>
           <a:xfrm>
             <a:off x="2999232" y="3063240"/>
+            <a:ext cx="1691640" cy="658368"/>
+          </a:xfrm>
+          <a:prstGeom prst="rect">
+            <a:avLst/>
+          </a:prstGeom>
+          <a:noFill/>
+          <a:ln/>
+        </p:spPr>
+        <p:txBody>
+          <a:bodyPr wrap="square" lIns="0" tIns="0" rIns="0" bIns="0" rtlCol="0" anchor="t"/>
+          <a:lstStyle/>
+          <a:p>
+            <a:pPr algn="ctr" indent="0" marL="0">
+              <a:buNone/>
+            </a:pPr>
+            <a:r>
+              <a:rPr lang="en-US" sz="1700" b="1" dirty="0">
+                <a:solidFill>
+                  <a:schemeClr val="tx2"/>
+                </a:solidFill>
+              </a:rPr>
+              <a:t>OUOBA</a:t>
+            </a:r>
+            <a:endParaRPr lang="en-US" sz="1700" dirty="0"/>
+          </a:p>
+          <a:p>
+            <a:pPr algn="ctr" indent="0" marL="0">
+              <a:buNone/>
+            </a:pPr>
+            <a:r>
+              <a:rPr lang="en-US" sz="1500" b="1" dirty="0">
+                <a:solidFill>
+                  <a:schemeClr val="tx2"/>
+                </a:solidFill>
+              </a:rPr>
+              <a:t>Arnaud</a:t>
+            </a:r>
+            <a:endParaRPr lang="en-US" sz="1700" dirty="0"/>
+          </a:p>
+        </p:txBody>
+      </p:sp>
+      <p:sp>
+        <p:nvSpPr>
+          <p:cNvPr id="14" name="texte-244"/>
+          <p:cNvSpPr txBox="1"/>
+          <p:nvPr/>
+        </p:nvSpPr>
+        <p:spPr>
+          <a:xfrm>
+            <a:off x="2999232" y="3794760"/>
             <a:ext cx="1691640" cy="365760"/>
           </a:xfrm>
           <a:prstGeom prst="rect">
@@ -5629,42 +6281,6 @@
               <a:buNone/>
             </a:pPr>
             <a:r>
-              <a:rPr lang="en-US" sz="1700" b="1" dirty="0">
-                <a:solidFill>
-                  <a:schemeClr val="tx2"/>
-                </a:solidFill>
-              </a:rPr>
-              <a:t>Membre 2</a:t>
-            </a:r>
-            <a:endParaRPr lang="en-US" sz="1700" dirty="0"/>
-          </a:p>
-        </p:txBody>
-      </p:sp>
-      <p:sp>
-        <p:nvSpPr>
-          <p:cNvPr id="14" name="texte-244"/>
-          <p:cNvSpPr txBox="1"/>
-          <p:nvPr/>
-        </p:nvSpPr>
-        <p:spPr>
-          <a:xfrm>
-            <a:off x="2999232" y="3474720"/>
-            <a:ext cx="1691640" cy="365760"/>
-          </a:xfrm>
-          <a:prstGeom prst="rect">
-            <a:avLst/>
-          </a:prstGeom>
-          <a:noFill/>
-          <a:ln/>
-        </p:spPr>
-        <p:txBody>
-          <a:bodyPr wrap="square" lIns="0" tIns="0" rIns="0" bIns="0" rtlCol="0" anchor="t"/>
-          <a:lstStyle/>
-          <a:p>
-            <a:pPr algn="ctr" indent="0" marL="0">
-              <a:buNone/>
-            </a:pPr>
-            <a:r>
               <a:rPr lang="en-US" sz="1400" b="1" dirty="0">
                 <a:solidFill>
                   <a:schemeClr val="accent1"/>
@@ -5684,7 +6300,7 @@
         </p:nvSpPr>
         <p:spPr>
           <a:xfrm>
-            <a:off x="2999232" y="3931920"/>
+            <a:off x="2999232" y="4224528"/>
             <a:ext cx="1691640" cy="1463040"/>
           </a:xfrm>
           <a:prstGeom prst="rect">
@@ -5809,6 +6425,56 @@
         <p:spPr>
           <a:xfrm>
             <a:off x="5266944" y="3063240"/>
+            <a:ext cx="1691640" cy="658368"/>
+          </a:xfrm>
+          <a:prstGeom prst="rect">
+            <a:avLst/>
+          </a:prstGeom>
+          <a:noFill/>
+          <a:ln/>
+        </p:spPr>
+        <p:txBody>
+          <a:bodyPr wrap="square" lIns="0" tIns="0" rIns="0" bIns="0" rtlCol="0" anchor="t"/>
+          <a:lstStyle/>
+          <a:p>
+            <a:pPr algn="ctr" indent="0" marL="0">
+              <a:buNone/>
+            </a:pPr>
+            <a:r>
+              <a:rPr lang="en-US" sz="1700" b="1" dirty="0">
+                <a:solidFill>
+                  <a:schemeClr val="tx2"/>
+                </a:solidFill>
+              </a:rPr>
+              <a:t>NIKIEMA</a:t>
+            </a:r>
+            <a:endParaRPr lang="en-US" sz="1700" dirty="0"/>
+          </a:p>
+          <a:p>
+            <a:pPr algn="ctr" indent="0" marL="0">
+              <a:buNone/>
+            </a:pPr>
+            <a:r>
+              <a:rPr lang="en-US" sz="1500" b="1" dirty="0">
+                <a:solidFill>
+                  <a:schemeClr val="tx2"/>
+                </a:solidFill>
+              </a:rPr>
+              <a:t>Abdoul Fatahou</a:t>
+            </a:r>
+            <a:endParaRPr lang="en-US" sz="1700" dirty="0"/>
+          </a:p>
+        </p:txBody>
+      </p:sp>
+      <p:sp>
+        <p:nvSpPr>
+          <p:cNvPr id="20" name="texte-250"/>
+          <p:cNvSpPr txBox="1"/>
+          <p:nvPr/>
+        </p:nvSpPr>
+        <p:spPr>
+          <a:xfrm>
+            <a:off x="5266944" y="3794760"/>
             <a:ext cx="1691640" cy="365760"/>
           </a:xfrm>
           <a:prstGeom prst="rect">
@@ -5825,42 +6491,6 @@
               <a:buNone/>
             </a:pPr>
             <a:r>
-              <a:rPr lang="en-US" sz="1700" b="1" dirty="0">
-                <a:solidFill>
-                  <a:schemeClr val="tx2"/>
-                </a:solidFill>
-              </a:rPr>
-              <a:t>Membre 3</a:t>
-            </a:r>
-            <a:endParaRPr lang="en-US" sz="1700" dirty="0"/>
-          </a:p>
-        </p:txBody>
-      </p:sp>
-      <p:sp>
-        <p:nvSpPr>
-          <p:cNvPr id="20" name="texte-250"/>
-          <p:cNvSpPr txBox="1"/>
-          <p:nvPr/>
-        </p:nvSpPr>
-        <p:spPr>
-          <a:xfrm>
-            <a:off x="5266944" y="3474720"/>
-            <a:ext cx="1691640" cy="365760"/>
-          </a:xfrm>
-          <a:prstGeom prst="rect">
-            <a:avLst/>
-          </a:prstGeom>
-          <a:noFill/>
-          <a:ln/>
-        </p:spPr>
-        <p:txBody>
-          <a:bodyPr wrap="square" lIns="0" tIns="0" rIns="0" bIns="0" rtlCol="0" anchor="t"/>
-          <a:lstStyle/>
-          <a:p>
-            <a:pPr algn="ctr" indent="0" marL="0">
-              <a:buNone/>
-            </a:pPr>
-            <a:r>
               <a:rPr lang="en-US" sz="1400" b="1" dirty="0">
                 <a:solidFill>
                   <a:schemeClr val="accent1"/>
@@ -5880,7 +6510,7 @@
         </p:nvSpPr>
         <p:spPr>
           <a:xfrm>
-            <a:off x="5266944" y="3931920"/>
+            <a:off x="5266944" y="4224528"/>
             <a:ext cx="1691640" cy="1463040"/>
           </a:xfrm>
           <a:prstGeom prst="rect">
@@ -6005,6 +6635,56 @@
         <p:spPr>
           <a:xfrm>
             <a:off x="7534656" y="3063240"/>
+            <a:ext cx="1691640" cy="658368"/>
+          </a:xfrm>
+          <a:prstGeom prst="rect">
+            <a:avLst/>
+          </a:prstGeom>
+          <a:noFill/>
+          <a:ln/>
+        </p:spPr>
+        <p:txBody>
+          <a:bodyPr wrap="square" lIns="0" tIns="0" rIns="0" bIns="0" rtlCol="0" anchor="t"/>
+          <a:lstStyle/>
+          <a:p>
+            <a:pPr algn="ctr" indent="0" marL="0">
+              <a:buNone/>
+            </a:pPr>
+            <a:r>
+              <a:rPr lang="en-US" sz="1700" b="1" dirty="0">
+                <a:solidFill>
+                  <a:schemeClr val="tx2"/>
+                </a:solidFill>
+              </a:rPr>
+              <a:t>TIROUDA</a:t>
+            </a:r>
+            <a:endParaRPr lang="en-US" sz="1700" dirty="0"/>
+          </a:p>
+          <a:p>
+            <a:pPr algn="ctr" indent="0" marL="0">
+              <a:buNone/>
+            </a:pPr>
+            <a:r>
+              <a:rPr lang="en-US" sz="1500" b="1" dirty="0">
+                <a:solidFill>
+                  <a:schemeClr val="tx2"/>
+                </a:solidFill>
+              </a:rPr>
+              <a:t>Leila</a:t>
+            </a:r>
+            <a:endParaRPr lang="en-US" sz="1700" dirty="0"/>
+          </a:p>
+        </p:txBody>
+      </p:sp>
+      <p:sp>
+        <p:nvSpPr>
+          <p:cNvPr id="26" name="texte-256"/>
+          <p:cNvSpPr txBox="1"/>
+          <p:nvPr/>
+        </p:nvSpPr>
+        <p:spPr>
+          <a:xfrm>
+            <a:off x="7534656" y="3794760"/>
             <a:ext cx="1691640" cy="365760"/>
           </a:xfrm>
           <a:prstGeom prst="rect">
@@ -6021,42 +6701,6 @@
               <a:buNone/>
             </a:pPr>
             <a:r>
-              <a:rPr lang="en-US" sz="1700" b="1" dirty="0">
-                <a:solidFill>
-                  <a:schemeClr val="tx2"/>
-                </a:solidFill>
-              </a:rPr>
-              <a:t>Membre 4</a:t>
-            </a:r>
-            <a:endParaRPr lang="en-US" sz="1700" dirty="0"/>
-          </a:p>
-        </p:txBody>
-      </p:sp>
-      <p:sp>
-        <p:nvSpPr>
-          <p:cNvPr id="26" name="texte-256"/>
-          <p:cNvSpPr txBox="1"/>
-          <p:nvPr/>
-        </p:nvSpPr>
-        <p:spPr>
-          <a:xfrm>
-            <a:off x="7534656" y="3474720"/>
-            <a:ext cx="1691640" cy="365760"/>
-          </a:xfrm>
-          <a:prstGeom prst="rect">
-            <a:avLst/>
-          </a:prstGeom>
-          <a:noFill/>
-          <a:ln/>
-        </p:spPr>
-        <p:txBody>
-          <a:bodyPr wrap="square" lIns="0" tIns="0" rIns="0" bIns="0" rtlCol="0" anchor="t"/>
-          <a:lstStyle/>
-          <a:p>
-            <a:pPr algn="ctr" indent="0" marL="0">
-              <a:buNone/>
-            </a:pPr>
-            <a:r>
               <a:rPr lang="en-US" sz="1400" b="1" dirty="0">
                 <a:solidFill>
                   <a:schemeClr val="accent1"/>
@@ -6076,7 +6720,7 @@
         </p:nvSpPr>
         <p:spPr>
           <a:xfrm>
-            <a:off x="7534656" y="3931920"/>
+            <a:off x="7534656" y="4224528"/>
             <a:ext cx="1691640" cy="1463040"/>
           </a:xfrm>
           <a:prstGeom prst="rect">
@@ -6201,6 +6845,56 @@
         <p:spPr>
           <a:xfrm>
             <a:off x="9802368" y="3063240"/>
+            <a:ext cx="1691640" cy="658368"/>
+          </a:xfrm>
+          <a:prstGeom prst="rect">
+            <a:avLst/>
+          </a:prstGeom>
+          <a:noFill/>
+          <a:ln/>
+        </p:spPr>
+        <p:txBody>
+          <a:bodyPr wrap="square" lIns="0" tIns="0" rIns="0" bIns="0" rtlCol="0" anchor="t"/>
+          <a:lstStyle/>
+          <a:p>
+            <a:pPr algn="ctr" indent="0" marL="0">
+              <a:buNone/>
+            </a:pPr>
+            <a:r>
+              <a:rPr lang="en-US" sz="1700" b="1" dirty="0">
+                <a:solidFill>
+                  <a:schemeClr val="tx2"/>
+                </a:solidFill>
+              </a:rPr>
+              <a:t>ROUAMBA</a:t>
+            </a:r>
+            <a:endParaRPr lang="en-US" sz="1700" dirty="0"/>
+          </a:p>
+          <a:p>
+            <a:pPr algn="ctr" indent="0" marL="0">
+              <a:buNone/>
+            </a:pPr>
+            <a:r>
+              <a:rPr lang="en-US" sz="1500" b="1" dirty="0">
+                <a:solidFill>
+                  <a:schemeClr val="tx2"/>
+                </a:solidFill>
+              </a:rPr>
+              <a:t>Frank</a:t>
+            </a:r>
+            <a:endParaRPr lang="en-US" sz="1700" dirty="0"/>
+          </a:p>
+        </p:txBody>
+      </p:sp>
+      <p:sp>
+        <p:nvSpPr>
+          <p:cNvPr id="32" name="texte-262"/>
+          <p:cNvSpPr txBox="1"/>
+          <p:nvPr/>
+        </p:nvSpPr>
+        <p:spPr>
+          <a:xfrm>
+            <a:off x="9802368" y="3794760"/>
             <a:ext cx="1691640" cy="365760"/>
           </a:xfrm>
           <a:prstGeom prst="rect">
@@ -6217,42 +6911,6 @@
               <a:buNone/>
             </a:pPr>
             <a:r>
-              <a:rPr lang="en-US" sz="1700" b="1" dirty="0">
-                <a:solidFill>
-                  <a:schemeClr val="tx2"/>
-                </a:solidFill>
-              </a:rPr>
-              <a:t>Membre 5</a:t>
-            </a:r>
-            <a:endParaRPr lang="en-US" sz="1700" dirty="0"/>
-          </a:p>
-        </p:txBody>
-      </p:sp>
-      <p:sp>
-        <p:nvSpPr>
-          <p:cNvPr id="32" name="texte-262"/>
-          <p:cNvSpPr txBox="1"/>
-          <p:nvPr/>
-        </p:nvSpPr>
-        <p:spPr>
-          <a:xfrm>
-            <a:off x="9802368" y="3474720"/>
-            <a:ext cx="1691640" cy="365760"/>
-          </a:xfrm>
-          <a:prstGeom prst="rect">
-            <a:avLst/>
-          </a:prstGeom>
-          <a:noFill/>
-          <a:ln/>
-        </p:spPr>
-        <p:txBody>
-          <a:bodyPr wrap="square" lIns="0" tIns="0" rIns="0" bIns="0" rtlCol="0" anchor="t"/>
-          <a:lstStyle/>
-          <a:p>
-            <a:pPr algn="ctr" indent="0" marL="0">
-              <a:buNone/>
-            </a:pPr>
-            <a:r>
               <a:rPr lang="en-US" sz="1400" b="1" dirty="0">
                 <a:solidFill>
                   <a:schemeClr val="accent1"/>
@@ -6272,7 +6930,7 @@
         </p:nvSpPr>
         <p:spPr>
           <a:xfrm>
-            <a:off x="9802368" y="3931920"/>
+            <a:off x="9802368" y="4224528"/>
             <a:ext cx="1691640" cy="1463040"/>
           </a:xfrm>
           <a:prstGeom prst="rect">
@@ -6353,7 +7011,7 @@
 </p:sld>
 </file>
 
-<file path=ppt/slides/slide13.xml><?xml version="1.0" encoding="utf-8"?>
+<file path=ppt/slides/slide14.xml><?xml version="1.0" encoding="utf-8"?>
 <p:sld xmlns:a="http://schemas.openxmlformats.org/drawingml/2006/main" xmlns:r="http://schemas.openxmlformats.org/officeDocument/2006/relationships" xmlns:p="http://schemas.openxmlformats.org/presentationml/2006/main">
   <p:cSld name="Slide 13">
     <p:spTree>
@@ -14989,6 +15647,10 @@
             <a:prstDash val="solid"/>
           </a:ln>
         </p:spPr>
+        <p:txBody>
+          <a:bodyPr/>
+          <a:p/>
+        </p:txBody>
       </p:sp>
       <p:sp>
         <p:nvSpPr>
@@ -15052,6 +15714,10 @@
             <a:prstDash val="solid"/>
           </a:ln>
         </p:spPr>
+        <p:txBody>
+          <a:bodyPr/>
+          <a:p/>
+        </p:txBody>
       </p:sp>
       <p:sp>
         <p:nvSpPr>
@@ -15151,6 +15817,10 @@
             <a:prstDash val="solid"/>
           </a:ln>
         </p:spPr>
+        <p:txBody>
+          <a:bodyPr/>
+          <a:p/>
+        </p:txBody>
       </p:sp>
       <p:sp>
         <p:nvSpPr>
@@ -15250,6 +15920,10 @@
             <a:prstDash val="solid"/>
           </a:ln>
         </p:spPr>
+        <p:txBody>
+          <a:bodyPr/>
+          <a:p/>
+        </p:txBody>
       </p:sp>
       <p:sp>
         <p:nvSpPr>
@@ -15349,6 +16023,10 @@
             <a:prstDash val="solid"/>
           </a:ln>
         </p:spPr>
+        <p:txBody>
+          <a:bodyPr/>
+          <a:p/>
+        </p:txBody>
       </p:sp>
       <p:sp>
         <p:nvSpPr>
@@ -15448,6 +16126,10 @@
             <a:prstDash val="solid"/>
           </a:ln>
         </p:spPr>
+        <p:txBody>
+          <a:bodyPr/>
+          <a:p/>
+        </p:txBody>
       </p:sp>
       <p:sp>
         <p:nvSpPr>
@@ -15547,6 +16229,10 @@
             <a:prstDash val="solid"/>
           </a:ln>
         </p:spPr>
+        <p:txBody>
+          <a:bodyPr/>
+          <a:p/>
+        </p:txBody>
       </p:sp>
       <p:sp>
         <p:nvSpPr>
@@ -15610,6 +16296,10 @@
             <a:prstDash val="solid"/>
           </a:ln>
         </p:spPr>
+        <p:txBody>
+          <a:bodyPr/>
+          <a:p/>
+        </p:txBody>
       </p:sp>
       <p:sp>
         <p:nvSpPr>
@@ -15709,6 +16399,10 @@
             <a:prstDash val="solid"/>
           </a:ln>
         </p:spPr>
+        <p:txBody>
+          <a:bodyPr/>
+          <a:p/>
+        </p:txBody>
       </p:sp>
       <p:sp>
         <p:nvSpPr>
@@ -15808,6 +16502,10 @@
             <a:prstDash val="solid"/>
           </a:ln>
         </p:spPr>
+        <p:txBody>
+          <a:bodyPr/>
+          <a:p/>
+        </p:txBody>
       </p:sp>
       <p:sp>
         <p:nvSpPr>
@@ -15907,6 +16605,10 @@
             <a:prstDash val="solid"/>
           </a:ln>
         </p:spPr>
+        <p:txBody>
+          <a:bodyPr/>
+          <a:p/>
+        </p:txBody>
       </p:sp>
       <p:sp>
         <p:nvSpPr>
@@ -15974,7 +16676,7 @@
                   <a:schemeClr val="tx1"/>
                 </a:solidFill>
               </a:rPr>
-              <a:t>5xx · code 101503</a:t>
+              <a:t>500 · code 101503</a:t>
             </a:r>
             <a:endParaRPr lang="en-US" sz="1600" dirty="0"/>
           </a:p>

</xml_diff>

<commit_message>
Correction du README et de la présentation
</commit_message>
<xml_diff>
--- a/presentation/groupe3-si-wso2.pptx
+++ b/presentation/groupe3-si-wso2.pptx
@@ -4,6 +4,9 @@
   <p:sldMasterIdLst>
     <p:sldMasterId id="2147483648" r:id="rId1"/>
   </p:sldMasterIdLst>
+  <p:notesMasterIdLst>
+    <p:notesMasterId r:id="rId16"/>
+  </p:notesMasterIdLst>
   <p:sldIdLst>
     <p:sldId id="256" r:id="rId2"/>
     <p:sldId id="257" r:id="rId3"/>
@@ -15,14 +18,11 @@
     <p:sldId id="263" r:id="rId9"/>
     <p:sldId id="264" r:id="rId10"/>
     <p:sldId id="265" r:id="rId11"/>
-    <p:sldId id="269" r:id="rId20"/>
-    <p:sldId id="266" r:id="rId12"/>
-    <p:sldId id="267" r:id="rId13"/>
-    <p:sldId id="268" r:id="rId14"/>
+    <p:sldId id="269" r:id="rId12"/>
+    <p:sldId id="266" r:id="rId13"/>
+    <p:sldId id="267" r:id="rId14"/>
+    <p:sldId id="268" r:id="rId15"/>
   </p:sldIdLst>
-  <p:notesMasterIdLst>
-    <p:notesMasterId r:id="rId15"/>
-  </p:notesMasterIdLst>
   <p:sldSz cx="12192000" cy="6858000"/>
   <p:notesSz cx="6858000" cy="12192000"/>
   <p:defaultTextStyle>
@@ -120,20 +120,20 @@
   <p:extLst>
     <p:ext uri="{521415D9-36F7-43E2-AB2F-B90AF26B5E84}">
       <p14:sectionLst xmlns:p14="http://schemas.microsoft.com/office/powerpoint/2010/main">
-        <p14:section name="Introduction" id="{2d9cc00e-9bec-49c3-721c-39ae6390248c}">
+        <p14:section name="Introduction" id="{2D9CC00E-9BEC-49C3-721C-39AE6390248C}">
           <p14:sldIdLst>
             <p14:sldId id="256"/>
             <p14:sldId id="257"/>
           </p14:sldIdLst>
         </p14:section>
-        <p14:section name="Conception" id="{79a12982-34a5-cb81-5687-b24424ef5a81}">
+        <p14:section name="Conception" id="{79A12982-34A5-CB81-5687-B24424EF5A81}">
           <p14:sldIdLst>
             <p14:sldId id="258"/>
             <p14:sldId id="259"/>
             <p14:sldId id="260"/>
           </p14:sldIdLst>
         </p14:section>
-        <p14:section name="Gestion de l'API" id="{6cfb659a-8c77-f6bd-a79f-a43729a094a0}">
+        <p14:section name="Gestion de l'API" id="{6CFB659A-8C77-F6BD-A79F-A43729A094A0}">
           <p14:sldIdLst>
             <p14:sldId id="261"/>
             <p14:sldId id="262"/>
@@ -141,14 +141,15 @@
             <p14:sldId id="264"/>
           </p14:sldIdLst>
         </p14:section>
-        <p14:section name="Validation" id="{14e22d0e-64f2-fef5-a4cb-e30f713065c4}">
+        <p14:section name="Validation" id="{14E22D0E-64F2-FEF5-A4CB-E30F713065C4}">
           <p14:sldIdLst>
             <p14:sldId id="265"/>
+            <p14:sldId id="269"/>
             <p14:sldId id="266"/>
             <p14:sldId id="267"/>
           </p14:sldIdLst>
         </p14:section>
-        <p14:section name="Conclusion" id="{edec1692-647e-ab90-67c8-5ae38c86d1fd}">
+        <p14:section name="Conclusion" id="{EDEC1692-647E-AB90-67C8-5AE38C86D1FD}">
           <p14:sldIdLst>
             <p14:sldId id="268"/>
           </p14:sldIdLst>
@@ -184,234 +185,10 @@
           <a:chExt cx="0" cy="0"/>
         </a:xfrm>
       </p:grpSpPr>
-      <p:sp>
-        <p:nvSpPr>
-          <p:cNvPr id="2" name="Header Placeholder 1"/>
-          <p:cNvSpPr>
-            <a:spLocks noGrp="1"/>
-          </p:cNvSpPr>
-          <p:nvPr>
-            <p:ph type="hdr" sz="quarter"/>
-          </p:nvPr>
-        </p:nvSpPr>
-        <p:spPr>
-          <a:xfrm>
-            <a:off x="0" y="0"/>
-            <a:ext cx="2971800" cy="458788"/>
-          </a:xfrm>
-          <a:prstGeom prst="rect">
-            <a:avLst/>
-          </a:prstGeom>
-        </p:spPr>
-        <p:txBody>
-          <a:bodyPr vert="horz" lIns="91440" tIns="45720" rIns="91440" bIns="45720" rtlCol="0"/>
-          <a:lstStyle>
-            <a:lvl1pPr algn="l">
-              <a:defRPr sz="1200"/>
-            </a:lvl1pPr>
-          </a:lstStyle>
-          <a:p>
-            <a:endParaRPr lang="en-US"/>
-          </a:p>
-        </p:txBody>
-      </p:sp>
-      <p:sp>
-        <p:nvSpPr>
-          <p:cNvPr id="3" name="Date Placeholder 2"/>
-          <p:cNvSpPr>
-            <a:spLocks noGrp="1"/>
-          </p:cNvSpPr>
-          <p:nvPr>
-            <p:ph type="dt" idx="1"/>
-          </p:nvPr>
-        </p:nvSpPr>
-        <p:spPr>
-          <a:xfrm>
-            <a:off x="3884613" y="0"/>
-            <a:ext cx="2971800" cy="458788"/>
-          </a:xfrm>
-          <a:prstGeom prst="rect">
-            <a:avLst/>
-          </a:prstGeom>
-        </p:spPr>
-        <p:txBody>
-          <a:bodyPr vert="horz" lIns="91440" tIns="45720" rIns="91440" bIns="45720" rtlCol="0"/>
-          <a:lstStyle>
-            <a:lvl1pPr algn="r">
-              <a:defRPr sz="1200"/>
-            </a:lvl1pPr>
-          </a:lstStyle>
-          <a:p>
-            <a:fld id="{5282F153-3F37-0F45-9E97-73ACFA13230C}" type="datetimeFigureOut">
-              <a:rPr lang="en-US"/>
-              <a:t>7/23/19</a:t>
-            </a:fld>
-            <a:endParaRPr lang="en-US"/>
-          </a:p>
-        </p:txBody>
-      </p:sp>
-      <p:sp>
-        <p:nvSpPr>
-          <p:cNvPr id="4" name="Slide Image Placeholder 3"/>
-          <p:cNvSpPr>
-            <a:spLocks noGrp="1" noRot="1" noChangeAspect="1"/>
-          </p:cNvSpPr>
-          <p:nvPr>
-            <p:ph type="sldImg" idx="2"/>
-          </p:nvPr>
-        </p:nvSpPr>
-        <p:spPr>
-          <a:xfrm>
-            <a:off x="685800" y="1143000"/>
-            <a:ext cx="5486400" cy="3086100"/>
-          </a:xfrm>
-          <a:prstGeom prst="rect">
-            <a:avLst/>
-          </a:prstGeom>
-          <a:noFill/>
-          <a:ln w="12700">
-            <a:solidFill>
-              <a:prstClr val="black"/>
-            </a:solidFill>
-          </a:ln>
-        </p:spPr>
-        <p:txBody>
-          <a:bodyPr vert="horz" lIns="91440" tIns="45720" rIns="91440" bIns="45720" rtlCol="0" anchor="ctr"/>
-          <a:lstStyle/>
-          <a:p>
-            <a:endParaRPr lang="en-US"/>
-          </a:p>
-        </p:txBody>
-      </p:sp>
-      <p:sp>
-        <p:nvSpPr>
-          <p:cNvPr id="5" name="Notes Placeholder 4"/>
-          <p:cNvSpPr>
-            <a:spLocks noGrp="1"/>
-          </p:cNvSpPr>
-          <p:nvPr>
-            <p:ph type="body" sz="quarter" idx="3"/>
-          </p:nvPr>
-        </p:nvSpPr>
-        <p:spPr>
-          <a:xfrm>
-            <a:off x="685800" y="4400550"/>
-            <a:ext cx="5486400" cy="3600450"/>
-          </a:xfrm>
-          <a:prstGeom prst="rect">
-            <a:avLst/>
-          </a:prstGeom>
-        </p:spPr>
-        <p:txBody>
-          <a:bodyPr vert="horz" lIns="91440" tIns="45720" rIns="91440" bIns="45720" rtlCol="0"/>
-          <a:lstStyle/>
-          <a:p>
-            <a:pPr lvl="0"/>
-            <a:r>
-              <a:rPr lang="en-US"/>
-              <a:t>Click to edit Master text styles</a:t>
-            </a:r>
-          </a:p>
-          <a:p>
-            <a:pPr lvl="1"/>
-            <a:r>
-              <a:rPr lang="en-US"/>
-              <a:t>Second level</a:t>
-            </a:r>
-          </a:p>
-          <a:p>
-            <a:pPr lvl="2"/>
-            <a:r>
-              <a:rPr lang="en-US"/>
-              <a:t>Third level</a:t>
-            </a:r>
-          </a:p>
-          <a:p>
-            <a:pPr lvl="3"/>
-            <a:r>
-              <a:rPr lang="en-US"/>
-              <a:t>Fourth level</a:t>
-            </a:r>
-          </a:p>
-          <a:p>
-            <a:pPr lvl="4"/>
-            <a:r>
-              <a:rPr lang="en-US"/>
-              <a:t>Fifth level</a:t>
-            </a:r>
-          </a:p>
-        </p:txBody>
-      </p:sp>
-      <p:sp>
-        <p:nvSpPr>
-          <p:cNvPr id="6" name="Footer Placeholder 5"/>
-          <p:cNvSpPr>
-            <a:spLocks noGrp="1"/>
-          </p:cNvSpPr>
-          <p:nvPr>
-            <p:ph type="ftr" sz="quarter" idx="4"/>
-          </p:nvPr>
-        </p:nvSpPr>
-        <p:spPr>
-          <a:xfrm>
-            <a:off x="0" y="8685213"/>
-            <a:ext cx="2971800" cy="458787"/>
-          </a:xfrm>
-          <a:prstGeom prst="rect">
-            <a:avLst/>
-          </a:prstGeom>
-        </p:spPr>
-        <p:txBody>
-          <a:bodyPr vert="horz" lIns="91440" tIns="45720" rIns="91440" bIns="45720" rtlCol="0" anchor="b"/>
-          <a:lstStyle>
-            <a:lvl1pPr algn="l">
-              <a:defRPr sz="1200"/>
-            </a:lvl1pPr>
-          </a:lstStyle>
-          <a:p>
-            <a:endParaRPr lang="en-US"/>
-          </a:p>
-        </p:txBody>
-      </p:sp>
-      <p:sp>
-        <p:nvSpPr>
-          <p:cNvPr id="7" name="Slide Number Placeholder 6"/>
-          <p:cNvSpPr>
-            <a:spLocks noGrp="1"/>
-          </p:cNvSpPr>
-          <p:nvPr>
-            <p:ph type="sldNum" sz="quarter" idx="5"/>
-          </p:nvPr>
-        </p:nvSpPr>
-        <p:spPr>
-          <a:xfrm>
-            <a:off x="3884613" y="8685213"/>
-            <a:ext cx="2971800" cy="458787"/>
-          </a:xfrm>
-          <a:prstGeom prst="rect">
-            <a:avLst/>
-          </a:prstGeom>
-        </p:spPr>
-        <p:txBody>
-          <a:bodyPr vert="horz" lIns="91440" tIns="45720" rIns="91440" bIns="45720" rtlCol="0" anchor="b"/>
-          <a:lstStyle>
-            <a:lvl1pPr algn="r">
-              <a:defRPr sz="1200"/>
-            </a:lvl1pPr>
-          </a:lstStyle>
-          <a:p>
-            <a:fld id="{CE5E9CC1-C706-0F49-92D6-E571CC5EEA8F}" type="slidenum">
-              <a:rPr lang="en-US"/>
-              <a:t>‹#›</a:t>
-            </a:fld>
-            <a:endParaRPr lang="en-US"/>
-          </a:p>
-        </p:txBody>
-      </p:sp>
     </p:spTree>
     <p:extLst>
       <p:ext uri="{BB962C8B-B14F-4D97-AF65-F5344CB8AC3E}">
-        <p14:creationId xmlns:p14="http://schemas.microsoft.com/office/powerpoint/2010/main" val="1024086991"/>
+        <p14:creationId xmlns:p14="http://schemas.microsoft.com/office/powerpoint/2010/main" val="1839523082"/>
       </p:ext>
     </p:extLst>
   </p:cSld>
@@ -559,7 +336,6 @@
               <a:rPr lang="en-US" dirty="0"/>
               <a:t>Présentation du groupe et du thème : publier une API de santé dans WSO2 API Manager et gérer tout son cycle de vie, de la création au retrait. Remplacer « Membre 1 à 5 » par vos noms.</a:t>
             </a:r>
-            <a:endParaRPr lang="en-US" dirty="0"/>
           </a:p>
         </p:txBody>
       </p:sp>
@@ -647,7 +423,6 @@
               <a:rPr lang="en-US" dirty="0"/>
               <a:t>Trois niveaux de tests : pytest pour le backend seul, la collection Postman pour la démo manuelle, et e2e.py qui enchaîne tout le scénario de bout en bout sur WSO2 et écrit le rapport resultats-obtenus.md. Le quota (T8) passe en dernier car il consomme le plan pendant une minute.</a:t>
             </a:r>
-            <a:endParaRPr lang="en-US" dirty="0"/>
           </a:p>
         </p:txBody>
       </p:sp>
@@ -735,7 +510,6 @@
               <a:rPr lang="en-US" dirty="0"/>
               <a:t>Montrer qu'aucune configuration n'est faite à la main. Tout est dans le dépôt : base, API, contrats, configuration WSO2 et tests. La procédure manuelle docs/wso2-setup.md reste disponible en secours.</a:t>
             </a:r>
-            <a:endParaRPr lang="en-US" dirty="0"/>
           </a:p>
         </p:txBody>
       </p:sp>
@@ -756,7 +530,7 @@
           <a:p>
             <a:fld id="{F7021451-1387-4CA6-816F-3879F97B5CBC}" type="slidenum">
               <a:rPr lang="en-US"/>
-              <a:t>11</a:t>
+              <a:t>12</a:t>
             </a:fld>
             <a:endParaRPr lang="en-US"/>
           </a:p>
@@ -823,7 +597,6 @@
               <a:rPr lang="en-US" dirty="0"/>
               <a:t>Chaque membre présente sa partie et a poussé ses fichiers sur sa propre branche, avec une Pull Request relue par le chef de projet. Remplacer les noms.</a:t>
             </a:r>
-            <a:endParaRPr lang="en-US" dirty="0"/>
           </a:p>
         </p:txBody>
       </p:sp>
@@ -844,7 +617,7 @@
           <a:p>
             <a:fld id="{F7021451-1387-4CA6-816F-3879F97B5CBC}" type="slidenum">
               <a:rPr lang="en-US"/>
-              <a:t>12</a:t>
+              <a:t>13</a:t>
             </a:fld>
             <a:endParaRPr lang="en-US"/>
           </a:p>
@@ -911,7 +684,6 @@
               <a:rPr lang="en-US" dirty="0"/>
               <a:t>Lancer la démo : python tests/e2e.py, ou les dossiers Postman un par un. Garder la vidéo de secours prête si le réseau ou la machine pose problème.</a:t>
             </a:r>
-            <a:endParaRPr lang="en-US" dirty="0"/>
           </a:p>
         </p:txBody>
       </p:sp>
@@ -932,7 +704,7 @@
           <a:p>
             <a:fld id="{F7021451-1387-4CA6-816F-3879F97B5CBC}" type="slidenum">
               <a:rPr lang="en-US"/>
-              <a:t>13</a:t>
+              <a:t>14</a:t>
             </a:fld>
             <a:endParaRPr lang="en-US"/>
           </a:p>
@@ -999,7 +771,6 @@
               <a:rPr lang="en-US" dirty="0"/>
               <a:t>Rappeler les 7 consignes du prof. Chaque carte renvoie à une partie de la démo. Insister sur la 7e : c'est le point le plus original du sujet.</a:t>
             </a:r>
-            <a:endParaRPr lang="en-US" dirty="0"/>
           </a:p>
         </p:txBody>
       </p:sp>
@@ -1087,7 +858,6 @@
               <a:rPr lang="en-US" dirty="0"/>
               <a:t>Parcours d'une requête : le client obtient un jeton sur le port 9443, appelle la passerelle sur 8243, WSO2 vérifie le jeton, la souscription et le quota, puis transmet au backend FastAPI qui lit PostgreSQL. Tout tourne dans Docker Compose ; WSO2 joint le backend par le nom de service « api ».</a:t>
             </a:r>
-            <a:endParaRPr lang="en-US" dirty="0"/>
           </a:p>
         </p:txBody>
       </p:sp>
@@ -1175,7 +945,6 @@
               <a:rPr lang="en-US" dirty="0"/>
               <a:t>Trois routes en lecture seule. Les paramètres sont validés : page &gt;= 1, size entre 1 et 100, type dans une liste fermée. Toute erreur a le même format JSON. Si la base tombe, l'API renvoie 503 au lieu de planter.</a:t>
             </a:r>
-            <a:endParaRPr lang="en-US" dirty="0"/>
           </a:p>
         </p:txBody>
       </p:sp>
@@ -1263,7 +1032,6 @@
               <a:rPr lang="en-US" dirty="0"/>
               <a:t>Le contrat OpenAPI 3.0.3 est importé tel quel dans le Publisher. Il distingue les erreurs du backend (format Error) et celles de la passerelle WSO2 (codes à 6 chiffres). Les codes WSO2 viennent de la documentation officielle des erreurs.</a:t>
             </a:r>
-            <a:endParaRPr lang="en-US" dirty="0"/>
           </a:p>
         </p:txBody>
       </p:sp>
@@ -1351,7 +1119,6 @@
               <a:rPr lang="en-US" dirty="0"/>
               <a:t>Côté Admin Portal, on crée le plan Plan10ParMinute. Côté Developer Portal, l'application AppPortailSante génère ses clés, souscrit à l'API avec ce plan et obtient un jeton. Une seconde application, AppNonAbonnee, sert à démontrer le refus 403.</a:t>
             </a:r>
-            <a:endParaRPr lang="en-US" dirty="0"/>
           </a:p>
         </p:txBody>
       </p:sp>
@@ -1439,7 +1206,6 @@
               <a:rPr lang="en-US" dirty="0"/>
               <a:t>Démontrer chaque transition avec wso2ctl.py ou dans le Publisher, menu Lifecycle. Le blocage est réversible (Re-Publish). La publication de la v2 déprécie automatiquement la v1 grâce à l'option « Deprecate old versions ». Le retrait (Retire) est définitif.</a:t>
             </a:r>
-            <a:endParaRPr lang="en-US" dirty="0"/>
           </a:p>
         </p:txBody>
       </p:sp>
@@ -1527,7 +1293,6 @@
               <a:rPr lang="en-US" dirty="0"/>
               <a:t>C'est la consigne 7. Les deux cas renvoient une erreur au client, mais pour des raisons différentes. Blocage : décision dans WSO2, état BLOCKED, backend en marche, code 700700. Panne : WSO2 reste PUBLISHED, la passerelle tente le backend et échoue, code 101503. Le script e2e.py enregistre les deux réponses.</a:t>
             </a:r>
-            <a:endParaRPr lang="en-US" dirty="0"/>
           </a:p>
         </p:txBody>
       </p:sp>
@@ -1615,7 +1380,6 @@
               <a:rPr lang="en-US" dirty="0"/>
               <a:t>Create New Version copie la v1 en 2.0.0. On importe v2.yaml, on route vers /v2 du backend, on publie en cochant la dépréciation des anciennes versions. Les clients v1 continuent de fonctionner : la v2 garde tous les champs de la v1 et en ajoute. Un test vérifie cette compatibilité.</a:t>
             </a:r>
-            <a:endParaRPr lang="en-US" dirty="0"/>
           </a:p>
         </p:txBody>
       </p:sp>
@@ -1693,6 +1457,7 @@
         <a:solidFill>
           <a:schemeClr val="tx2"/>
         </a:solidFill>
+        <a:effectLst/>
       </p:bgPr>
     </p:bg>
     <p:spTree>
@@ -1712,9 +1477,11 @@
       <p:sp>
         <p:nvSpPr>
           <p:cNvPr id="2" name="Text 0"/>
-          <p:cNvSpPr/>
+          <p:cNvSpPr>
+            <a:spLocks noGrp="1"/>
+          </p:cNvSpPr>
           <p:nvPr>
-            <p:ph idx="100" type="title" hasCustomPrompt="1"/>
+            <p:ph type="title" idx="100" hasCustomPrompt="1"/>
           </p:nvPr>
         </p:nvSpPr>
         <p:spPr>
@@ -1731,7 +1498,7 @@
         <p:txBody>
           <a:bodyPr wrap="square" rtlCol="0"/>
           <a:lstStyle>
-            <a:lvl1pPr indent="0" marL="0">
+            <a:lvl1pPr marL="0" indent="0">
               <a:buNone/>
               <a:defRPr lang="en-US" sz="4000" b="1" dirty="0">
                 <a:solidFill>
@@ -1741,7 +1508,7 @@
             </a:lvl1pPr>
           </a:lstStyle>
           <a:p>
-            <a:pPr indent="0" marL="0">
+            <a:pPr marL="0" indent="0">
               <a:buNone/>
             </a:pPr>
             <a:endParaRPr lang="en-US" sz="4000" dirty="0"/>
@@ -1751,9 +1518,11 @@
       <p:sp>
         <p:nvSpPr>
           <p:cNvPr id="3" name="Text 0"/>
-          <p:cNvSpPr/>
+          <p:cNvSpPr>
+            <a:spLocks noGrp="1"/>
+          </p:cNvSpPr>
           <p:nvPr>
-            <p:ph idx="101" type="body" hasCustomPrompt="1"/>
+            <p:ph type="body" idx="101" hasCustomPrompt="1"/>
           </p:nvPr>
         </p:nvSpPr>
         <p:spPr>
@@ -1770,7 +1539,7 @@
         <p:txBody>
           <a:bodyPr wrap="square" rtlCol="0"/>
           <a:lstStyle>
-            <a:lvl1pPr indent="0" marL="0">
+            <a:lvl1pPr marL="0" indent="0">
               <a:buNone/>
               <a:defRPr lang="en-US" sz="1800" dirty="0">
                 <a:solidFill>
@@ -1780,7 +1549,7 @@
             </a:lvl1pPr>
           </a:lstStyle>
           <a:p>
-            <a:pPr indent="0" marL="0">
+            <a:pPr marL="0" indent="0">
               <a:buNone/>
             </a:pPr>
             <a:endParaRPr lang="en-US" sz="1800" dirty="0"/>
@@ -1803,6 +1572,7 @@
         <a:solidFill>
           <a:schemeClr val="bg1"/>
         </a:solidFill>
+        <a:effectLst/>
       </p:bgPr>
     </p:bg>
     <p:spTree>
@@ -1822,9 +1592,11 @@
       <p:sp>
         <p:nvSpPr>
           <p:cNvPr id="2" name="Text 0"/>
-          <p:cNvSpPr/>
+          <p:cNvSpPr>
+            <a:spLocks noGrp="1"/>
+          </p:cNvSpPr>
           <p:nvPr>
-            <p:ph idx="100" type="title" hasCustomPrompt="1"/>
+            <p:ph type="title" idx="100" hasCustomPrompt="1"/>
           </p:nvPr>
         </p:nvSpPr>
         <p:spPr>
@@ -1841,7 +1613,7 @@
         <p:txBody>
           <a:bodyPr wrap="square" rtlCol="0"/>
           <a:lstStyle>
-            <a:lvl1pPr indent="0" marL="0">
+            <a:lvl1pPr marL="0" indent="0">
               <a:buNone/>
               <a:defRPr lang="en-US" sz="3200" b="1" dirty="0">
                 <a:solidFill>
@@ -1851,7 +1623,7 @@
             </a:lvl1pPr>
           </a:lstStyle>
           <a:p>
-            <a:pPr indent="0" marL="0">
+            <a:pPr marL="0" indent="0">
               <a:buNone/>
             </a:pPr>
             <a:endParaRPr lang="en-US" sz="3200" dirty="0"/>
@@ -1879,7 +1651,7 @@
           <a:bodyPr wrap="square" lIns="0" tIns="0" rIns="0" bIns="0" rtlCol="0" anchor="ctr"/>
           <a:lstStyle/>
           <a:p>
-            <a:pPr indent="0" marL="0">
+            <a:pPr marL="0" indent="0">
               <a:buNone/>
             </a:pPr>
             <a:r>
@@ -1914,7 +1686,7 @@
           </a:prstGeom>
           <a:extLst>
             <a:ext uri="{C572A759-6A51-4108-AA02-DFA0A04FC94B}">
-              <ma14:wrappingTextBoxFlag xmlns:ma14="http://schemas.microsoft.com/office/mac/drawingml/2011/main" val="0"/>
+              <ma14:wrappingTextBoxFlag xmlns:ma14="http://schemas.microsoft.com/office/mac/drawingml/2011/main" xmlns="" val="0"/>
             </a:ext>
           </a:extLst>
         </p:spPr>
@@ -1932,8 +1704,8 @@
           <a:p>
             <a:pPr algn="r"/>
             <a:fld id="{F7021451-1387-4CA6-816F-3879F97B5CBC}" type="slidenum">
-              <a:rPr b="0" lang="en-US"/>
-              <a:t>1003</a:t>
+              <a:rPr lang="en-US" b="0"/>
+              <a:t>‹N°›</a:t>
             </a:fld>
             <a:endParaRPr lang="en-US"/>
           </a:p>
@@ -1955,6 +1727,7 @@
         <a:solidFill>
           <a:schemeClr val="tx2"/>
         </a:solidFill>
+        <a:effectLst/>
       </p:bgPr>
     </p:bg>
     <p:spTree>
@@ -1974,9 +1747,11 @@
       <p:sp>
         <p:nvSpPr>
           <p:cNvPr id="2" name="Text 0"/>
-          <p:cNvSpPr/>
+          <p:cNvSpPr>
+            <a:spLocks noGrp="1"/>
+          </p:cNvSpPr>
           <p:nvPr>
-            <p:ph idx="100" type="title" hasCustomPrompt="1"/>
+            <p:ph type="title" idx="100" hasCustomPrompt="1"/>
           </p:nvPr>
         </p:nvSpPr>
         <p:spPr>
@@ -1993,7 +1768,7 @@
         <p:txBody>
           <a:bodyPr wrap="square" rtlCol="0"/>
           <a:lstStyle>
-            <a:lvl1pPr indent="0" marL="0">
+            <a:lvl1pPr marL="0" indent="0">
               <a:buNone/>
               <a:defRPr lang="en-US" sz="3400" b="1" dirty="0">
                 <a:solidFill>
@@ -2003,7 +1778,7 @@
             </a:lvl1pPr>
           </a:lstStyle>
           <a:p>
-            <a:pPr indent="0" marL="0">
+            <a:pPr marL="0" indent="0">
               <a:buNone/>
             </a:pPr>
             <a:endParaRPr lang="en-US" sz="3400" dirty="0"/>
@@ -2021,6 +1796,11 @@
 <file path=ppt/slideMasters/slideMaster1.xml><?xml version="1.0" encoding="utf-8"?>
 <p:sldMaster xmlns:a="http://schemas.openxmlformats.org/drawingml/2006/main" xmlns:r="http://schemas.openxmlformats.org/officeDocument/2006/relationships" xmlns:p="http://schemas.openxmlformats.org/presentationml/2006/main">
   <p:cSld>
+    <p:bg>
+      <p:bgRef idx="1001">
+        <a:schemeClr val="bg1"/>
+      </p:bgRef>
+    </p:bg>
     <p:spTree>
       <p:nvGrpSpPr>
         <p:cNvPr id="1" name=""/>
@@ -2055,7 +1835,7 @@
           </a:prstGeom>
           <a:extLst>
             <a:ext uri="{C572A759-6A51-4108-AA02-DFA0A04FC94B}">
-              <ma14:wrappingTextBoxFlag xmlns:ma14="http://schemas.microsoft.com/office/mac/drawingml/2011/main" val="0"/>
+              <ma14:wrappingTextBoxFlag xmlns:ma14="http://schemas.microsoft.com/office/mac/drawingml/2011/main" xmlns="" val="0"/>
             </a:ext>
           </a:extLst>
         </p:spPr>
@@ -2073,8 +1853,8 @@
           <a:p>
             <a:pPr algn="r"/>
             <a:fld id="{F7021451-1387-4CA6-816F-3879F97B5CBC}" type="slidenum">
-              <a:rPr b="0" lang="en-US"/>
-              <a:t>null</a:t>
+              <a:rPr lang="en-US" b="0"/>
+              <a:t>‹N°›</a:t>
             </a:fld>
             <a:endParaRPr lang="en-US"/>
           </a:p>
@@ -2363,9 +2143,11 @@
       <p:sp>
         <p:nvSpPr>
           <p:cNvPr id="2" name="Text 0"/>
-          <p:cNvSpPr/>
+          <p:cNvSpPr>
+            <a:spLocks noGrp="1"/>
+          </p:cNvSpPr>
           <p:nvPr>
-            <p:ph idx="100" type="title" hasCustomPrompt="1"/>
+            <p:ph type="title" idx="100" hasCustomPrompt="1"/>
           </p:nvPr>
         </p:nvSpPr>
         <p:spPr>
@@ -2383,7 +2165,7 @@
           <a:bodyPr wrap="square" lIns="0" tIns="0" rIns="0" bIns="0" rtlCol="0" anchor="b"/>
           <a:lstStyle/>
           <a:p>
-            <a:pPr indent="0" marL="0">
+            <a:pPr marL="0" indent="0">
               <a:buNone/>
             </a:pPr>
             <a:r>
@@ -2401,9 +2183,11 @@
       <p:sp>
         <p:nvSpPr>
           <p:cNvPr id="3" name="Text 0"/>
-          <p:cNvSpPr/>
+          <p:cNvSpPr>
+            <a:spLocks noGrp="1"/>
+          </p:cNvSpPr>
           <p:nvPr>
-            <p:ph idx="101" type="body" hasCustomPrompt="1"/>
+            <p:ph type="body" idx="101" hasCustomPrompt="1"/>
           </p:nvPr>
         </p:nvSpPr>
         <p:spPr>
@@ -2421,7 +2205,7 @@
           <a:bodyPr wrap="square" lIns="0" tIns="0" rIns="0" bIns="0" rtlCol="0" anchor="t"/>
           <a:lstStyle/>
           <a:p>
-            <a:pPr indent="0" marL="0">
+            <a:pPr marL="0" indent="0">
               <a:buNone/>
             </a:pPr>
             <a:r>
@@ -2435,7 +2219,7 @@
             <a:endParaRPr lang="en-US" sz="1800" dirty="0"/>
           </a:p>
           <a:p>
-            <a:pPr indent="0" marL="0">
+            <a:pPr marL="0" indent="0">
               <a:buNone/>
             </a:pPr>
             <a:r>
@@ -2444,7 +2228,7 @@
                   <a:schemeClr val="bg1"/>
                 </a:solidFill>
               </a:rPr>
-              <a:t>LOMPO Ephraim · OUOBA Arnaud · NIKIEMA Abdoul Fatahou · TIROUDA Leila · ROUAMBA Frank</a:t>
+              <a:t>LOMPO Ephraim · OUOBA Arnaud · NIKIEMA Abdoul Fatahou · TIROUDA Leila · ROUAMBA Franck</a:t>
             </a:r>
             <a:endParaRPr lang="en-US" sz="1800" dirty="0"/>
           </a:p>
@@ -2478,9 +2262,11 @@
       <p:sp>
         <p:nvSpPr>
           <p:cNvPr id="2" name="Text 0"/>
-          <p:cNvSpPr/>
+          <p:cNvSpPr>
+            <a:spLocks noGrp="1"/>
+          </p:cNvSpPr>
           <p:nvPr>
-            <p:ph idx="100" type="title" hasCustomPrompt="1"/>
+            <p:ph type="title" idx="100" hasCustomPrompt="1"/>
           </p:nvPr>
         </p:nvSpPr>
         <p:spPr>
@@ -2498,7 +2284,7 @@
           <a:bodyPr wrap="square" lIns="0" tIns="0" rIns="0" bIns="0" rtlCol="0" anchor="ctr"/>
           <a:lstStyle/>
           <a:p>
-            <a:pPr indent="0" marL="0">
+            <a:pPr marL="0" indent="0">
               <a:buNone/>
             </a:pPr>
             <a:r>
@@ -2541,7 +2327,10 @@
         </p:spPr>
         <p:txBody>
           <a:bodyPr/>
-          <a:p/>
+          <a:lstStyle/>
+          <a:p>
+            <a:endParaRPr/>
+          </a:p>
         </p:txBody>
       </p:sp>
       <p:sp>
@@ -2565,7 +2354,7 @@
           <a:bodyPr wrap="square" lIns="0" tIns="0" rIns="0" bIns="0" rtlCol="0" anchor="t"/>
           <a:lstStyle/>
           <a:p>
-            <a:pPr indent="0" marL="0">
+            <a:pPr marL="0" indent="0">
               <a:buNone/>
             </a:pPr>
             <a:r>
@@ -2601,7 +2390,7 @@
           <a:bodyPr wrap="square" lIns="0" tIns="0" rIns="0" bIns="0" rtlCol="0" anchor="t"/>
           <a:lstStyle/>
           <a:p>
-            <a:pPr algn="r" indent="0" marL="0">
+            <a:pPr marL="0" indent="0" algn="r">
               <a:buNone/>
             </a:pPr>
             <a:r>
@@ -2637,7 +2426,7 @@
           <a:bodyPr wrap="square" lIns="0" tIns="0" rIns="0" bIns="0" rtlCol="0" anchor="t"/>
           <a:lstStyle/>
           <a:p>
-            <a:pPr indent="0" marL="0">
+            <a:pPr marL="0" indent="0">
               <a:buNone/>
             </a:pPr>
             <a:r>
@@ -2680,7 +2469,10 @@
         </p:spPr>
         <p:txBody>
           <a:bodyPr/>
-          <a:p/>
+          <a:lstStyle/>
+          <a:p>
+            <a:endParaRPr/>
+          </a:p>
         </p:txBody>
       </p:sp>
       <p:sp>
@@ -2704,7 +2496,7 @@
           <a:bodyPr wrap="square" lIns="0" tIns="0" rIns="0" bIns="0" rtlCol="0" anchor="t"/>
           <a:lstStyle/>
           <a:p>
-            <a:pPr indent="0" marL="0">
+            <a:pPr marL="0" indent="0">
               <a:buNone/>
             </a:pPr>
             <a:r>
@@ -2740,7 +2532,7 @@
           <a:bodyPr wrap="square" lIns="0" tIns="0" rIns="0" bIns="0" rtlCol="0" anchor="t"/>
           <a:lstStyle/>
           <a:p>
-            <a:pPr algn="r" indent="0" marL="0">
+            <a:pPr marL="0" indent="0" algn="r">
               <a:buNone/>
             </a:pPr>
             <a:r>
@@ -2776,7 +2568,7 @@
           <a:bodyPr wrap="square" lIns="0" tIns="0" rIns="0" bIns="0" rtlCol="0" anchor="t"/>
           <a:lstStyle/>
           <a:p>
-            <a:pPr indent="0" marL="0">
+            <a:pPr marL="0" indent="0">
               <a:buNone/>
             </a:pPr>
             <a:r>
@@ -2819,7 +2611,10 @@
         </p:spPr>
         <p:txBody>
           <a:bodyPr/>
-          <a:p/>
+          <a:lstStyle/>
+          <a:p>
+            <a:endParaRPr/>
+          </a:p>
         </p:txBody>
       </p:sp>
       <p:sp>
@@ -2843,7 +2638,7 @@
           <a:bodyPr wrap="square" lIns="0" tIns="0" rIns="0" bIns="0" rtlCol="0" anchor="t"/>
           <a:lstStyle/>
           <a:p>
-            <a:pPr indent="0" marL="0">
+            <a:pPr marL="0" indent="0">
               <a:buNone/>
             </a:pPr>
             <a:r>
@@ -2879,7 +2674,7 @@
           <a:bodyPr wrap="square" lIns="0" tIns="0" rIns="0" bIns="0" rtlCol="0" anchor="t"/>
           <a:lstStyle/>
           <a:p>
-            <a:pPr algn="r" indent="0" marL="0">
+            <a:pPr marL="0" indent="0" algn="r">
               <a:buNone/>
             </a:pPr>
             <a:r>
@@ -2915,7 +2710,7 @@
           <a:bodyPr wrap="square" lIns="0" tIns="0" rIns="0" bIns="0" rtlCol="0" anchor="t"/>
           <a:lstStyle/>
           <a:p>
-            <a:pPr indent="0" marL="0">
+            <a:pPr marL="0" indent="0">
               <a:buNone/>
             </a:pPr>
             <a:r>
@@ -2958,7 +2753,10 @@
         </p:spPr>
         <p:txBody>
           <a:bodyPr/>
-          <a:p/>
+          <a:lstStyle/>
+          <a:p>
+            <a:endParaRPr/>
+          </a:p>
         </p:txBody>
       </p:sp>
       <p:sp>
@@ -2982,7 +2780,7 @@
           <a:bodyPr wrap="square" lIns="0" tIns="0" rIns="0" bIns="0" rtlCol="0" anchor="t"/>
           <a:lstStyle/>
           <a:p>
-            <a:pPr indent="0" marL="0">
+            <a:pPr marL="0" indent="0">
               <a:buNone/>
             </a:pPr>
             <a:r>
@@ -3018,7 +2816,7 @@
           <a:bodyPr wrap="square" lIns="0" tIns="0" rIns="0" bIns="0" rtlCol="0" anchor="t"/>
           <a:lstStyle/>
           <a:p>
-            <a:pPr algn="r" indent="0" marL="0">
+            <a:pPr marL="0" indent="0" algn="r">
               <a:buNone/>
             </a:pPr>
             <a:r>
@@ -3054,7 +2852,7 @@
           <a:bodyPr wrap="square" lIns="0" tIns="0" rIns="0" bIns="0" rtlCol="0" anchor="t"/>
           <a:lstStyle/>
           <a:p>
-            <a:pPr indent="0" marL="0">
+            <a:pPr marL="0" indent="0">
               <a:buNone/>
             </a:pPr>
             <a:r>
@@ -3097,7 +2895,10 @@
         </p:spPr>
         <p:txBody>
           <a:bodyPr/>
-          <a:p/>
+          <a:lstStyle/>
+          <a:p>
+            <a:endParaRPr/>
+          </a:p>
         </p:txBody>
       </p:sp>
       <p:sp>
@@ -3121,7 +2922,7 @@
           <a:bodyPr wrap="square" lIns="0" tIns="0" rIns="0" bIns="0" rtlCol="0" anchor="t"/>
           <a:lstStyle/>
           <a:p>
-            <a:pPr indent="0" marL="0">
+            <a:pPr marL="0" indent="0">
               <a:buNone/>
             </a:pPr>
             <a:r>
@@ -3157,7 +2958,7 @@
           <a:bodyPr wrap="square" lIns="0" tIns="0" rIns="0" bIns="0" rtlCol="0" anchor="t"/>
           <a:lstStyle/>
           <a:p>
-            <a:pPr algn="r" indent="0" marL="0">
+            <a:pPr marL="0" indent="0" algn="r">
               <a:buNone/>
             </a:pPr>
             <a:r>
@@ -3193,7 +2994,7 @@
           <a:bodyPr wrap="square" lIns="0" tIns="0" rIns="0" bIns="0" rtlCol="0" anchor="t"/>
           <a:lstStyle/>
           <a:p>
-            <a:pPr indent="0" marL="0">
+            <a:pPr marL="0" indent="0">
               <a:buNone/>
             </a:pPr>
             <a:r>
@@ -3236,7 +3037,10 @@
         </p:spPr>
         <p:txBody>
           <a:bodyPr/>
-          <a:p/>
+          <a:lstStyle/>
+          <a:p>
+            <a:endParaRPr/>
+          </a:p>
         </p:txBody>
       </p:sp>
       <p:sp>
@@ -3260,7 +3064,7 @@
           <a:bodyPr wrap="square" lIns="0" tIns="0" rIns="0" bIns="0" rtlCol="0" anchor="t"/>
           <a:lstStyle/>
           <a:p>
-            <a:pPr indent="0" marL="0">
+            <a:pPr marL="0" indent="0">
               <a:buNone/>
             </a:pPr>
             <a:r>
@@ -3296,7 +3100,7 @@
           <a:bodyPr wrap="square" lIns="0" tIns="0" rIns="0" bIns="0" rtlCol="0" anchor="t"/>
           <a:lstStyle/>
           <a:p>
-            <a:pPr algn="r" indent="0" marL="0">
+            <a:pPr marL="0" indent="0" algn="r">
               <a:buNone/>
             </a:pPr>
             <a:r>
@@ -3332,7 +3136,7 @@
           <a:bodyPr wrap="square" lIns="0" tIns="0" rIns="0" bIns="0" rtlCol="0" anchor="t"/>
           <a:lstStyle/>
           <a:p>
-            <a:pPr indent="0" marL="0">
+            <a:pPr marL="0" indent="0">
               <a:buNone/>
             </a:pPr>
             <a:r>
@@ -3375,7 +3179,10 @@
         </p:spPr>
         <p:txBody>
           <a:bodyPr/>
-          <a:p/>
+          <a:lstStyle/>
+          <a:p>
+            <a:endParaRPr/>
+          </a:p>
         </p:txBody>
       </p:sp>
       <p:sp>
@@ -3399,7 +3206,7 @@
           <a:bodyPr wrap="square" lIns="0" tIns="0" rIns="0" bIns="0" rtlCol="0" anchor="t"/>
           <a:lstStyle/>
           <a:p>
-            <a:pPr indent="0" marL="0">
+            <a:pPr marL="0" indent="0">
               <a:buNone/>
             </a:pPr>
             <a:r>
@@ -3435,7 +3242,7 @@
           <a:bodyPr wrap="square" lIns="0" tIns="0" rIns="0" bIns="0" rtlCol="0" anchor="t"/>
           <a:lstStyle/>
           <a:p>
-            <a:pPr algn="r" indent="0" marL="0">
+            <a:pPr marL="0" indent="0" algn="r">
               <a:buNone/>
             </a:pPr>
             <a:r>
@@ -3471,7 +3278,7 @@
           <a:bodyPr wrap="square" lIns="0" tIns="0" rIns="0" bIns="0" rtlCol="0" anchor="t"/>
           <a:lstStyle/>
           <a:p>
-            <a:pPr indent="0" marL="0">
+            <a:pPr marL="0" indent="0">
               <a:buNone/>
             </a:pPr>
             <a:r>
@@ -3514,7 +3321,10 @@
         </p:spPr>
         <p:txBody>
           <a:bodyPr/>
-          <a:p/>
+          <a:lstStyle/>
+          <a:p>
+            <a:endParaRPr/>
+          </a:p>
         </p:txBody>
       </p:sp>
       <p:sp>
@@ -3538,7 +3348,7 @@
           <a:bodyPr wrap="square" lIns="0" tIns="0" rIns="0" bIns="0" rtlCol="0" anchor="t"/>
           <a:lstStyle/>
           <a:p>
-            <a:pPr indent="0" marL="0">
+            <a:pPr marL="0" indent="0">
               <a:buNone/>
             </a:pPr>
             <a:r>
@@ -3574,7 +3384,7 @@
           <a:bodyPr wrap="square" lIns="0" tIns="0" rIns="0" bIns="0" rtlCol="0" anchor="t"/>
           <a:lstStyle/>
           <a:p>
-            <a:pPr algn="r" indent="0" marL="0">
+            <a:pPr marL="0" indent="0" algn="r">
               <a:buNone/>
             </a:pPr>
             <a:r>
@@ -3610,7 +3420,7 @@
           <a:bodyPr wrap="square" lIns="0" tIns="0" rIns="0" bIns="0" rtlCol="0" anchor="t"/>
           <a:lstStyle/>
           <a:p>
-            <a:pPr indent="0" marL="0">
+            <a:pPr marL="0" indent="0">
               <a:buNone/>
             </a:pPr>
             <a:r>
@@ -3653,7 +3463,10 @@
         </p:spPr>
         <p:txBody>
           <a:bodyPr/>
-          <a:p/>
+          <a:lstStyle/>
+          <a:p>
+            <a:endParaRPr/>
+          </a:p>
         </p:txBody>
       </p:sp>
       <p:sp>
@@ -3677,7 +3490,7 @@
           <a:bodyPr wrap="square" lIns="0" tIns="0" rIns="0" bIns="0" rtlCol="0" anchor="t"/>
           <a:lstStyle/>
           <a:p>
-            <a:pPr indent="0" marL="0">
+            <a:pPr marL="0" indent="0">
               <a:buNone/>
             </a:pPr>
             <a:r>
@@ -3713,7 +3526,7 @@
           <a:bodyPr wrap="square" lIns="0" tIns="0" rIns="0" bIns="0" rtlCol="0" anchor="t"/>
           <a:lstStyle/>
           <a:p>
-            <a:pPr algn="r" indent="0" marL="0">
+            <a:pPr marL="0" indent="0" algn="r">
               <a:buNone/>
             </a:pPr>
             <a:r>
@@ -3749,7 +3562,7 @@
           <a:bodyPr wrap="square" lIns="0" tIns="0" rIns="0" bIns="0" rtlCol="0" anchor="t"/>
           <a:lstStyle/>
           <a:p>
-            <a:pPr indent="0" marL="0">
+            <a:pPr marL="0" indent="0">
               <a:buNone/>
             </a:pPr>
             <a:r>
@@ -3792,7 +3605,10 @@
         </p:spPr>
         <p:txBody>
           <a:bodyPr/>
-          <a:p/>
+          <a:lstStyle/>
+          <a:p>
+            <a:endParaRPr/>
+          </a:p>
         </p:txBody>
       </p:sp>
       <p:sp>
@@ -3816,7 +3632,7 @@
           <a:bodyPr wrap="square" lIns="0" tIns="0" rIns="0" bIns="0" rtlCol="0" anchor="t"/>
           <a:lstStyle/>
           <a:p>
-            <a:pPr indent="0" marL="0">
+            <a:pPr marL="0" indent="0">
               <a:buNone/>
             </a:pPr>
             <a:r>
@@ -3852,7 +3668,7 @@
           <a:bodyPr wrap="square" lIns="0" tIns="0" rIns="0" bIns="0" rtlCol="0" anchor="t"/>
           <a:lstStyle/>
           <a:p>
-            <a:pPr algn="r" indent="0" marL="0">
+            <a:pPr marL="0" indent="0" algn="r">
               <a:buNone/>
             </a:pPr>
             <a:r>
@@ -3888,7 +3704,7 @@
           <a:bodyPr wrap="square" lIns="0" tIns="0" rIns="0" bIns="0" rtlCol="0" anchor="t"/>
           <a:lstStyle/>
           <a:p>
-            <a:pPr indent="0" marL="0">
+            <a:pPr marL="0" indent="0">
               <a:buNone/>
             </a:pPr>
             <a:r>
@@ -3931,7 +3747,10 @@
         </p:spPr>
         <p:txBody>
           <a:bodyPr/>
-          <a:p/>
+          <a:lstStyle/>
+          <a:p>
+            <a:endParaRPr/>
+          </a:p>
         </p:txBody>
       </p:sp>
       <p:sp>
@@ -3955,7 +3774,7 @@
           <a:bodyPr wrap="square" lIns="0" tIns="0" rIns="0" bIns="0" rtlCol="0" anchor="t"/>
           <a:lstStyle/>
           <a:p>
-            <a:pPr indent="0" marL="0">
+            <a:pPr marL="0" indent="0">
               <a:buNone/>
             </a:pPr>
             <a:r>
@@ -3991,7 +3810,7 @@
           <a:bodyPr wrap="square" lIns="0" tIns="0" rIns="0" bIns="0" rtlCol="0" anchor="t"/>
           <a:lstStyle/>
           <a:p>
-            <a:pPr algn="r" indent="0" marL="0">
+            <a:pPr marL="0" indent="0" algn="r">
               <a:buNone/>
             </a:pPr>
             <a:r>
@@ -4027,7 +3846,7 @@
           <a:bodyPr wrap="square" lIns="0" tIns="0" rIns="0" bIns="0" rtlCol="0" anchor="t"/>
           <a:lstStyle/>
           <a:p>
-            <a:pPr indent="0" marL="0">
+            <a:pPr marL="0" indent="0">
               <a:buNone/>
             </a:pPr>
             <a:r>
@@ -4070,7 +3889,10 @@
         </p:spPr>
         <p:txBody>
           <a:bodyPr/>
-          <a:p/>
+          <a:lstStyle/>
+          <a:p>
+            <a:endParaRPr/>
+          </a:p>
         </p:txBody>
       </p:sp>
       <p:sp>
@@ -4094,7 +3916,7 @@
           <a:bodyPr wrap="square" lIns="0" tIns="0" rIns="0" bIns="0" rtlCol="0" anchor="t"/>
           <a:lstStyle/>
           <a:p>
-            <a:pPr indent="0" marL="0">
+            <a:pPr marL="0" indent="0">
               <a:buNone/>
             </a:pPr>
             <a:r>
@@ -4130,7 +3952,7 @@
           <a:bodyPr wrap="square" lIns="0" tIns="0" rIns="0" bIns="0" rtlCol="0" anchor="t"/>
           <a:lstStyle/>
           <a:p>
-            <a:pPr algn="r" indent="0" marL="0">
+            <a:pPr marL="0" indent="0" algn="r">
               <a:buNone/>
             </a:pPr>
             <a:r>
@@ -4166,7 +3988,7 @@
           <a:bodyPr wrap="square" lIns="0" tIns="0" rIns="0" bIns="0" rtlCol="0" anchor="t"/>
           <a:lstStyle/>
           <a:p>
-            <a:pPr indent="0" marL="0">
+            <a:pPr marL="0" indent="0">
               <a:buNone/>
             </a:pPr>
             <a:r>
@@ -4209,7 +4031,10 @@
         </p:spPr>
         <p:txBody>
           <a:bodyPr/>
-          <a:p/>
+          <a:lstStyle/>
+          <a:p>
+            <a:endParaRPr/>
+          </a:p>
         </p:txBody>
       </p:sp>
       <p:sp>
@@ -4233,7 +4058,7 @@
           <a:bodyPr wrap="square" lIns="0" tIns="0" rIns="0" bIns="0" rtlCol="0" anchor="t"/>
           <a:lstStyle/>
           <a:p>
-            <a:pPr indent="0" marL="0">
+            <a:pPr marL="0" indent="0">
               <a:buNone/>
             </a:pPr>
             <a:r>
@@ -4269,7 +4094,7 @@
           <a:bodyPr wrap="square" lIns="0" tIns="0" rIns="0" bIns="0" rtlCol="0" anchor="t"/>
           <a:lstStyle/>
           <a:p>
-            <a:pPr algn="r" indent="0" marL="0">
+            <a:pPr marL="0" indent="0" algn="r">
               <a:buNone/>
             </a:pPr>
             <a:r>
@@ -4305,7 +4130,7 @@
           <a:bodyPr wrap="square" lIns="0" tIns="0" rIns="0" bIns="0" rtlCol="0" anchor="t"/>
           <a:lstStyle/>
           <a:p>
-            <a:pPr indent="0" marL="0">
+            <a:pPr marL="0" indent="0">
               <a:buNone/>
             </a:pPr>
             <a:r>
@@ -4348,7 +4173,10 @@
         </p:spPr>
         <p:txBody>
           <a:bodyPr/>
-          <a:p/>
+          <a:lstStyle/>
+          <a:p>
+            <a:endParaRPr/>
+          </a:p>
         </p:txBody>
       </p:sp>
       <p:sp>
@@ -4372,7 +4200,7 @@
           <a:bodyPr wrap="square" lIns="0" tIns="0" rIns="0" bIns="0" rtlCol="0" anchor="t"/>
           <a:lstStyle/>
           <a:p>
-            <a:pPr indent="0" marL="0">
+            <a:pPr marL="0" indent="0">
               <a:spcAft>
                 <a:spcPts val="400"/>
               </a:spcAft>
@@ -4389,7 +4217,7 @@
             <a:endParaRPr lang="en-US" sz="1400" dirty="0"/>
           </a:p>
           <a:p>
-            <a:pPr indent="0" marL="0">
+            <a:pPr marL="0" indent="0">
               <a:spcAft>
                 <a:spcPts val="400"/>
               </a:spcAft>
@@ -4406,7 +4234,7 @@
             <a:endParaRPr lang="en-US" sz="1400" dirty="0"/>
           </a:p>
           <a:p>
-            <a:pPr indent="0" marL="0">
+            <a:pPr marL="0" indent="0">
               <a:spcAft>
                 <a:spcPts val="400"/>
               </a:spcAft>
@@ -4423,7 +4251,7 @@
             <a:endParaRPr lang="en-US" sz="1400" dirty="0"/>
           </a:p>
           <a:p>
-            <a:pPr indent="0" marL="0">
+            <a:pPr marL="0" indent="0">
               <a:spcAft>
                 <a:spcPts val="400"/>
               </a:spcAft>
@@ -4440,7 +4268,7 @@
             <a:endParaRPr lang="en-US" sz="1400" dirty="0"/>
           </a:p>
           <a:p>
-            <a:pPr indent="0" marL="0">
+            <a:pPr marL="0" indent="0">
               <a:spcAft>
                 <a:spcPts val="400"/>
               </a:spcAft>
@@ -4457,7 +4285,7 @@
             <a:endParaRPr lang="en-US" sz="1400" dirty="0"/>
           </a:p>
           <a:p>
-            <a:pPr indent="0" marL="0">
+            <a:pPr marL="0" indent="0">
               <a:spcAft>
                 <a:spcPts val="400"/>
               </a:spcAft>
@@ -4474,7 +4302,7 @@
             <a:endParaRPr lang="en-US" sz="1400" dirty="0"/>
           </a:p>
           <a:p>
-            <a:pPr indent="0" marL="0">
+            <a:pPr marL="0" indent="0">
               <a:spcAft>
                 <a:spcPts val="400"/>
               </a:spcAft>
@@ -4491,7 +4319,7 @@
             <a:endParaRPr lang="en-US" sz="1400" dirty="0"/>
           </a:p>
           <a:p>
-            <a:pPr indent="0" marL="0">
+            <a:pPr marL="0" indent="0">
               <a:spcAft>
                 <a:spcPts val="400"/>
               </a:spcAft>
@@ -4508,7 +4336,7 @@
             <a:endParaRPr lang="en-US" sz="1400" dirty="0"/>
           </a:p>
           <a:p>
-            <a:pPr indent="0" marL="0">
+            <a:pPr marL="0" indent="0">
               <a:spcAft>
                 <a:spcPts val="400"/>
               </a:spcAft>
@@ -4525,14 +4353,14 @@
             <a:endParaRPr lang="en-US" sz="1400" dirty="0"/>
           </a:p>
           <a:p>
-            <a:pPr indent="0" marL="0">
+            <a:pPr marL="0" indent="0">
               <a:spcAft>
                 <a:spcPts val="400"/>
               </a:spcAft>
               <a:buNone/>
             </a:pPr>
             <a:r>
-              <a:rPr lang="en-US" sz="1200" dirty="0" i="1">
+              <a:rPr lang="en-US" sz="1200" i="1" dirty="0">
                 <a:solidFill>
                   <a:schemeClr val="bg1"/>
                 </a:solidFill>
@@ -4545,7 +4373,7 @@
       </p:sp>
       <p:sp>
         <p:nvSpPr>
-          <p:cNvPr id="25" name="Slide Number Placeholder 0"/>
+          <p:cNvPr id="3" name="Slide Number Placeholder 0"/>
           <p:cNvSpPr>
             <a:spLocks noGrp="1"/>
           </p:cNvSpPr>
@@ -4563,7 +4391,7 @@
           </a:prstGeom>
           <a:extLst>
             <a:ext uri="{C572A759-6A51-4108-AA02-DFA0A04FC94B}">
-              <ma14:wrappingTextBoxFlag xmlns:ma14="http://schemas.microsoft.com/office/mac/drawingml/2011/main" val="0"/>
+              <ma14:wrappingTextBoxFlag xmlns:ma14="http://schemas.microsoft.com/office/mac/drawingml/2011/main" xmlns="" val="0"/>
             </a:ext>
           </a:extLst>
         </p:spPr>
@@ -4581,7 +4409,7 @@
           <a:p>
             <a:pPr algn="r"/>
             <a:fld id="{F7021451-1387-4CA6-816F-3879F97B5CBC}" type="slidenum">
-              <a:rPr b="0" lang="en-US"/>
+              <a:rPr lang="en-US" b="0"/>
               <a:t>10</a:t>
             </a:fld>
             <a:endParaRPr lang="en-US"/>
@@ -4597,7 +4425,7 @@
 </file>
 
 <file path=ppt/slides/slide11.xml><?xml version="1.0" encoding="utf-8"?>
-<p:sld xmlns:a="http://schemas.openxmlformats.org/drawingml/2006/main" xmlns:p="http://schemas.openxmlformats.org/presentationml/2006/main" xmlns:r="http://schemas.openxmlformats.org/officeDocument/2006/relationships">
+<p:sld xmlns:a="http://schemas.openxmlformats.org/drawingml/2006/main" xmlns:r="http://schemas.openxmlformats.org/officeDocument/2006/relationships" xmlns:p="http://schemas.openxmlformats.org/presentationml/2006/main">
   <p:cSld>
     <p:spTree>
       <p:nvGrpSpPr>
@@ -4605,13 +4433,22 @@
         <p:cNvGrpSpPr/>
         <p:nvPr/>
       </p:nvGrpSpPr>
-      <p:grpSpPr/>
+      <p:grpSpPr>
+        <a:xfrm>
+          <a:off x="0" y="0"/>
+          <a:ext cx="0" cy="0"/>
+          <a:chOff x="0" y="0"/>
+          <a:chExt cx="0" cy="0"/>
+        </a:xfrm>
+      </p:grpSpPr>
       <p:sp>
         <p:nvSpPr>
           <p:cNvPr id="2" name="Text 0"/>
-          <p:cNvSpPr/>
+          <p:cNvSpPr>
+            <a:spLocks noGrp="1"/>
+          </p:cNvSpPr>
           <p:nvPr>
-            <p:ph idx="100" type="title" hasCustomPrompt="1"/>
+            <p:ph type="title" idx="100" hasCustomPrompt="1"/>
           </p:nvPr>
         </p:nvSpPr>
         <p:spPr>
@@ -4629,7 +4466,7 @@
           <a:bodyPr wrap="square" lIns="0" tIns="0" rIns="0" bIns="0" rtlCol="0" anchor="ctr"/>
           <a:lstStyle/>
           <a:p>
-            <a:pPr indent="0" marL="0">
+            <a:pPr marL="0" indent="0">
               <a:buNone/>
             </a:pPr>
             <a:r>
@@ -4664,7 +4501,7 @@
           </a:prstGeom>
           <a:extLst>
             <a:ext uri="{C572A759-6A51-4108-AA02-DFA0A04FC94B}">
-              <ma14:wrappingTextBoxFlag xmlns:ma14="http://schemas.microsoft.com/office/mac/drawingml/2011/main" val="0"/>
+              <ma14:wrappingTextBoxFlag xmlns:ma14="http://schemas.microsoft.com/office/mac/drawingml/2011/main" xmlns="" val="0"/>
             </a:ext>
           </a:extLst>
         </p:spPr>
@@ -4682,8 +4519,8 @@
           <a:p>
             <a:pPr algn="r"/>
             <a:fld id="{F7021451-1387-4CA6-816F-3879F97B5CBC}" type="slidenum">
-              <a:rPr b="0" lang="en-US"/>
-              <a:t>10</a:t>
+              <a:rPr lang="en-US" b="0"/>
+              <a:t>11</a:t>
             </a:fld>
             <a:endParaRPr lang="en-US"/>
           </a:p>
@@ -4735,7 +4572,7 @@
           <a:noFill/>
         </p:spPr>
         <p:txBody>
-          <a:bodyPr wrap="square" lIns="0" rIns="0" tIns="0" bIns="0">
+          <a:bodyPr wrap="square" lIns="0" tIns="0" rIns="0" bIns="0">
             <a:spAutoFit/>
           </a:bodyPr>
           <a:lstStyle/>
@@ -4805,7 +4642,7 @@
           <a:noFill/>
         </p:spPr>
         <p:txBody>
-          <a:bodyPr wrap="square" lIns="0" rIns="0" tIns="0" bIns="0">
+          <a:bodyPr wrap="square" lIns="0" tIns="0" rIns="0" bIns="0">
             <a:spAutoFit/>
           </a:bodyPr>
           <a:lstStyle/>
@@ -4875,7 +4712,7 @@
           <a:noFill/>
         </p:spPr>
         <p:txBody>
-          <a:bodyPr wrap="square" lIns="0" rIns="0" tIns="0" bIns="0">
+          <a:bodyPr wrap="square" lIns="0" tIns="0" rIns="0" bIns="0">
             <a:spAutoFit/>
           </a:bodyPr>
           <a:lstStyle/>
@@ -4945,7 +4782,7 @@
           <a:noFill/>
         </p:spPr>
         <p:txBody>
-          <a:bodyPr wrap="square" lIns="0" rIns="0" tIns="0" bIns="0">
+          <a:bodyPr wrap="square" lIns="0" tIns="0" rIns="0" bIns="0">
             <a:spAutoFit/>
           </a:bodyPr>
           <a:lstStyle/>
@@ -5015,7 +4852,7 @@
           <a:noFill/>
         </p:spPr>
         <p:txBody>
-          <a:bodyPr wrap="square" lIns="0" rIns="0" tIns="0" bIns="0">
+          <a:bodyPr wrap="square" lIns="0" tIns="0" rIns="0" bIns="0">
             <a:spAutoFit/>
           </a:bodyPr>
           <a:lstStyle/>
@@ -5067,9 +4904,11 @@
       <p:sp>
         <p:nvSpPr>
           <p:cNvPr id="2" name="Text 0"/>
-          <p:cNvSpPr/>
+          <p:cNvSpPr>
+            <a:spLocks noGrp="1"/>
+          </p:cNvSpPr>
           <p:nvPr>
-            <p:ph idx="100" type="title" hasCustomPrompt="1"/>
+            <p:ph type="title" idx="100" hasCustomPrompt="1"/>
           </p:nvPr>
         </p:nvSpPr>
         <p:spPr>
@@ -5087,7 +4926,7 @@
           <a:bodyPr wrap="square" lIns="0" tIns="0" rIns="0" bIns="0" rtlCol="0" anchor="ctr"/>
           <a:lstStyle/>
           <a:p>
-            <a:pPr indent="0" marL="0">
+            <a:pPr marL="0" indent="0">
               <a:buNone/>
             </a:pPr>
             <a:r>
@@ -5128,7 +4967,10 @@
         </p:spPr>
         <p:txBody>
           <a:bodyPr/>
-          <a:p/>
+          <a:lstStyle/>
+          <a:p>
+            <a:endParaRPr/>
+          </a:p>
         </p:txBody>
       </p:sp>
       <p:sp>
@@ -5152,7 +4994,7 @@
           <a:bodyPr wrap="square" lIns="0" tIns="0" rIns="0" bIns="0" rtlCol="0" anchor="ctr"/>
           <a:lstStyle/>
           <a:p>
-            <a:pPr algn="ctr" indent="0" marL="0">
+            <a:pPr marL="0" indent="0" algn="ctr">
               <a:buNone/>
             </a:pPr>
             <a:r>
@@ -5195,7 +5037,10 @@
         </p:spPr>
         <p:txBody>
           <a:bodyPr/>
-          <a:p/>
+          <a:lstStyle/>
+          <a:p>
+            <a:endParaRPr/>
+          </a:p>
         </p:txBody>
       </p:sp>
       <p:sp>
@@ -5219,7 +5064,7 @@
           <a:bodyPr wrap="square" lIns="0" tIns="0" rIns="0" bIns="0" rtlCol="0" anchor="ctr"/>
           <a:lstStyle/>
           <a:p>
-            <a:pPr indent="0" marL="0">
+            <a:pPr marL="0" indent="0">
               <a:buNone/>
             </a:pPr>
             <a:r>
@@ -5258,11 +5103,11 @@
           <a:bodyPr wrap="square" lIns="0" tIns="0" rIns="0" bIns="0" rtlCol="0" anchor="ctr"/>
           <a:lstStyle/>
           <a:p>
-            <a:pPr indent="0" marL="0">
-              <a:buNone/>
-            </a:pPr>
-            <a:r>
-              <a:rPr lang="en-US" sz="1200" dirty="0" b="1">
+            <a:pPr marL="0" indent="0">
+              <a:buNone/>
+            </a:pPr>
+            <a:r>
+              <a:rPr lang="en-US" sz="1200" b="1" dirty="0">
                 <a:solidFill>
                   <a:schemeClr val="accent4"/>
                 </a:solidFill>
@@ -5272,7 +5117,7 @@
             <a:endParaRPr lang="en-US" sz="1400" dirty="0"/>
           </a:p>
           <a:p>
-            <a:pPr indent="0" marL="0">
+            <a:pPr marL="0" indent="0">
               <a:buNone/>
             </a:pPr>
             <a:r>
@@ -5313,7 +5158,10 @@
         </p:spPr>
         <p:txBody>
           <a:bodyPr/>
-          <a:p/>
+          <a:lstStyle/>
+          <a:p>
+            <a:endParaRPr/>
+          </a:p>
         </p:txBody>
       </p:sp>
       <p:sp>
@@ -5337,7 +5185,7 @@
           <a:bodyPr wrap="square" lIns="0" tIns="0" rIns="0" bIns="0" rtlCol="0" anchor="ctr"/>
           <a:lstStyle/>
           <a:p>
-            <a:pPr algn="ctr" indent="0" marL="0">
+            <a:pPr marL="0" indent="0" algn="ctr">
               <a:buNone/>
             </a:pPr>
             <a:r>
@@ -5380,7 +5228,10 @@
         </p:spPr>
         <p:txBody>
           <a:bodyPr/>
-          <a:p/>
+          <a:lstStyle/>
+          <a:p>
+            <a:endParaRPr/>
+          </a:p>
         </p:txBody>
       </p:sp>
       <p:sp>
@@ -5404,7 +5255,7 @@
           <a:bodyPr wrap="square" lIns="0" tIns="0" rIns="0" bIns="0" rtlCol="0" anchor="ctr"/>
           <a:lstStyle/>
           <a:p>
-            <a:pPr indent="0" marL="0">
+            <a:pPr marL="0" indent="0">
               <a:buNone/>
             </a:pPr>
             <a:r>
@@ -5443,7 +5294,7 @@
           <a:bodyPr wrap="square" lIns="0" tIns="0" rIns="0" bIns="0" rtlCol="0" anchor="ctr"/>
           <a:lstStyle/>
           <a:p>
-            <a:pPr indent="0" marL="0">
+            <a:pPr marL="0" indent="0">
               <a:buNone/>
             </a:pPr>
             <a:r>
@@ -5484,7 +5335,10 @@
         </p:spPr>
         <p:txBody>
           <a:bodyPr/>
-          <a:p/>
+          <a:lstStyle/>
+          <a:p>
+            <a:endParaRPr/>
+          </a:p>
         </p:txBody>
       </p:sp>
       <p:sp>
@@ -5508,7 +5362,7 @@
           <a:bodyPr wrap="square" lIns="0" tIns="0" rIns="0" bIns="0" rtlCol="0" anchor="ctr"/>
           <a:lstStyle/>
           <a:p>
-            <a:pPr algn="ctr" indent="0" marL="0">
+            <a:pPr marL="0" indent="0" algn="ctr">
               <a:buNone/>
             </a:pPr>
             <a:r>
@@ -5551,7 +5405,10 @@
         </p:spPr>
         <p:txBody>
           <a:bodyPr/>
-          <a:p/>
+          <a:lstStyle/>
+          <a:p>
+            <a:endParaRPr/>
+          </a:p>
         </p:txBody>
       </p:sp>
       <p:sp>
@@ -5575,7 +5432,7 @@
           <a:bodyPr wrap="square" lIns="0" tIns="0" rIns="0" bIns="0" rtlCol="0" anchor="ctr"/>
           <a:lstStyle/>
           <a:p>
-            <a:pPr indent="0" marL="0">
+            <a:pPr marL="0" indent="0">
               <a:buNone/>
             </a:pPr>
             <a:r>
@@ -5614,7 +5471,7 @@
           <a:bodyPr wrap="square" lIns="0" tIns="0" rIns="0" bIns="0" rtlCol="0" anchor="ctr"/>
           <a:lstStyle/>
           <a:p>
-            <a:pPr indent="0" marL="0">
+            <a:pPr marL="0" indent="0">
               <a:buNone/>
             </a:pPr>
             <a:r>
@@ -5655,7 +5512,10 @@
         </p:spPr>
         <p:txBody>
           <a:bodyPr/>
-          <a:p/>
+          <a:lstStyle/>
+          <a:p>
+            <a:endParaRPr/>
+          </a:p>
         </p:txBody>
       </p:sp>
       <p:sp>
@@ -5679,7 +5539,7 @@
           <a:bodyPr wrap="square" lIns="0" tIns="0" rIns="0" bIns="0" rtlCol="0" anchor="ctr"/>
           <a:lstStyle/>
           <a:p>
-            <a:pPr algn="ctr" indent="0" marL="0">
+            <a:pPr marL="0" indent="0" algn="ctr">
               <a:buNone/>
             </a:pPr>
             <a:r>
@@ -5722,7 +5582,10 @@
         </p:spPr>
         <p:txBody>
           <a:bodyPr/>
-          <a:p/>
+          <a:lstStyle/>
+          <a:p>
+            <a:endParaRPr/>
+          </a:p>
         </p:txBody>
       </p:sp>
       <p:sp>
@@ -5746,7 +5609,7 @@
           <a:bodyPr wrap="square" lIns="0" tIns="0" rIns="0" bIns="0" rtlCol="0" anchor="ctr"/>
           <a:lstStyle/>
           <a:p>
-            <a:pPr indent="0" marL="0">
+            <a:pPr marL="0" indent="0">
               <a:buNone/>
             </a:pPr>
             <a:r>
@@ -5785,7 +5648,7 @@
           <a:bodyPr wrap="square" lIns="0" tIns="0" rIns="0" bIns="0" rtlCol="0" anchor="ctr"/>
           <a:lstStyle/>
           <a:p>
-            <a:pPr indent="0" marL="0">
+            <a:pPr marL="0" indent="0">
               <a:buNone/>
             </a:pPr>
             <a:r>
@@ -5820,7 +5683,7 @@
           </a:prstGeom>
           <a:extLst>
             <a:ext uri="{C572A759-6A51-4108-AA02-DFA0A04FC94B}">
-              <ma14:wrappingTextBoxFlag xmlns:ma14="http://schemas.microsoft.com/office/mac/drawingml/2011/main" val="0"/>
+              <ma14:wrappingTextBoxFlag xmlns:ma14="http://schemas.microsoft.com/office/mac/drawingml/2011/main" xmlns="" val="0"/>
             </a:ext>
           </a:extLst>
         </p:spPr>
@@ -5838,8 +5701,8 @@
           <a:p>
             <a:pPr algn="r"/>
             <a:fld id="{F7021451-1387-4CA6-816F-3879F97B5CBC}" type="slidenum">
-              <a:rPr b="0" lang="en-US"/>
-              <a:t>11</a:t>
+              <a:rPr lang="en-US" b="0"/>
+              <a:t>12</a:t>
             </a:fld>
             <a:endParaRPr lang="en-US"/>
           </a:p>
@@ -5873,9 +5736,11 @@
       <p:sp>
         <p:nvSpPr>
           <p:cNvPr id="2" name="Text 0"/>
-          <p:cNvSpPr/>
+          <p:cNvSpPr>
+            <a:spLocks noGrp="1"/>
+          </p:cNvSpPr>
           <p:nvPr>
-            <p:ph idx="100" type="title" hasCustomPrompt="1"/>
+            <p:ph type="title" idx="100" hasCustomPrompt="1"/>
           </p:nvPr>
         </p:nvSpPr>
         <p:spPr>
@@ -5893,7 +5758,7 @@
           <a:bodyPr wrap="square" lIns="0" tIns="0" rIns="0" bIns="0" rtlCol="0" anchor="ctr"/>
           <a:lstStyle/>
           <a:p>
-            <a:pPr indent="0" marL="0">
+            <a:pPr marL="0" indent="0">
               <a:buNone/>
             </a:pPr>
             <a:r>
@@ -5981,7 +5846,7 @@
           <a:bodyPr wrap="square" lIns="0" tIns="0" rIns="0" bIns="0" rtlCol="0" anchor="ctr"/>
           <a:lstStyle/>
           <a:p>
-            <a:pPr algn="ctr" indent="0" marL="0">
+            <a:pPr marL="0" indent="0" algn="ctr">
               <a:buNone/>
             </a:pPr>
             <a:r>
@@ -6017,7 +5882,7 @@
           <a:bodyPr wrap="square" lIns="0" tIns="0" rIns="0" bIns="0" rtlCol="0" anchor="t"/>
           <a:lstStyle/>
           <a:p>
-            <a:pPr algn="ctr" indent="0" marL="0">
+            <a:pPr marL="0" indent="0" algn="ctr">
               <a:buNone/>
             </a:pPr>
             <a:r>
@@ -6031,7 +5896,7 @@
             <a:endParaRPr lang="en-US" sz="1700" dirty="0"/>
           </a:p>
           <a:p>
-            <a:pPr algn="ctr" indent="0" marL="0">
+            <a:pPr marL="0" indent="0" algn="ctr">
               <a:buNone/>
             </a:pPr>
             <a:r>
@@ -6067,7 +5932,7 @@
           <a:bodyPr wrap="square" lIns="0" tIns="0" rIns="0" bIns="0" rtlCol="0" anchor="t"/>
           <a:lstStyle/>
           <a:p>
-            <a:pPr algn="ctr" indent="0" marL="0">
+            <a:pPr marL="0" indent="0" algn="ctr">
               <a:buNone/>
             </a:pPr>
             <a:r>
@@ -6103,7 +5968,7 @@
           <a:bodyPr wrap="square" lIns="0" tIns="0" rIns="0" bIns="0" rtlCol="0" anchor="t"/>
           <a:lstStyle/>
           <a:p>
-            <a:pPr algn="ctr" indent="0" marL="0">
+            <a:pPr marL="0" indent="0" algn="ctr">
               <a:buNone/>
             </a:pPr>
             <a:r>
@@ -6191,7 +6056,7 @@
           <a:bodyPr wrap="square" lIns="0" tIns="0" rIns="0" bIns="0" rtlCol="0" anchor="ctr"/>
           <a:lstStyle/>
           <a:p>
-            <a:pPr algn="ctr" indent="0" marL="0">
+            <a:pPr marL="0" indent="0" algn="ctr">
               <a:buNone/>
             </a:pPr>
             <a:r>
@@ -6227,7 +6092,7 @@
           <a:bodyPr wrap="square" lIns="0" tIns="0" rIns="0" bIns="0" rtlCol="0" anchor="t"/>
           <a:lstStyle/>
           <a:p>
-            <a:pPr algn="ctr" indent="0" marL="0">
+            <a:pPr marL="0" indent="0" algn="ctr">
               <a:buNone/>
             </a:pPr>
             <a:r>
@@ -6241,7 +6106,7 @@
             <a:endParaRPr lang="en-US" sz="1700" dirty="0"/>
           </a:p>
           <a:p>
-            <a:pPr algn="ctr" indent="0" marL="0">
+            <a:pPr marL="0" indent="0" algn="ctr">
               <a:buNone/>
             </a:pPr>
             <a:r>
@@ -6277,7 +6142,7 @@
           <a:bodyPr wrap="square" lIns="0" tIns="0" rIns="0" bIns="0" rtlCol="0" anchor="t"/>
           <a:lstStyle/>
           <a:p>
-            <a:pPr algn="ctr" indent="0" marL="0">
+            <a:pPr marL="0" indent="0" algn="ctr">
               <a:buNone/>
             </a:pPr>
             <a:r>
@@ -6313,7 +6178,7 @@
           <a:bodyPr wrap="square" lIns="0" tIns="0" rIns="0" bIns="0" rtlCol="0" anchor="t"/>
           <a:lstStyle/>
           <a:p>
-            <a:pPr algn="ctr" indent="0" marL="0">
+            <a:pPr marL="0" indent="0" algn="ctr">
               <a:buNone/>
             </a:pPr>
             <a:r>
@@ -6401,7 +6266,7 @@
           <a:bodyPr wrap="square" lIns="0" tIns="0" rIns="0" bIns="0" rtlCol="0" anchor="ctr"/>
           <a:lstStyle/>
           <a:p>
-            <a:pPr algn="ctr" indent="0" marL="0">
+            <a:pPr marL="0" indent="0" algn="ctr">
               <a:buNone/>
             </a:pPr>
             <a:r>
@@ -6437,7 +6302,7 @@
           <a:bodyPr wrap="square" lIns="0" tIns="0" rIns="0" bIns="0" rtlCol="0" anchor="t"/>
           <a:lstStyle/>
           <a:p>
-            <a:pPr algn="ctr" indent="0" marL="0">
+            <a:pPr marL="0" indent="0" algn="ctr">
               <a:buNone/>
             </a:pPr>
             <a:r>
@@ -6451,7 +6316,7 @@
             <a:endParaRPr lang="en-US" sz="1700" dirty="0"/>
           </a:p>
           <a:p>
-            <a:pPr algn="ctr" indent="0" marL="0">
+            <a:pPr marL="0" indent="0" algn="ctr">
               <a:buNone/>
             </a:pPr>
             <a:r>
@@ -6487,7 +6352,7 @@
           <a:bodyPr wrap="square" lIns="0" tIns="0" rIns="0" bIns="0" rtlCol="0" anchor="t"/>
           <a:lstStyle/>
           <a:p>
-            <a:pPr algn="ctr" indent="0" marL="0">
+            <a:pPr marL="0" indent="0" algn="ctr">
               <a:buNone/>
             </a:pPr>
             <a:r>
@@ -6523,7 +6388,7 @@
           <a:bodyPr wrap="square" lIns="0" tIns="0" rIns="0" bIns="0" rtlCol="0" anchor="t"/>
           <a:lstStyle/>
           <a:p>
-            <a:pPr algn="ctr" indent="0" marL="0">
+            <a:pPr marL="0" indent="0" algn="ctr">
               <a:buNone/>
             </a:pPr>
             <a:r>
@@ -6611,7 +6476,7 @@
           <a:bodyPr wrap="square" lIns="0" tIns="0" rIns="0" bIns="0" rtlCol="0" anchor="ctr"/>
           <a:lstStyle/>
           <a:p>
-            <a:pPr algn="ctr" indent="0" marL="0">
+            <a:pPr marL="0" indent="0" algn="ctr">
               <a:buNone/>
             </a:pPr>
             <a:r>
@@ -6647,7 +6512,7 @@
           <a:bodyPr wrap="square" lIns="0" tIns="0" rIns="0" bIns="0" rtlCol="0" anchor="t"/>
           <a:lstStyle/>
           <a:p>
-            <a:pPr algn="ctr" indent="0" marL="0">
+            <a:pPr marL="0" indent="0" algn="ctr">
               <a:buNone/>
             </a:pPr>
             <a:r>
@@ -6661,7 +6526,7 @@
             <a:endParaRPr lang="en-US" sz="1700" dirty="0"/>
           </a:p>
           <a:p>
-            <a:pPr algn="ctr" indent="0" marL="0">
+            <a:pPr marL="0" indent="0" algn="ctr">
               <a:buNone/>
             </a:pPr>
             <a:r>
@@ -6697,7 +6562,7 @@
           <a:bodyPr wrap="square" lIns="0" tIns="0" rIns="0" bIns="0" rtlCol="0" anchor="t"/>
           <a:lstStyle/>
           <a:p>
-            <a:pPr algn="ctr" indent="0" marL="0">
+            <a:pPr marL="0" indent="0" algn="ctr">
               <a:buNone/>
             </a:pPr>
             <a:r>
@@ -6733,7 +6598,7 @@
           <a:bodyPr wrap="square" lIns="0" tIns="0" rIns="0" bIns="0" rtlCol="0" anchor="t"/>
           <a:lstStyle/>
           <a:p>
-            <a:pPr algn="ctr" indent="0" marL="0">
+            <a:pPr marL="0" indent="0" algn="ctr">
               <a:buNone/>
             </a:pPr>
             <a:r>
@@ -6821,7 +6686,7 @@
           <a:bodyPr wrap="square" lIns="0" tIns="0" rIns="0" bIns="0" rtlCol="0" anchor="ctr"/>
           <a:lstStyle/>
           <a:p>
-            <a:pPr algn="ctr" indent="0" marL="0">
+            <a:pPr marL="0" indent="0" algn="ctr">
               <a:buNone/>
             </a:pPr>
             <a:r>
@@ -6857,7 +6722,7 @@
           <a:bodyPr wrap="square" lIns="0" tIns="0" rIns="0" bIns="0" rtlCol="0" anchor="t"/>
           <a:lstStyle/>
           <a:p>
-            <a:pPr algn="ctr" indent="0" marL="0">
+            <a:pPr marL="0" indent="0" algn="ctr">
               <a:buNone/>
             </a:pPr>
             <a:r>
@@ -6871,7 +6736,7 @@
             <a:endParaRPr lang="en-US" sz="1700" dirty="0"/>
           </a:p>
           <a:p>
-            <a:pPr algn="ctr" indent="0" marL="0">
+            <a:pPr marL="0" indent="0" algn="ctr">
               <a:buNone/>
             </a:pPr>
             <a:r>
@@ -6880,7 +6745,7 @@
                   <a:schemeClr val="tx2"/>
                 </a:solidFill>
               </a:rPr>
-              <a:t>Frank</a:t>
+              <a:t>Franck</a:t>
             </a:r>
             <a:endParaRPr lang="en-US" sz="1700" dirty="0"/>
           </a:p>
@@ -6907,7 +6772,7 @@
           <a:bodyPr wrap="square" lIns="0" tIns="0" rIns="0" bIns="0" rtlCol="0" anchor="t"/>
           <a:lstStyle/>
           <a:p>
-            <a:pPr algn="ctr" indent="0" marL="0">
+            <a:pPr marL="0" indent="0" algn="ctr">
               <a:buNone/>
             </a:pPr>
             <a:r>
@@ -6943,7 +6808,7 @@
           <a:bodyPr wrap="square" lIns="0" tIns="0" rIns="0" bIns="0" rtlCol="0" anchor="t"/>
           <a:lstStyle/>
           <a:p>
-            <a:pPr algn="ctr" indent="0" marL="0">
+            <a:pPr marL="0" indent="0" algn="ctr">
               <a:buNone/>
             </a:pPr>
             <a:r>
@@ -6960,7 +6825,7 @@
       </p:sp>
       <p:sp>
         <p:nvSpPr>
-          <p:cNvPr id="25" name="Slide Number Placeholder 0"/>
+          <p:cNvPr id="3" name="Slide Number Placeholder 0"/>
           <p:cNvSpPr>
             <a:spLocks noGrp="1"/>
           </p:cNvSpPr>
@@ -6978,7 +6843,7 @@
           </a:prstGeom>
           <a:extLst>
             <a:ext uri="{C572A759-6A51-4108-AA02-DFA0A04FC94B}">
-              <ma14:wrappingTextBoxFlag xmlns:ma14="http://schemas.microsoft.com/office/mac/drawingml/2011/main" val="0"/>
+              <ma14:wrappingTextBoxFlag xmlns:ma14="http://schemas.microsoft.com/office/mac/drawingml/2011/main" xmlns="" val="0"/>
             </a:ext>
           </a:extLst>
         </p:spPr>
@@ -6996,8 +6861,8 @@
           <a:p>
             <a:pPr algn="r"/>
             <a:fld id="{F7021451-1387-4CA6-816F-3879F97B5CBC}" type="slidenum">
-              <a:rPr b="0" lang="en-US"/>
-              <a:t>12</a:t>
+              <a:rPr lang="en-US" b="0"/>
+              <a:t>13</a:t>
             </a:fld>
             <a:endParaRPr lang="en-US"/>
           </a:p>
@@ -7031,9 +6896,11 @@
       <p:sp>
         <p:nvSpPr>
           <p:cNvPr id="2" name="Text 0"/>
-          <p:cNvSpPr/>
+          <p:cNvSpPr>
+            <a:spLocks noGrp="1"/>
+          </p:cNvSpPr>
           <p:nvPr>
-            <p:ph idx="100" type="title" hasCustomPrompt="1"/>
+            <p:ph type="title" idx="100" hasCustomPrompt="1"/>
           </p:nvPr>
         </p:nvSpPr>
         <p:spPr>
@@ -7051,7 +6918,7 @@
           <a:bodyPr wrap="square" lIns="0" tIns="0" rIns="0" bIns="0" rtlCol="0"/>
           <a:lstStyle/>
           <a:p>
-            <a:pPr indent="0" marL="0">
+            <a:pPr marL="0" indent="0">
               <a:buNone/>
             </a:pPr>
             <a:r>
@@ -7112,7 +6979,7 @@
           <a:bodyPr wrap="square" lIns="0" tIns="0" rIns="0" bIns="0" rtlCol="0" anchor="ctr"/>
           <a:lstStyle/>
           <a:p>
-            <a:pPr algn="ctr" indent="0" marL="0">
+            <a:pPr marL="0" indent="0" algn="ctr">
               <a:buNone/>
             </a:pPr>
             <a:r>
@@ -7148,7 +7015,7 @@
           <a:bodyPr wrap="square" lIns="0" tIns="0" rIns="0" bIns="0" rtlCol="0" anchor="ctr"/>
           <a:lstStyle/>
           <a:p>
-            <a:pPr indent="0" marL="0">
+            <a:pPr marL="0" indent="0">
               <a:buNone/>
             </a:pPr>
             <a:r>
@@ -7209,7 +7076,7 @@
           <a:bodyPr wrap="square" lIns="0" tIns="0" rIns="0" bIns="0" rtlCol="0" anchor="ctr"/>
           <a:lstStyle/>
           <a:p>
-            <a:pPr algn="ctr" indent="0" marL="0">
+            <a:pPr marL="0" indent="0" algn="ctr">
               <a:buNone/>
             </a:pPr>
             <a:r>
@@ -7245,7 +7112,7 @@
           <a:bodyPr wrap="square" lIns="0" tIns="0" rIns="0" bIns="0" rtlCol="0" anchor="ctr"/>
           <a:lstStyle/>
           <a:p>
-            <a:pPr indent="0" marL="0">
+            <a:pPr marL="0" indent="0">
               <a:buNone/>
             </a:pPr>
             <a:r>
@@ -7306,7 +7173,7 @@
           <a:bodyPr wrap="square" lIns="0" tIns="0" rIns="0" bIns="0" rtlCol="0" anchor="ctr"/>
           <a:lstStyle/>
           <a:p>
-            <a:pPr algn="ctr" indent="0" marL="0">
+            <a:pPr marL="0" indent="0" algn="ctr">
               <a:buNone/>
             </a:pPr>
             <a:r>
@@ -7342,7 +7209,7 @@
           <a:bodyPr wrap="square" lIns="0" tIns="0" rIns="0" bIns="0" rtlCol="0" anchor="ctr"/>
           <a:lstStyle/>
           <a:p>
-            <a:pPr indent="0" marL="0">
+            <a:pPr marL="0" indent="0">
               <a:buNone/>
             </a:pPr>
             <a:r>
@@ -7403,7 +7270,7 @@
           <a:bodyPr wrap="square" lIns="0" tIns="0" rIns="0" bIns="0" rtlCol="0" anchor="ctr"/>
           <a:lstStyle/>
           <a:p>
-            <a:pPr algn="ctr" indent="0" marL="0">
+            <a:pPr marL="0" indent="0" algn="ctr">
               <a:buNone/>
             </a:pPr>
             <a:r>
@@ -7439,7 +7306,7 @@
           <a:bodyPr wrap="square" lIns="0" tIns="0" rIns="0" bIns="0" rtlCol="0" anchor="ctr"/>
           <a:lstStyle/>
           <a:p>
-            <a:pPr indent="0" marL="0">
+            <a:pPr marL="0" indent="0">
               <a:buNone/>
             </a:pPr>
             <a:r>
@@ -7500,7 +7367,7 @@
           <a:bodyPr wrap="square" lIns="0" tIns="0" rIns="0" bIns="0" rtlCol="0" anchor="ctr"/>
           <a:lstStyle/>
           <a:p>
-            <a:pPr algn="ctr" indent="0" marL="0">
+            <a:pPr marL="0" indent="0" algn="ctr">
               <a:buNone/>
             </a:pPr>
             <a:r>
@@ -7536,7 +7403,7 @@
           <a:bodyPr wrap="square" lIns="0" tIns="0" rIns="0" bIns="0" rtlCol="0" anchor="ctr"/>
           <a:lstStyle/>
           <a:p>
-            <a:pPr indent="0" marL="0">
+            <a:pPr marL="0" indent="0">
               <a:buNone/>
             </a:pPr>
             <a:r>
@@ -7572,7 +7439,7 @@
           <a:bodyPr wrap="square" lIns="0" tIns="0" rIns="0" bIns="0" rtlCol="0" anchor="ctr"/>
           <a:lstStyle/>
           <a:p>
-            <a:pPr indent="0" marL="0">
+            <a:pPr marL="0" indent="0">
               <a:buNone/>
             </a:pPr>
             <a:r>
@@ -7615,9 +7482,11 @@
       <p:sp>
         <p:nvSpPr>
           <p:cNvPr id="2" name="Text 0"/>
-          <p:cNvSpPr/>
+          <p:cNvSpPr>
+            <a:spLocks noGrp="1"/>
+          </p:cNvSpPr>
           <p:nvPr>
-            <p:ph idx="100" type="title" hasCustomPrompt="1"/>
+            <p:ph type="title" idx="100" hasCustomPrompt="1"/>
           </p:nvPr>
         </p:nvSpPr>
         <p:spPr>
@@ -7635,7 +7504,7 @@
           <a:bodyPr wrap="square" lIns="0" tIns="0" rIns="0" bIns="0" rtlCol="0" anchor="ctr"/>
           <a:lstStyle/>
           <a:p>
-            <a:pPr indent="0" marL="0">
+            <a:pPr marL="0" indent="0">
               <a:buNone/>
             </a:pPr>
             <a:r>
@@ -7723,7 +7592,7 @@
           <a:bodyPr wrap="square" lIns="0" tIns="0" rIns="0" bIns="0" rtlCol="0" anchor="ctr"/>
           <a:lstStyle/>
           <a:p>
-            <a:pPr algn="ctr" indent="0" marL="0">
+            <a:pPr marL="0" indent="0" algn="ctr">
               <a:buNone/>
             </a:pPr>
             <a:r>
@@ -7759,7 +7628,7 @@
           <a:bodyPr wrap="square" lIns="0" tIns="0" rIns="0" bIns="0" rtlCol="0" anchor="t"/>
           <a:lstStyle/>
           <a:p>
-            <a:pPr indent="0" marL="0">
+            <a:pPr marL="0" indent="0">
               <a:buNone/>
             </a:pPr>
             <a:r>
@@ -7795,7 +7664,7 @@
           <a:bodyPr wrap="square" lIns="0" tIns="0" rIns="0" bIns="0" rtlCol="0" anchor="t"/>
           <a:lstStyle/>
           <a:p>
-            <a:pPr indent="0" marL="0">
+            <a:pPr marL="0" indent="0">
               <a:buNone/>
             </a:pPr>
             <a:r>
@@ -7883,7 +7752,7 @@
           <a:bodyPr wrap="square" lIns="0" tIns="0" rIns="0" bIns="0" rtlCol="0" anchor="ctr"/>
           <a:lstStyle/>
           <a:p>
-            <a:pPr algn="ctr" indent="0" marL="0">
+            <a:pPr marL="0" indent="0" algn="ctr">
               <a:buNone/>
             </a:pPr>
             <a:r>
@@ -7919,7 +7788,7 @@
           <a:bodyPr wrap="square" lIns="0" tIns="0" rIns="0" bIns="0" rtlCol="0" anchor="t"/>
           <a:lstStyle/>
           <a:p>
-            <a:pPr indent="0" marL="0">
+            <a:pPr marL="0" indent="0">
               <a:buNone/>
             </a:pPr>
             <a:r>
@@ -7955,7 +7824,7 @@
           <a:bodyPr wrap="square" lIns="0" tIns="0" rIns="0" bIns="0" rtlCol="0" anchor="t"/>
           <a:lstStyle/>
           <a:p>
-            <a:pPr indent="0" marL="0">
+            <a:pPr marL="0" indent="0">
               <a:buNone/>
             </a:pPr>
             <a:r>
@@ -8043,7 +7912,7 @@
           <a:bodyPr wrap="square" lIns="0" tIns="0" rIns="0" bIns="0" rtlCol="0" anchor="ctr"/>
           <a:lstStyle/>
           <a:p>
-            <a:pPr algn="ctr" indent="0" marL="0">
+            <a:pPr marL="0" indent="0" algn="ctr">
               <a:buNone/>
             </a:pPr>
             <a:r>
@@ -8079,7 +7948,7 @@
           <a:bodyPr wrap="square" lIns="0" tIns="0" rIns="0" bIns="0" rtlCol="0" anchor="t"/>
           <a:lstStyle/>
           <a:p>
-            <a:pPr indent="0" marL="0">
+            <a:pPr marL="0" indent="0">
               <a:buNone/>
             </a:pPr>
             <a:r>
@@ -8115,7 +7984,7 @@
           <a:bodyPr wrap="square" lIns="0" tIns="0" rIns="0" bIns="0" rtlCol="0" anchor="t"/>
           <a:lstStyle/>
           <a:p>
-            <a:pPr indent="0" marL="0">
+            <a:pPr marL="0" indent="0">
               <a:buNone/>
             </a:pPr>
             <a:r>
@@ -8203,7 +8072,7 @@
           <a:bodyPr wrap="square" lIns="0" tIns="0" rIns="0" bIns="0" rtlCol="0" anchor="ctr"/>
           <a:lstStyle/>
           <a:p>
-            <a:pPr algn="ctr" indent="0" marL="0">
+            <a:pPr marL="0" indent="0" algn="ctr">
               <a:buNone/>
             </a:pPr>
             <a:r>
@@ -8239,7 +8108,7 @@
           <a:bodyPr wrap="square" lIns="0" tIns="0" rIns="0" bIns="0" rtlCol="0" anchor="t"/>
           <a:lstStyle/>
           <a:p>
-            <a:pPr indent="0" marL="0">
+            <a:pPr marL="0" indent="0">
               <a:buNone/>
             </a:pPr>
             <a:r>
@@ -8275,7 +8144,7 @@
           <a:bodyPr wrap="square" lIns="0" tIns="0" rIns="0" bIns="0" rtlCol="0" anchor="t"/>
           <a:lstStyle/>
           <a:p>
-            <a:pPr indent="0" marL="0">
+            <a:pPr marL="0" indent="0">
               <a:buNone/>
             </a:pPr>
             <a:r>
@@ -8363,7 +8232,7 @@
           <a:bodyPr wrap="square" lIns="0" tIns="0" rIns="0" bIns="0" rtlCol="0" anchor="ctr"/>
           <a:lstStyle/>
           <a:p>
-            <a:pPr algn="ctr" indent="0" marL="0">
+            <a:pPr marL="0" indent="0" algn="ctr">
               <a:buNone/>
             </a:pPr>
             <a:r>
@@ -8399,7 +8268,7 @@
           <a:bodyPr wrap="square" lIns="0" tIns="0" rIns="0" bIns="0" rtlCol="0" anchor="t"/>
           <a:lstStyle/>
           <a:p>
-            <a:pPr indent="0" marL="0">
+            <a:pPr marL="0" indent="0">
               <a:buNone/>
             </a:pPr>
             <a:r>
@@ -8435,7 +8304,7 @@
           <a:bodyPr wrap="square" lIns="0" tIns="0" rIns="0" bIns="0" rtlCol="0" anchor="t"/>
           <a:lstStyle/>
           <a:p>
-            <a:pPr indent="0" marL="0">
+            <a:pPr marL="0" indent="0">
               <a:buNone/>
             </a:pPr>
             <a:r>
@@ -8523,7 +8392,7 @@
           <a:bodyPr wrap="square" lIns="0" tIns="0" rIns="0" bIns="0" rtlCol="0" anchor="ctr"/>
           <a:lstStyle/>
           <a:p>
-            <a:pPr algn="ctr" indent="0" marL="0">
+            <a:pPr marL="0" indent="0" algn="ctr">
               <a:buNone/>
             </a:pPr>
             <a:r>
@@ -8559,7 +8428,7 @@
           <a:bodyPr wrap="square" lIns="0" tIns="0" rIns="0" bIns="0" rtlCol="0" anchor="t"/>
           <a:lstStyle/>
           <a:p>
-            <a:pPr indent="0" marL="0">
+            <a:pPr marL="0" indent="0">
               <a:buNone/>
             </a:pPr>
             <a:r>
@@ -8595,7 +8464,7 @@
           <a:bodyPr wrap="square" lIns="0" tIns="0" rIns="0" bIns="0" rtlCol="0" anchor="t"/>
           <a:lstStyle/>
           <a:p>
-            <a:pPr indent="0" marL="0">
+            <a:pPr marL="0" indent="0">
               <a:buNone/>
             </a:pPr>
             <a:r>
@@ -8683,7 +8552,7 @@
           <a:bodyPr wrap="square" lIns="0" tIns="0" rIns="0" bIns="0" rtlCol="0" anchor="ctr"/>
           <a:lstStyle/>
           <a:p>
-            <a:pPr algn="ctr" indent="0" marL="0">
+            <a:pPr marL="0" indent="0" algn="ctr">
               <a:buNone/>
             </a:pPr>
             <a:r>
@@ -8719,7 +8588,7 @@
           <a:bodyPr wrap="square" lIns="0" tIns="0" rIns="0" bIns="0" rtlCol="0" anchor="t"/>
           <a:lstStyle/>
           <a:p>
-            <a:pPr indent="0" marL="0">
+            <a:pPr marL="0" indent="0">
               <a:buNone/>
             </a:pPr>
             <a:r>
@@ -8755,7 +8624,7 @@
           <a:bodyPr wrap="square" lIns="0" tIns="0" rIns="0" bIns="0" rtlCol="0" anchor="t"/>
           <a:lstStyle/>
           <a:p>
-            <a:pPr indent="0" marL="0">
+            <a:pPr marL="0" indent="0">
               <a:buNone/>
             </a:pPr>
             <a:r>
@@ -8791,7 +8660,7 @@
           <a:bodyPr wrap="square" lIns="0" tIns="0" rIns="0" bIns="0" rtlCol="0" anchor="ctr"/>
           <a:lstStyle/>
           <a:p>
-            <a:pPr indent="0" marL="0">
+            <a:pPr marL="0" indent="0">
               <a:buNone/>
             </a:pPr>
             <a:r>
@@ -8808,7 +8677,7 @@
       </p:sp>
       <p:sp>
         <p:nvSpPr>
-          <p:cNvPr id="25" name="Slide Number Placeholder 0"/>
+          <p:cNvPr id="3" name="Slide Number Placeholder 0"/>
           <p:cNvSpPr>
             <a:spLocks noGrp="1"/>
           </p:cNvSpPr>
@@ -8826,7 +8695,7 @@
           </a:prstGeom>
           <a:extLst>
             <a:ext uri="{C572A759-6A51-4108-AA02-DFA0A04FC94B}">
-              <ma14:wrappingTextBoxFlag xmlns:ma14="http://schemas.microsoft.com/office/mac/drawingml/2011/main" val="0"/>
+              <ma14:wrappingTextBoxFlag xmlns:ma14="http://schemas.microsoft.com/office/mac/drawingml/2011/main" xmlns="" val="0"/>
             </a:ext>
           </a:extLst>
         </p:spPr>
@@ -8844,7 +8713,7 @@
           <a:p>
             <a:pPr algn="r"/>
             <a:fld id="{F7021451-1387-4CA6-816F-3879F97B5CBC}" type="slidenum">
-              <a:rPr b="0" lang="en-US"/>
+              <a:rPr lang="en-US" b="0"/>
               <a:t>2</a:t>
             </a:fld>
             <a:endParaRPr lang="en-US"/>
@@ -8879,9 +8748,11 @@
       <p:sp>
         <p:nvSpPr>
           <p:cNvPr id="2" name="Text 0"/>
-          <p:cNvSpPr/>
+          <p:cNvSpPr>
+            <a:spLocks noGrp="1"/>
+          </p:cNvSpPr>
           <p:nvPr>
-            <p:ph idx="100" type="title" hasCustomPrompt="1"/>
+            <p:ph type="title" idx="100" hasCustomPrompt="1"/>
           </p:nvPr>
         </p:nvSpPr>
         <p:spPr>
@@ -8899,7 +8770,7 @@
           <a:bodyPr wrap="square" lIns="0" tIns="0" rIns="0" bIns="0" rtlCol="0" anchor="ctr"/>
           <a:lstStyle/>
           <a:p>
-            <a:pPr indent="0" marL="0">
+            <a:pPr marL="0" indent="0">
               <a:buNone/>
             </a:pPr>
             <a:r>
@@ -8962,7 +8833,7 @@
           <a:bodyPr wrap="square" lIns="1016" tIns="1016" rIns="1016" bIns="1016" rtlCol="0" anchor="ctr"/>
           <a:lstStyle/>
           <a:p>
-            <a:pPr algn="ctr" indent="0" marL="0">
+            <a:pPr marL="0" indent="0" algn="ctr">
               <a:buNone/>
             </a:pPr>
             <a:r>
@@ -8976,7 +8847,7 @@
             <a:endParaRPr lang="en-US" sz="1600" dirty="0"/>
           </a:p>
           <a:p>
-            <a:pPr algn="ctr" indent="0" marL="0">
+            <a:pPr marL="0" indent="0" algn="ctr">
               <a:buNone/>
             </a:pPr>
             <a:r>
@@ -9039,7 +8910,7 @@
           <a:bodyPr wrap="square" lIns="0" tIns="0" rIns="0" bIns="0" rtlCol="0" anchor="ctr"/>
           <a:lstStyle/>
           <a:p>
-            <a:pPr algn="ctr" indent="0" marL="0">
+            <a:pPr marL="0" indent="0" algn="ctr">
               <a:buNone/>
             </a:pPr>
             <a:r>
@@ -9053,7 +8924,7 @@
             <a:endParaRPr lang="en-US" sz="1400" dirty="0"/>
           </a:p>
           <a:p>
-            <a:pPr algn="ctr" indent="0" marL="0">
+            <a:pPr marL="0" indent="0" algn="ctr">
               <a:buNone/>
             </a:pPr>
             <a:r>
@@ -9067,7 +8938,7 @@
             <a:endParaRPr lang="en-US" sz="1400" dirty="0"/>
           </a:p>
           <a:p>
-            <a:pPr algn="ctr" indent="0" marL="0">
+            <a:pPr marL="0" indent="0" algn="ctr">
               <a:buNone/>
             </a:pPr>
             <a:r>
@@ -9081,7 +8952,7 @@
             <a:endParaRPr lang="en-US" sz="1400" dirty="0"/>
           </a:p>
           <a:p>
-            <a:pPr algn="ctr" indent="0" marL="0">
+            <a:pPr marL="0" indent="0" algn="ctr">
               <a:buNone/>
             </a:pPr>
             <a:r>
@@ -9095,7 +8966,7 @@
             <a:endParaRPr lang="en-US" sz="1400" dirty="0"/>
           </a:p>
           <a:p>
-            <a:pPr algn="ctr" indent="0" marL="0">
+            <a:pPr marL="0" indent="0" algn="ctr">
               <a:buNone/>
             </a:pPr>
             <a:r>
@@ -9109,7 +8980,7 @@
             <a:endParaRPr lang="en-US" sz="1400" dirty="0"/>
           </a:p>
           <a:p>
-            <a:pPr algn="ctr" indent="0" marL="0">
+            <a:pPr marL="0" indent="0" algn="ctr">
               <a:buNone/>
             </a:pPr>
             <a:r>
@@ -9123,7 +8994,7 @@
             <a:endParaRPr lang="en-US" sz="1400" dirty="0"/>
           </a:p>
           <a:p>
-            <a:pPr algn="ctr" indent="0" marL="0">
+            <a:pPr marL="0" indent="0" algn="ctr">
               <a:buNone/>
             </a:pPr>
             <a:r>
@@ -9186,7 +9057,7 @@
           <a:bodyPr wrap="square" lIns="1016" tIns="1016" rIns="1016" bIns="1016" rtlCol="0" anchor="ctr"/>
           <a:lstStyle/>
           <a:p>
-            <a:pPr algn="ctr" indent="0" marL="0">
+            <a:pPr marL="0" indent="0" algn="ctr">
               <a:buNone/>
             </a:pPr>
             <a:r>
@@ -9200,7 +9071,7 @@
             <a:endParaRPr lang="en-US" sz="1600" dirty="0"/>
           </a:p>
           <a:p>
-            <a:pPr algn="ctr" indent="0" marL="0">
+            <a:pPr marL="0" indent="0" algn="ctr">
               <a:buNone/>
             </a:pPr>
             <a:r>
@@ -9263,7 +9134,7 @@
           <a:bodyPr wrap="square" lIns="1016" tIns="1016" rIns="1016" bIns="1016" rtlCol="0" anchor="ctr"/>
           <a:lstStyle/>
           <a:p>
-            <a:pPr algn="ctr" indent="0" marL="0">
+            <a:pPr marL="0" indent="0" algn="ctr">
               <a:buNone/>
             </a:pPr>
             <a:r>
@@ -9277,7 +9148,7 @@
             <a:endParaRPr lang="en-US" sz="1600" dirty="0"/>
           </a:p>
           <a:p>
-            <a:pPr algn="ctr" indent="0" marL="0">
+            <a:pPr marL="0" indent="0" algn="ctr">
               <a:buNone/>
             </a:pPr>
             <a:r>
@@ -9385,7 +9256,7 @@
           <a:bodyPr wrap="square" lIns="0" tIns="0" rIns="0" bIns="0" rtlCol="0" anchor="b"/>
           <a:lstStyle/>
           <a:p>
-            <a:pPr algn="ctr" indent="0" marL="0">
+            <a:pPr marL="0" indent="0" algn="ctr">
               <a:buNone/>
             </a:pPr>
             <a:r>
@@ -9421,7 +9292,7 @@
           <a:bodyPr wrap="square" lIns="0" tIns="0" rIns="0" bIns="0" rtlCol="0" anchor="t"/>
           <a:lstStyle/>
           <a:p>
-            <a:pPr algn="ctr" indent="0" marL="0">
+            <a:pPr marL="0" indent="0" algn="ctr">
               <a:buNone/>
             </a:pPr>
             <a:r>
@@ -9457,7 +9328,7 @@
           <a:bodyPr wrap="square" lIns="0" tIns="0" rIns="0" bIns="0" rtlCol="0" anchor="t"/>
           <a:lstStyle/>
           <a:p>
-            <a:pPr algn="ctr" indent="0" marL="0">
+            <a:pPr marL="0" indent="0" algn="ctr">
               <a:buNone/>
             </a:pPr>
             <a:r>
@@ -9520,7 +9391,7 @@
           <a:bodyPr wrap="square" lIns="0" tIns="0" rIns="0" bIns="0" rtlCol="0" anchor="t"/>
           <a:lstStyle/>
           <a:p>
-            <a:pPr indent="0" marL="0">
+            <a:pPr marL="0" indent="0">
               <a:spcAft>
                 <a:spcPts val="600"/>
               </a:spcAft>
@@ -9534,30 +9405,24 @@
               </a:rPr>
               <a:t>Routage par version  </a:t>
             </a:r>
-            <a:pPr indent="0" marL="0">
+            <a:r>
+              <a:rPr lang="en-US" sz="1400" dirty="0">
+                <a:solidFill>
+                  <a:schemeClr val="tx1"/>
+                </a:solidFill>
+              </a:rPr>
+              <a:t>/structures/1.0.0/*  →  http://api:8000/v1/*      /structures/2.0.0/*  →  http://api:8000/v2/*</a:t>
+            </a:r>
+            <a:endParaRPr lang="en-US" sz="1400" dirty="0"/>
+          </a:p>
+          <a:p>
+            <a:pPr marL="0" indent="0">
               <a:spcAft>
                 <a:spcPts val="600"/>
               </a:spcAft>
               <a:buNone/>
             </a:pPr>
             <a:r>
-              <a:rPr lang="en-US" sz="1400" dirty="0">
-                <a:solidFill>
-                  <a:schemeClr val="tx1"/>
-                </a:solidFill>
-              </a:rPr>
-              <a:t>/structures/1.0.0/*  →  http://api:8000/v1/*      /structures/2.0.0/*  →  http://api:8000/v2/*</a:t>
-            </a:r>
-            <a:endParaRPr lang="en-US" sz="1400" dirty="0"/>
-          </a:p>
-          <a:p>
-            <a:pPr indent="0" marL="0">
-              <a:spcAft>
-                <a:spcPts val="600"/>
-              </a:spcAft>
-              <a:buNone/>
-            </a:pPr>
-            <a:r>
               <a:rPr lang="en-US" sz="1400" b="1" dirty="0">
                 <a:solidFill>
                   <a:schemeClr val="tx2"/>
@@ -9565,12 +9430,6 @@
               </a:rPr>
               <a:t>Installation  </a:t>
             </a:r>
-            <a:pPr indent="0" marL="0">
-              <a:spcAft>
-                <a:spcPts val="600"/>
-              </a:spcAft>
-              <a:buNone/>
-            </a:pPr>
             <a:r>
               <a:rPr lang="en-US" sz="1400" dirty="0">
                 <a:solidFill>
@@ -9603,7 +9462,7 @@
           </a:prstGeom>
           <a:extLst>
             <a:ext uri="{C572A759-6A51-4108-AA02-DFA0A04FC94B}">
-              <ma14:wrappingTextBoxFlag xmlns:ma14="http://schemas.microsoft.com/office/mac/drawingml/2011/main" val="0"/>
+              <ma14:wrappingTextBoxFlag xmlns:ma14="http://schemas.microsoft.com/office/mac/drawingml/2011/main" xmlns="" val="0"/>
             </a:ext>
           </a:extLst>
         </p:spPr>
@@ -9621,7 +9480,7 @@
           <a:p>
             <a:pPr algn="r"/>
             <a:fld id="{F7021451-1387-4CA6-816F-3879F97B5CBC}" type="slidenum">
-              <a:rPr b="0" lang="en-US"/>
+              <a:rPr lang="en-US" b="0"/>
               <a:t>3</a:t>
             </a:fld>
             <a:endParaRPr lang="en-US"/>
@@ -9656,9 +9515,11 @@
       <p:sp>
         <p:nvSpPr>
           <p:cNvPr id="2" name="Text 0"/>
-          <p:cNvSpPr/>
+          <p:cNvSpPr>
+            <a:spLocks noGrp="1"/>
+          </p:cNvSpPr>
           <p:nvPr>
-            <p:ph idx="100" type="title" hasCustomPrompt="1"/>
+            <p:ph type="title" idx="100" hasCustomPrompt="1"/>
           </p:nvPr>
         </p:nvSpPr>
         <p:spPr>
@@ -9676,7 +9537,7 @@
           <a:bodyPr wrap="square" lIns="0" tIns="0" rIns="0" bIns="0" rtlCol="0" anchor="ctr"/>
           <a:lstStyle/>
           <a:p>
-            <a:pPr indent="0" marL="0">
+            <a:pPr marL="0" indent="0">
               <a:buNone/>
             </a:pPr>
             <a:r>
@@ -9712,7 +9573,7 @@
           <a:bodyPr wrap="square" lIns="0" tIns="0" rIns="0" bIns="0" rtlCol="0" anchor="t"/>
           <a:lstStyle/>
           <a:p>
-            <a:pPr indent="0" marL="0">
+            <a:pPr marL="0" indent="0">
               <a:buNone/>
             </a:pPr>
             <a:r>
@@ -9751,7 +9612,7 @@
           <a:bodyPr wrap="square" lIns="0" tIns="0" rIns="0" bIns="0" rtlCol="0" anchor="t"/>
           <a:lstStyle/>
           <a:p>
-            <a:pPr indent="0" marL="0">
+            <a:pPr marL="0" indent="0">
               <a:buNone/>
             </a:pPr>
             <a:r>
@@ -9787,7 +9648,7 @@
           <a:bodyPr wrap="square" lIns="0" tIns="0" rIns="0" bIns="0" rtlCol="0" anchor="t"/>
           <a:lstStyle/>
           <a:p>
-            <a:pPr indent="0" marL="0">
+            <a:pPr marL="0" indent="0">
               <a:buNone/>
             </a:pPr>
             <a:r>
@@ -9826,7 +9687,7 @@
           <a:bodyPr wrap="square" lIns="0" tIns="0" rIns="0" bIns="0" rtlCol="0" anchor="t"/>
           <a:lstStyle/>
           <a:p>
-            <a:pPr indent="0" marL="0">
+            <a:pPr marL="0" indent="0">
               <a:buNone/>
             </a:pPr>
             <a:r>
@@ -9862,7 +9723,7 @@
           <a:bodyPr wrap="square" lIns="0" tIns="0" rIns="0" bIns="0" rtlCol="0" anchor="t"/>
           <a:lstStyle/>
           <a:p>
-            <a:pPr indent="0" marL="0">
+            <a:pPr marL="0" indent="0">
               <a:buNone/>
             </a:pPr>
             <a:r>
@@ -9901,7 +9762,7 @@
           <a:bodyPr wrap="square" lIns="0" tIns="0" rIns="0" bIns="0" rtlCol="0" anchor="t"/>
           <a:lstStyle/>
           <a:p>
-            <a:pPr indent="0" marL="0">
+            <a:pPr marL="0" indent="0">
               <a:buNone/>
             </a:pPr>
             <a:r>
@@ -9918,7 +9779,7 @@
       </p:sp>
       <p:graphicFrame>
         <p:nvGraphicFramePr>
-          <p:cNvPr id="5" name="table-routes"/>
+          <p:cNvPr id="3" name="table-routes"/>
           <p:cNvGraphicFramePr>
             <a:graphicFrameLocks noGrp="1"/>
           </p:cNvGraphicFramePr>
@@ -9932,16 +9793,34 @@
         </p:nvGraphicFramePr>
         <p:xfrm>
           <a:off x="3474720" y="1463040"/>
-          <a:ext cx="8183880" cy="914400"/>
+          <a:ext cx="8183880" cy="2514600"/>
         </p:xfrm>
         <a:graphic>
           <a:graphicData uri="http://schemas.openxmlformats.org/drawingml/2006/table">
             <a:tbl>
               <a:tblPr/>
               <a:tblGrid>
-                <a:gridCol w="2834640"/>
-                <a:gridCol w="3703320"/>
-                <a:gridCol w="1645920"/>
+                <a:gridCol w="2834640">
+                  <a:extLst>
+                    <a:ext uri="{9D8B030D-6E8A-4147-A177-3AD203B41FA5}">
+                      <a16:colId xmlns:a16="http://schemas.microsoft.com/office/drawing/2014/main" val="20000"/>
+                    </a:ext>
+                  </a:extLst>
+                </a:gridCol>
+                <a:gridCol w="3703320">
+                  <a:extLst>
+                    <a:ext uri="{9D8B030D-6E8A-4147-A177-3AD203B41FA5}">
+                      <a16:colId xmlns:a16="http://schemas.microsoft.com/office/drawing/2014/main" val="20001"/>
+                    </a:ext>
+                  </a:extLst>
+                </a:gridCol>
+                <a:gridCol w="1645920">
+                  <a:extLst>
+                    <a:ext uri="{9D8B030D-6E8A-4147-A177-3AD203B41FA5}">
+                      <a16:colId xmlns:a16="http://schemas.microsoft.com/office/drawing/2014/main" val="20002"/>
+                    </a:ext>
+                  </a:extLst>
+                </a:gridCol>
               </a:tblGrid>
               <a:tr h="502920">
                 <a:tc>
@@ -9949,7 +9828,7 @@
                     <a:bodyPr/>
                     <a:lstStyle/>
                     <a:p>
-                      <a:pPr indent="0" marL="0">
+                      <a:pPr marL="0" indent="0">
                         <a:buNone/>
                       </a:pPr>
                       <a:r>
@@ -10010,7 +9889,7 @@
                     <a:bodyPr/>
                     <a:lstStyle/>
                     <a:p>
-                      <a:pPr indent="0" marL="0">
+                      <a:pPr marL="0" indent="0">
                         <a:buNone/>
                       </a:pPr>
                       <a:r>
@@ -10071,7 +9950,7 @@
                     <a:bodyPr/>
                     <a:lstStyle/>
                     <a:p>
-                      <a:pPr indent="0" marL="0">
+                      <a:pPr marL="0" indent="0">
                         <a:buNone/>
                       </a:pPr>
                       <a:r>
@@ -10127,6 +10006,11 @@
                     </a:solidFill>
                   </a:tcPr>
                 </a:tc>
+                <a:extLst>
+                  <a:ext uri="{0D108BD9-81ED-4DB2-BD59-A6C34878D82A}">
+                    <a16:rowId xmlns:a16="http://schemas.microsoft.com/office/drawing/2014/main" val="10000"/>
+                  </a:ext>
+                </a:extLst>
               </a:tr>
               <a:tr h="502920">
                 <a:tc>
@@ -10134,7 +10018,7 @@
                     <a:bodyPr/>
                     <a:lstStyle/>
                     <a:p>
-                      <a:pPr indent="0" marL="0">
+                      <a:pPr marL="0" indent="0">
                         <a:buNone/>
                       </a:pPr>
                       <a:r>
@@ -10202,7 +10086,7 @@
                     <a:bodyPr/>
                     <a:lstStyle/>
                     <a:p>
-                      <a:pPr indent="0" marL="0">
+                      <a:pPr marL="0" indent="0">
                         <a:buNone/>
                       </a:pPr>
                       <a:r>
@@ -10263,7 +10147,7 @@
                     <a:bodyPr/>
                     <a:lstStyle/>
                     <a:p>
-                      <a:pPr indent="0" marL="0">
+                      <a:pPr marL="0" indent="0">
                         <a:buNone/>
                       </a:pPr>
                       <a:r>
@@ -10319,6 +10203,11 @@
                     </a:solidFill>
                   </a:tcPr>
                 </a:tc>
+                <a:extLst>
+                  <a:ext uri="{0D108BD9-81ED-4DB2-BD59-A6C34878D82A}">
+                    <a16:rowId xmlns:a16="http://schemas.microsoft.com/office/drawing/2014/main" val="10001"/>
+                  </a:ext>
+                </a:extLst>
               </a:tr>
               <a:tr h="502920">
                 <a:tc>
@@ -10326,7 +10215,7 @@
                     <a:bodyPr/>
                     <a:lstStyle/>
                     <a:p>
-                      <a:pPr indent="0" marL="0">
+                      <a:pPr marL="0" indent="0">
                         <a:buNone/>
                       </a:pPr>
                       <a:r>
@@ -10394,7 +10283,7 @@
                     <a:bodyPr/>
                     <a:lstStyle/>
                     <a:p>
-                      <a:pPr indent="0" marL="0">
+                      <a:pPr marL="0" indent="0">
                         <a:buNone/>
                       </a:pPr>
                       <a:r>
@@ -10455,7 +10344,7 @@
                     <a:bodyPr/>
                     <a:lstStyle/>
                     <a:p>
-                      <a:pPr indent="0" marL="0">
+                      <a:pPr marL="0" indent="0">
                         <a:buNone/>
                       </a:pPr>
                       <a:r>
@@ -10511,6 +10400,11 @@
                     </a:solidFill>
                   </a:tcPr>
                 </a:tc>
+                <a:extLst>
+                  <a:ext uri="{0D108BD9-81ED-4DB2-BD59-A6C34878D82A}">
+                    <a16:rowId xmlns:a16="http://schemas.microsoft.com/office/drawing/2014/main" val="10002"/>
+                  </a:ext>
+                </a:extLst>
               </a:tr>
               <a:tr h="502920">
                 <a:tc>
@@ -10518,7 +10412,7 @@
                     <a:bodyPr/>
                     <a:lstStyle/>
                     <a:p>
-                      <a:pPr indent="0" marL="0">
+                      <a:pPr marL="0" indent="0">
                         <a:buNone/>
                       </a:pPr>
                       <a:r>
@@ -10586,7 +10480,7 @@
                     <a:bodyPr/>
                     <a:lstStyle/>
                     <a:p>
-                      <a:pPr indent="0" marL="0">
+                      <a:pPr marL="0" indent="0">
                         <a:buNone/>
                       </a:pPr>
                       <a:r>
@@ -10647,7 +10541,7 @@
                     <a:bodyPr/>
                     <a:lstStyle/>
                     <a:p>
-                      <a:pPr indent="0" marL="0">
+                      <a:pPr marL="0" indent="0">
                         <a:buNone/>
                       </a:pPr>
                       <a:r>
@@ -10703,6 +10597,11 @@
                     </a:solidFill>
                   </a:tcPr>
                 </a:tc>
+                <a:extLst>
+                  <a:ext uri="{0D108BD9-81ED-4DB2-BD59-A6C34878D82A}">
+                    <a16:rowId xmlns:a16="http://schemas.microsoft.com/office/drawing/2014/main" val="10003"/>
+                  </a:ext>
+                </a:extLst>
               </a:tr>
               <a:tr h="502920">
                 <a:tc>
@@ -10710,7 +10609,7 @@
                     <a:bodyPr/>
                     <a:lstStyle/>
                     <a:p>
-                      <a:pPr indent="0" marL="0">
+                      <a:pPr marL="0" indent="0">
                         <a:buNone/>
                       </a:pPr>
                       <a:r>
@@ -10778,7 +10677,7 @@
                     <a:bodyPr/>
                     <a:lstStyle/>
                     <a:p>
-                      <a:pPr indent="0" marL="0">
+                      <a:pPr marL="0" indent="0">
                         <a:buNone/>
                       </a:pPr>
                       <a:r>
@@ -10839,7 +10738,7 @@
                     <a:bodyPr/>
                     <a:lstStyle/>
                     <a:p>
-                      <a:pPr indent="0" marL="0">
+                      <a:pPr marL="0" indent="0">
                         <a:buNone/>
                       </a:pPr>
                       <a:r>
@@ -10895,6 +10794,11 @@
                     </a:solidFill>
                   </a:tcPr>
                 </a:tc>
+                <a:extLst>
+                  <a:ext uri="{0D108BD9-81ED-4DB2-BD59-A6C34878D82A}">
+                    <a16:rowId xmlns:a16="http://schemas.microsoft.com/office/drawing/2014/main" val="10004"/>
+                  </a:ext>
+                </a:extLst>
               </a:tr>
             </a:tbl>
           </a:graphicData>
@@ -10948,7 +10852,7 @@
           <a:bodyPr wrap="square" lIns="0" tIns="0" rIns="0" bIns="0" rtlCol="0" anchor="t"/>
           <a:lstStyle/>
           <a:p>
-            <a:pPr indent="0" marL="0">
+            <a:pPr marL="0" indent="0">
               <a:spcAft>
                 <a:spcPts val="800"/>
               </a:spcAft>
@@ -10965,7 +10869,7 @@
             <a:endParaRPr lang="en-US" sz="1400" dirty="0"/>
           </a:p>
           <a:p>
-            <a:pPr indent="0" marL="0">
+            <a:pPr marL="0" indent="0">
               <a:spcAft>
                 <a:spcPts val="800"/>
               </a:spcAft>
@@ -11006,7 +10910,7 @@
           </a:prstGeom>
           <a:extLst>
             <a:ext uri="{C572A759-6A51-4108-AA02-DFA0A04FC94B}">
-              <ma14:wrappingTextBoxFlag xmlns:ma14="http://schemas.microsoft.com/office/mac/drawingml/2011/main" val="0"/>
+              <ma14:wrappingTextBoxFlag xmlns:ma14="http://schemas.microsoft.com/office/mac/drawingml/2011/main" xmlns="" val="0"/>
             </a:ext>
           </a:extLst>
         </p:spPr>
@@ -11024,7 +10928,7 @@
           <a:p>
             <a:pPr algn="r"/>
             <a:fld id="{F7021451-1387-4CA6-816F-3879F97B5CBC}" type="slidenum">
-              <a:rPr b="0" lang="en-US"/>
+              <a:rPr lang="en-US" b="0"/>
               <a:t>4</a:t>
             </a:fld>
             <a:endParaRPr lang="en-US"/>
@@ -11059,9 +10963,11 @@
       <p:sp>
         <p:nvSpPr>
           <p:cNvPr id="2" name="Text 0"/>
-          <p:cNvSpPr/>
+          <p:cNvSpPr>
+            <a:spLocks noGrp="1"/>
+          </p:cNvSpPr>
           <p:nvPr>
-            <p:ph idx="100" type="title" hasCustomPrompt="1"/>
+            <p:ph type="title" idx="100" hasCustomPrompt="1"/>
           </p:nvPr>
         </p:nvSpPr>
         <p:spPr>
@@ -11079,7 +10985,7 @@
           <a:bodyPr wrap="square" lIns="0" tIns="0" rIns="0" bIns="0" rtlCol="0" anchor="ctr"/>
           <a:lstStyle/>
           <a:p>
-            <a:pPr indent="0" marL="0">
+            <a:pPr marL="0" indent="0">
               <a:buNone/>
             </a:pPr>
             <a:r>
@@ -11110,17 +11016,41 @@
         </p:nvGraphicFramePr>
         <p:xfrm>
           <a:off x="548640" y="1371600"/>
-          <a:ext cx="7863840" cy="914400"/>
+          <a:ext cx="7863840" cy="4279392"/>
         </p:xfrm>
         <a:graphic>
           <a:graphicData uri="http://schemas.openxmlformats.org/drawingml/2006/table">
             <a:tbl>
               <a:tblPr/>
               <a:tblGrid>
-                <a:gridCol w="822960"/>
-                <a:gridCol w="2651760"/>
-                <a:gridCol w="1554480"/>
-                <a:gridCol w="2834640"/>
+                <a:gridCol w="822960">
+                  <a:extLst>
+                    <a:ext uri="{9D8B030D-6E8A-4147-A177-3AD203B41FA5}">
+                      <a16:colId xmlns:a16="http://schemas.microsoft.com/office/drawing/2014/main" val="20000"/>
+                    </a:ext>
+                  </a:extLst>
+                </a:gridCol>
+                <a:gridCol w="2651760">
+                  <a:extLst>
+                    <a:ext uri="{9D8B030D-6E8A-4147-A177-3AD203B41FA5}">
+                      <a16:colId xmlns:a16="http://schemas.microsoft.com/office/drawing/2014/main" val="20001"/>
+                    </a:ext>
+                  </a:extLst>
+                </a:gridCol>
+                <a:gridCol w="1554480">
+                  <a:extLst>
+                    <a:ext uri="{9D8B030D-6E8A-4147-A177-3AD203B41FA5}">
+                      <a16:colId xmlns:a16="http://schemas.microsoft.com/office/drawing/2014/main" val="20002"/>
+                    </a:ext>
+                  </a:extLst>
+                </a:gridCol>
+                <a:gridCol w="2834640">
+                  <a:extLst>
+                    <a:ext uri="{9D8B030D-6E8A-4147-A177-3AD203B41FA5}">
+                      <a16:colId xmlns:a16="http://schemas.microsoft.com/office/drawing/2014/main" val="20003"/>
+                    </a:ext>
+                  </a:extLst>
+                </a:gridCol>
               </a:tblGrid>
               <a:tr h="475488">
                 <a:tc>
@@ -11128,7 +11058,7 @@
                     <a:bodyPr/>
                     <a:lstStyle/>
                     <a:p>
-                      <a:pPr indent="0" marL="0">
+                      <a:pPr marL="0" indent="0">
                         <a:buNone/>
                       </a:pPr>
                       <a:r>
@@ -11189,7 +11119,7 @@
                     <a:bodyPr/>
                     <a:lstStyle/>
                     <a:p>
-                      <a:pPr indent="0" marL="0">
+                      <a:pPr marL="0" indent="0">
                         <a:buNone/>
                       </a:pPr>
                       <a:r>
@@ -11250,7 +11180,7 @@
                     <a:bodyPr/>
                     <a:lstStyle/>
                     <a:p>
-                      <a:pPr indent="0" marL="0">
+                      <a:pPr marL="0" indent="0">
                         <a:buNone/>
                       </a:pPr>
                       <a:r>
@@ -11311,7 +11241,7 @@
                     <a:bodyPr/>
                     <a:lstStyle/>
                     <a:p>
-                      <a:pPr indent="0" marL="0">
+                      <a:pPr marL="0" indent="0">
                         <a:buNone/>
                       </a:pPr>
                       <a:r>
@@ -11367,6 +11297,11 @@
                     </a:solidFill>
                   </a:tcPr>
                 </a:tc>
+                <a:extLst>
+                  <a:ext uri="{0D108BD9-81ED-4DB2-BD59-A6C34878D82A}">
+                    <a16:rowId xmlns:a16="http://schemas.microsoft.com/office/drawing/2014/main" val="10000"/>
+                  </a:ext>
+                </a:extLst>
               </a:tr>
               <a:tr h="475488">
                 <a:tc>
@@ -11374,7 +11309,7 @@
                     <a:bodyPr/>
                     <a:lstStyle/>
                     <a:p>
-                      <a:pPr indent="0" marL="0">
+                      <a:pPr marL="0" indent="0">
                         <a:buNone/>
                       </a:pPr>
                       <a:r>
@@ -11435,7 +11370,7 @@
                     <a:bodyPr/>
                     <a:lstStyle/>
                     <a:p>
-                      <a:pPr indent="0" marL="0">
+                      <a:pPr marL="0" indent="0">
                         <a:buNone/>
                       </a:pPr>
                       <a:r>
@@ -11496,7 +11431,7 @@
                     <a:bodyPr/>
                     <a:lstStyle/>
                     <a:p>
-                      <a:pPr indent="0" marL="0">
+                      <a:pPr marL="0" indent="0">
                         <a:buNone/>
                       </a:pPr>
                       <a:r>
@@ -11557,7 +11492,7 @@
                     <a:bodyPr/>
                     <a:lstStyle/>
                     <a:p>
-                      <a:pPr indent="0" marL="0">
+                      <a:pPr marL="0" indent="0">
                         <a:buNone/>
                       </a:pPr>
                       <a:r>
@@ -11613,6 +11548,11 @@
                     </a:solidFill>
                   </a:tcPr>
                 </a:tc>
+                <a:extLst>
+                  <a:ext uri="{0D108BD9-81ED-4DB2-BD59-A6C34878D82A}">
+                    <a16:rowId xmlns:a16="http://schemas.microsoft.com/office/drawing/2014/main" val="10001"/>
+                  </a:ext>
+                </a:extLst>
               </a:tr>
               <a:tr h="475488">
                 <a:tc>
@@ -11620,7 +11560,7 @@
                     <a:bodyPr/>
                     <a:lstStyle/>
                     <a:p>
-                      <a:pPr indent="0" marL="0">
+                      <a:pPr marL="0" indent="0">
                         <a:buNone/>
                       </a:pPr>
                       <a:r>
@@ -11681,7 +11621,7 @@
                     <a:bodyPr/>
                     <a:lstStyle/>
                     <a:p>
-                      <a:pPr indent="0" marL="0">
+                      <a:pPr marL="0" indent="0">
                         <a:buNone/>
                       </a:pPr>
                       <a:r>
@@ -11742,7 +11682,7 @@
                     <a:bodyPr/>
                     <a:lstStyle/>
                     <a:p>
-                      <a:pPr indent="0" marL="0">
+                      <a:pPr marL="0" indent="0">
                         <a:buNone/>
                       </a:pPr>
                       <a:r>
@@ -11803,7 +11743,7 @@
                     <a:bodyPr/>
                     <a:lstStyle/>
                     <a:p>
-                      <a:pPr indent="0" marL="0">
+                      <a:pPr marL="0" indent="0">
                         <a:buNone/>
                       </a:pPr>
                       <a:r>
@@ -11859,6 +11799,11 @@
                     </a:solidFill>
                   </a:tcPr>
                 </a:tc>
+                <a:extLst>
+                  <a:ext uri="{0D108BD9-81ED-4DB2-BD59-A6C34878D82A}">
+                    <a16:rowId xmlns:a16="http://schemas.microsoft.com/office/drawing/2014/main" val="10002"/>
+                  </a:ext>
+                </a:extLst>
               </a:tr>
               <a:tr h="475488">
                 <a:tc>
@@ -11866,7 +11811,7 @@
                     <a:bodyPr/>
                     <a:lstStyle/>
                     <a:p>
-                      <a:pPr indent="0" marL="0">
+                      <a:pPr marL="0" indent="0">
                         <a:buNone/>
                       </a:pPr>
                       <a:r>
@@ -11927,7 +11872,7 @@
                     <a:bodyPr/>
                     <a:lstStyle/>
                     <a:p>
-                      <a:pPr indent="0" marL="0">
+                      <a:pPr marL="0" indent="0">
                         <a:buNone/>
                       </a:pPr>
                       <a:r>
@@ -11988,7 +11933,7 @@
                     <a:bodyPr/>
                     <a:lstStyle/>
                     <a:p>
-                      <a:pPr indent="0" marL="0">
+                      <a:pPr marL="0" indent="0">
                         <a:buNone/>
                       </a:pPr>
                       <a:r>
@@ -12049,7 +11994,7 @@
                     <a:bodyPr/>
                     <a:lstStyle/>
                     <a:p>
-                      <a:pPr indent="0" marL="0">
+                      <a:pPr marL="0" indent="0">
                         <a:buNone/>
                       </a:pPr>
                       <a:r>
@@ -12105,6 +12050,11 @@
                     </a:solidFill>
                   </a:tcPr>
                 </a:tc>
+                <a:extLst>
+                  <a:ext uri="{0D108BD9-81ED-4DB2-BD59-A6C34878D82A}">
+                    <a16:rowId xmlns:a16="http://schemas.microsoft.com/office/drawing/2014/main" val="10003"/>
+                  </a:ext>
+                </a:extLst>
               </a:tr>
               <a:tr h="475488">
                 <a:tc>
@@ -12112,7 +12062,7 @@
                     <a:bodyPr/>
                     <a:lstStyle/>
                     <a:p>
-                      <a:pPr indent="0" marL="0">
+                      <a:pPr marL="0" indent="0">
                         <a:buNone/>
                       </a:pPr>
                       <a:r>
@@ -12173,7 +12123,7 @@
                     <a:bodyPr/>
                     <a:lstStyle/>
                     <a:p>
-                      <a:pPr indent="0" marL="0">
+                      <a:pPr marL="0" indent="0">
                         <a:buNone/>
                       </a:pPr>
                       <a:r>
@@ -12234,7 +12184,7 @@
                     <a:bodyPr/>
                     <a:lstStyle/>
                     <a:p>
-                      <a:pPr indent="0" marL="0">
+                      <a:pPr marL="0" indent="0">
                         <a:buNone/>
                       </a:pPr>
                       <a:r>
@@ -12295,7 +12245,7 @@
                     <a:bodyPr/>
                     <a:lstStyle/>
                     <a:p>
-                      <a:pPr indent="0" marL="0">
+                      <a:pPr marL="0" indent="0">
                         <a:buNone/>
                       </a:pPr>
                       <a:r>
@@ -12351,6 +12301,11 @@
                     </a:solidFill>
                   </a:tcPr>
                 </a:tc>
+                <a:extLst>
+                  <a:ext uri="{0D108BD9-81ED-4DB2-BD59-A6C34878D82A}">
+                    <a16:rowId xmlns:a16="http://schemas.microsoft.com/office/drawing/2014/main" val="10004"/>
+                  </a:ext>
+                </a:extLst>
               </a:tr>
               <a:tr h="475488">
                 <a:tc>
@@ -12358,7 +12313,7 @@
                     <a:bodyPr/>
                     <a:lstStyle/>
                     <a:p>
-                      <a:pPr indent="0" marL="0">
+                      <a:pPr marL="0" indent="0">
                         <a:buNone/>
                       </a:pPr>
                       <a:r>
@@ -12419,7 +12374,7 @@
                     <a:bodyPr/>
                     <a:lstStyle/>
                     <a:p>
-                      <a:pPr indent="0" marL="0">
+                      <a:pPr marL="0" indent="0">
                         <a:buNone/>
                       </a:pPr>
                       <a:r>
@@ -12480,7 +12435,7 @@
                     <a:bodyPr/>
                     <a:lstStyle/>
                     <a:p>
-                      <a:pPr indent="0" marL="0">
+                      <a:pPr marL="0" indent="0">
                         <a:buNone/>
                       </a:pPr>
                       <a:r>
@@ -12541,7 +12496,7 @@
                     <a:bodyPr/>
                     <a:lstStyle/>
                     <a:p>
-                      <a:pPr indent="0" marL="0">
+                      <a:pPr marL="0" indent="0">
                         <a:buNone/>
                       </a:pPr>
                       <a:r>
@@ -12597,6 +12552,11 @@
                     </a:solidFill>
                   </a:tcPr>
                 </a:tc>
+                <a:extLst>
+                  <a:ext uri="{0D108BD9-81ED-4DB2-BD59-A6C34878D82A}">
+                    <a16:rowId xmlns:a16="http://schemas.microsoft.com/office/drawing/2014/main" val="10005"/>
+                  </a:ext>
+                </a:extLst>
               </a:tr>
               <a:tr h="475488">
                 <a:tc>
@@ -12604,7 +12564,7 @@
                     <a:bodyPr/>
                     <a:lstStyle/>
                     <a:p>
-                      <a:pPr indent="0" marL="0">
+                      <a:pPr marL="0" indent="0">
                         <a:buNone/>
                       </a:pPr>
                       <a:r>
@@ -12665,7 +12625,7 @@
                     <a:bodyPr/>
                     <a:lstStyle/>
                     <a:p>
-                      <a:pPr indent="0" marL="0">
+                      <a:pPr marL="0" indent="0">
                         <a:buNone/>
                       </a:pPr>
                       <a:r>
@@ -12726,7 +12686,7 @@
                     <a:bodyPr/>
                     <a:lstStyle/>
                     <a:p>
-                      <a:pPr indent="0" marL="0">
+                      <a:pPr marL="0" indent="0">
                         <a:buNone/>
                       </a:pPr>
                       <a:r>
@@ -12787,7 +12747,7 @@
                     <a:bodyPr/>
                     <a:lstStyle/>
                     <a:p>
-                      <a:pPr indent="0" marL="0">
+                      <a:pPr marL="0" indent="0">
                         <a:buNone/>
                       </a:pPr>
                       <a:r>
@@ -12843,6 +12803,11 @@
                     </a:solidFill>
                   </a:tcPr>
                 </a:tc>
+                <a:extLst>
+                  <a:ext uri="{0D108BD9-81ED-4DB2-BD59-A6C34878D82A}">
+                    <a16:rowId xmlns:a16="http://schemas.microsoft.com/office/drawing/2014/main" val="10006"/>
+                  </a:ext>
+                </a:extLst>
               </a:tr>
               <a:tr h="475488">
                 <a:tc>
@@ -12850,7 +12815,7 @@
                     <a:bodyPr/>
                     <a:lstStyle/>
                     <a:p>
-                      <a:pPr indent="0" marL="0">
+                      <a:pPr marL="0" indent="0">
                         <a:buNone/>
                       </a:pPr>
                       <a:r>
@@ -12911,7 +12876,7 @@
                     <a:bodyPr/>
                     <a:lstStyle/>
                     <a:p>
-                      <a:pPr indent="0" marL="0">
+                      <a:pPr marL="0" indent="0">
                         <a:buNone/>
                       </a:pPr>
                       <a:r>
@@ -12972,7 +12937,7 @@
                     <a:bodyPr/>
                     <a:lstStyle/>
                     <a:p>
-                      <a:pPr indent="0" marL="0">
+                      <a:pPr marL="0" indent="0">
                         <a:buNone/>
                       </a:pPr>
                       <a:r>
@@ -13033,7 +12998,7 @@
                     <a:bodyPr/>
                     <a:lstStyle/>
                     <a:p>
-                      <a:pPr indent="0" marL="0">
+                      <a:pPr marL="0" indent="0">
                         <a:buNone/>
                       </a:pPr>
                       <a:r>
@@ -13089,6 +13054,11 @@
                     </a:solidFill>
                   </a:tcPr>
                 </a:tc>
+                <a:extLst>
+                  <a:ext uri="{0D108BD9-81ED-4DB2-BD59-A6C34878D82A}">
+                    <a16:rowId xmlns:a16="http://schemas.microsoft.com/office/drawing/2014/main" val="10007"/>
+                  </a:ext>
+                </a:extLst>
               </a:tr>
               <a:tr h="475488">
                 <a:tc>
@@ -13096,7 +13066,7 @@
                     <a:bodyPr/>
                     <a:lstStyle/>
                     <a:p>
-                      <a:pPr indent="0" marL="0">
+                      <a:pPr marL="0" indent="0">
                         <a:buNone/>
                       </a:pPr>
                       <a:r>
@@ -13157,7 +13127,7 @@
                     <a:bodyPr/>
                     <a:lstStyle/>
                     <a:p>
-                      <a:pPr indent="0" marL="0">
+                      <a:pPr marL="0" indent="0">
                         <a:buNone/>
                       </a:pPr>
                       <a:r>
@@ -13218,7 +13188,7 @@
                     <a:bodyPr/>
                     <a:lstStyle/>
                     <a:p>
-                      <a:pPr indent="0" marL="0">
+                      <a:pPr marL="0" indent="0">
                         <a:buNone/>
                       </a:pPr>
                       <a:r>
@@ -13279,7 +13249,7 @@
                     <a:bodyPr/>
                     <a:lstStyle/>
                     <a:p>
-                      <a:pPr indent="0" marL="0">
+                      <a:pPr marL="0" indent="0">
                         <a:buNone/>
                       </a:pPr>
                       <a:r>
@@ -13335,6 +13305,11 @@
                     </a:solidFill>
                   </a:tcPr>
                 </a:tc>
+                <a:extLst>
+                  <a:ext uri="{0D108BD9-81ED-4DB2-BD59-A6C34878D82A}">
+                    <a16:rowId xmlns:a16="http://schemas.microsoft.com/office/drawing/2014/main" val="10008"/>
+                  </a:ext>
+                </a:extLst>
               </a:tr>
             </a:tbl>
           </a:graphicData>
@@ -13369,7 +13344,7 @@
       </p:sp>
       <p:sp>
         <p:nvSpPr>
-          <p:cNvPr id="6" name="texte-61"/>
+          <p:cNvPr id="3" name="texte-61"/>
           <p:cNvSpPr txBox="1"/>
           <p:nvPr/>
         </p:nvSpPr>
@@ -13388,7 +13363,7 @@
           <a:bodyPr wrap="square" lIns="0" tIns="0" rIns="0" bIns="0" rtlCol="0" anchor="t"/>
           <a:lstStyle/>
           <a:p>
-            <a:pPr indent="0" marL="0">
+            <a:pPr marL="0" indent="0">
               <a:spcAft>
                 <a:spcPts val="600"/>
               </a:spcAft>
@@ -13405,7 +13380,7 @@
             <a:endParaRPr lang="en-US" sz="1400" dirty="0"/>
           </a:p>
           <a:p>
-            <a:pPr indent="0" marL="0">
+            <a:pPr marL="0" indent="0">
               <a:spcAft>
                 <a:spcPts val="600"/>
               </a:spcAft>
@@ -13422,7 +13397,7 @@
             <a:endParaRPr lang="en-US" sz="1400" dirty="0"/>
           </a:p>
           <a:p>
-            <a:pPr indent="0" marL="0">
+            <a:pPr marL="0" indent="0">
               <a:spcAft>
                 <a:spcPts val="600"/>
               </a:spcAft>
@@ -13439,7 +13414,7 @@
             <a:endParaRPr lang="en-US" sz="1400" dirty="0"/>
           </a:p>
           <a:p>
-            <a:pPr indent="0" marL="0">
+            <a:pPr marL="0" indent="0">
               <a:spcAft>
                 <a:spcPts val="600"/>
               </a:spcAft>
@@ -13456,7 +13431,7 @@
             <a:endParaRPr lang="en-US" sz="1400" dirty="0"/>
           </a:p>
           <a:p>
-            <a:pPr indent="0" marL="0">
+            <a:pPr marL="0" indent="0">
               <a:spcAft>
                 <a:spcPts val="600"/>
               </a:spcAft>
@@ -13494,7 +13469,7 @@
           </a:prstGeom>
           <a:extLst>
             <a:ext uri="{C572A759-6A51-4108-AA02-DFA0A04FC94B}">
-              <ma14:wrappingTextBoxFlag xmlns:ma14="http://schemas.microsoft.com/office/mac/drawingml/2011/main" val="0"/>
+              <ma14:wrappingTextBoxFlag xmlns:ma14="http://schemas.microsoft.com/office/mac/drawingml/2011/main" xmlns="" val="0"/>
             </a:ext>
           </a:extLst>
         </p:spPr>
@@ -13512,7 +13487,7 @@
           <a:p>
             <a:pPr algn="r"/>
             <a:fld id="{F7021451-1387-4CA6-816F-3879F97B5CBC}" type="slidenum">
-              <a:rPr b="0" lang="en-US"/>
+              <a:rPr lang="en-US" b="0"/>
               <a:t>5</a:t>
             </a:fld>
             <a:endParaRPr lang="en-US"/>
@@ -13547,9 +13522,11 @@
       <p:sp>
         <p:nvSpPr>
           <p:cNvPr id="2" name="Text 0"/>
-          <p:cNvSpPr/>
+          <p:cNvSpPr>
+            <a:spLocks noGrp="1"/>
+          </p:cNvSpPr>
           <p:nvPr>
-            <p:ph idx="100" type="title" hasCustomPrompt="1"/>
+            <p:ph type="title" idx="100" hasCustomPrompt="1"/>
           </p:nvPr>
         </p:nvSpPr>
         <p:spPr>
@@ -13567,7 +13544,7 @@
           <a:bodyPr wrap="square" lIns="0" tIns="0" rIns="0" bIns="0" rtlCol="0" anchor="ctr"/>
           <a:lstStyle/>
           <a:p>
-            <a:pPr indent="0" marL="0">
+            <a:pPr marL="0" indent="0">
               <a:buNone/>
             </a:pPr>
             <a:r>
@@ -13655,7 +13632,7 @@
           <a:bodyPr wrap="square" lIns="0" tIns="0" rIns="0" bIns="0" rtlCol="0" anchor="ctr"/>
           <a:lstStyle/>
           <a:p>
-            <a:pPr algn="ctr" indent="0" marL="0">
+            <a:pPr marL="0" indent="0" algn="ctr">
               <a:buNone/>
             </a:pPr>
             <a:r>
@@ -13691,7 +13668,7 @@
           <a:bodyPr wrap="square" lIns="0" tIns="0" rIns="0" bIns="0" rtlCol="0" anchor="t"/>
           <a:lstStyle/>
           <a:p>
-            <a:pPr indent="0" marL="0">
+            <a:pPr marL="0" indent="0">
               <a:buNone/>
             </a:pPr>
             <a:r>
@@ -13727,7 +13704,7 @@
           <a:bodyPr wrap="square" lIns="0" tIns="0" rIns="0" bIns="0" rtlCol="0" anchor="t"/>
           <a:lstStyle/>
           <a:p>
-            <a:pPr indent="0" marL="0">
+            <a:pPr marL="0" indent="0">
               <a:buNone/>
             </a:pPr>
             <a:r>
@@ -13839,7 +13816,7 @@
           <a:bodyPr wrap="square" lIns="0" tIns="0" rIns="0" bIns="0" rtlCol="0" anchor="ctr"/>
           <a:lstStyle/>
           <a:p>
-            <a:pPr algn="ctr" indent="0" marL="0">
+            <a:pPr marL="0" indent="0" algn="ctr">
               <a:buNone/>
             </a:pPr>
             <a:r>
@@ -13875,7 +13852,7 @@
           <a:bodyPr wrap="square" lIns="0" tIns="0" rIns="0" bIns="0" rtlCol="0" anchor="t"/>
           <a:lstStyle/>
           <a:p>
-            <a:pPr indent="0" marL="0">
+            <a:pPr marL="0" indent="0">
               <a:buNone/>
             </a:pPr>
             <a:r>
@@ -13911,7 +13888,7 @@
           <a:bodyPr wrap="square" lIns="0" tIns="0" rIns="0" bIns="0" rtlCol="0" anchor="t"/>
           <a:lstStyle/>
           <a:p>
-            <a:pPr indent="0" marL="0">
+            <a:pPr marL="0" indent="0">
               <a:buNone/>
             </a:pPr>
             <a:r>
@@ -14023,7 +14000,7 @@
           <a:bodyPr wrap="square" lIns="0" tIns="0" rIns="0" bIns="0" rtlCol="0" anchor="ctr"/>
           <a:lstStyle/>
           <a:p>
-            <a:pPr algn="ctr" indent="0" marL="0">
+            <a:pPr marL="0" indent="0" algn="ctr">
               <a:buNone/>
             </a:pPr>
             <a:r>
@@ -14059,7 +14036,7 @@
           <a:bodyPr wrap="square" lIns="0" tIns="0" rIns="0" bIns="0" rtlCol="0" anchor="t"/>
           <a:lstStyle/>
           <a:p>
-            <a:pPr indent="0" marL="0">
+            <a:pPr marL="0" indent="0">
               <a:buNone/>
             </a:pPr>
             <a:r>
@@ -14095,7 +14072,7 @@
           <a:bodyPr wrap="square" lIns="0" tIns="0" rIns="0" bIns="0" rtlCol="0" anchor="t"/>
           <a:lstStyle/>
           <a:p>
-            <a:pPr indent="0" marL="0">
+            <a:pPr marL="0" indent="0">
               <a:buNone/>
             </a:pPr>
             <a:r>
@@ -14207,7 +14184,7 @@
           <a:bodyPr wrap="square" lIns="0" tIns="0" rIns="0" bIns="0" rtlCol="0" anchor="ctr"/>
           <a:lstStyle/>
           <a:p>
-            <a:pPr algn="ctr" indent="0" marL="0">
+            <a:pPr marL="0" indent="0" algn="ctr">
               <a:buNone/>
             </a:pPr>
             <a:r>
@@ -14243,7 +14220,7 @@
           <a:bodyPr wrap="square" lIns="0" tIns="0" rIns="0" bIns="0" rtlCol="0" anchor="t"/>
           <a:lstStyle/>
           <a:p>
-            <a:pPr indent="0" marL="0">
+            <a:pPr marL="0" indent="0">
               <a:buNone/>
             </a:pPr>
             <a:r>
@@ -14279,7 +14256,7 @@
           <a:bodyPr wrap="square" lIns="0" tIns="0" rIns="0" bIns="0" rtlCol="0" anchor="t"/>
           <a:lstStyle/>
           <a:p>
-            <a:pPr indent="0" marL="0">
+            <a:pPr marL="0" indent="0">
               <a:buNone/>
             </a:pPr>
             <a:r>
@@ -14315,7 +14292,7 @@
           <a:bodyPr wrap="square" lIns="0" tIns="0" rIns="0" bIns="0" rtlCol="0" anchor="t"/>
           <a:lstStyle/>
           <a:p>
-            <a:pPr indent="0" marL="0">
+            <a:pPr marL="0" indent="0">
               <a:buNone/>
             </a:pPr>
             <a:r>
@@ -14354,7 +14331,7 @@
           <a:bodyPr wrap="square" lIns="0" tIns="0" rIns="0" bIns="0" rtlCol="0" anchor="t"/>
           <a:lstStyle/>
           <a:p>
-            <a:pPr indent="0" marL="0">
+            <a:pPr marL="0" indent="0">
               <a:buNone/>
             </a:pPr>
             <a:r>
@@ -14390,7 +14367,7 @@
           <a:bodyPr wrap="square" lIns="0" tIns="0" rIns="0" bIns="0" rtlCol="0" anchor="t"/>
           <a:lstStyle/>
           <a:p>
-            <a:pPr indent="0" marL="0">
+            <a:pPr marL="0" indent="0">
               <a:buNone/>
             </a:pPr>
             <a:r>
@@ -14429,7 +14406,7 @@
           <a:bodyPr wrap="square" lIns="0" tIns="0" rIns="0" bIns="0" rtlCol="0" anchor="t"/>
           <a:lstStyle/>
           <a:p>
-            <a:pPr indent="0" marL="0">
+            <a:pPr marL="0" indent="0">
               <a:buNone/>
             </a:pPr>
             <a:r>
@@ -14465,7 +14442,7 @@
           <a:bodyPr wrap="square" lIns="0" tIns="0" rIns="0" bIns="0" rtlCol="0" anchor="t"/>
           <a:lstStyle/>
           <a:p>
-            <a:pPr indent="0" marL="0">
+            <a:pPr marL="0" indent="0">
               <a:buNone/>
             </a:pPr>
             <a:r>
@@ -14504,7 +14481,7 @@
           <a:bodyPr wrap="square" lIns="0" tIns="0" rIns="0" bIns="0" rtlCol="0" anchor="t"/>
           <a:lstStyle/>
           <a:p>
-            <a:pPr indent="0" marL="0">
+            <a:pPr marL="0" indent="0">
               <a:buNone/>
             </a:pPr>
             <a:r>
@@ -14540,7 +14517,7 @@
           <a:bodyPr wrap="square" lIns="0" tIns="0" rIns="0" bIns="0" rtlCol="0" anchor="t"/>
           <a:lstStyle/>
           <a:p>
-            <a:pPr indent="0" marL="0">
+            <a:pPr marL="0" indent="0">
               <a:buNone/>
             </a:pPr>
             <a:r>
@@ -14579,7 +14556,7 @@
           <a:bodyPr wrap="square" lIns="0" tIns="0" rIns="0" bIns="0" rtlCol="0" anchor="t"/>
           <a:lstStyle/>
           <a:p>
-            <a:pPr indent="0" marL="0">
+            <a:pPr marL="0" indent="0">
               <a:buNone/>
             </a:pPr>
             <a:r>
@@ -14596,7 +14573,7 @@
       </p:sp>
       <p:sp>
         <p:nvSpPr>
-          <p:cNvPr id="25" name="Slide Number Placeholder 0"/>
+          <p:cNvPr id="3" name="Slide Number Placeholder 0"/>
           <p:cNvSpPr>
             <a:spLocks noGrp="1"/>
           </p:cNvSpPr>
@@ -14614,7 +14591,7 @@
           </a:prstGeom>
           <a:extLst>
             <a:ext uri="{C572A759-6A51-4108-AA02-DFA0A04FC94B}">
-              <ma14:wrappingTextBoxFlag xmlns:ma14="http://schemas.microsoft.com/office/mac/drawingml/2011/main" val="0"/>
+              <ma14:wrappingTextBoxFlag xmlns:ma14="http://schemas.microsoft.com/office/mac/drawingml/2011/main" xmlns="" val="0"/>
             </a:ext>
           </a:extLst>
         </p:spPr>
@@ -14632,7 +14609,7 @@
           <a:p>
             <a:pPr algn="r"/>
             <a:fld id="{F7021451-1387-4CA6-816F-3879F97B5CBC}" type="slidenum">
-              <a:rPr b="0" lang="en-US"/>
+              <a:rPr lang="en-US" b="0"/>
               <a:t>6</a:t>
             </a:fld>
             <a:endParaRPr lang="en-US"/>
@@ -14667,9 +14644,11 @@
       <p:sp>
         <p:nvSpPr>
           <p:cNvPr id="2" name="Text 0"/>
-          <p:cNvSpPr/>
+          <p:cNvSpPr>
+            <a:spLocks noGrp="1"/>
+          </p:cNvSpPr>
           <p:nvPr>
-            <p:ph idx="100" type="title" hasCustomPrompt="1"/>
+            <p:ph type="title" idx="100" hasCustomPrompt="1"/>
           </p:nvPr>
         </p:nvSpPr>
         <p:spPr>
@@ -14687,7 +14666,7 @@
           <a:bodyPr wrap="square" lIns="0" tIns="0" rIns="0" bIns="0" rtlCol="0" anchor="ctr"/>
           <a:lstStyle/>
           <a:p>
-            <a:pPr indent="0" marL="0">
+            <a:pPr marL="0" indent="0">
               <a:buNone/>
             </a:pPr>
             <a:r>
@@ -14750,7 +14729,7 @@
           <a:bodyPr wrap="square" lIns="1016" tIns="1016" rIns="1016" bIns="1016" rtlCol="0" anchor="ctr"/>
           <a:lstStyle/>
           <a:p>
-            <a:pPr algn="ctr" indent="0" marL="0">
+            <a:pPr marL="0" indent="0" algn="ctr">
               <a:buNone/>
             </a:pPr>
             <a:r>
@@ -14764,7 +14743,7 @@
             <a:endParaRPr lang="en-US" sz="1600" dirty="0"/>
           </a:p>
           <a:p>
-            <a:pPr algn="ctr" indent="0" marL="0">
+            <a:pPr marL="0" indent="0" algn="ctr">
               <a:buNone/>
             </a:pPr>
             <a:r>
@@ -14827,7 +14806,7 @@
           <a:bodyPr wrap="square" lIns="1016" tIns="1016" rIns="1016" bIns="1016" rtlCol="0" anchor="ctr"/>
           <a:lstStyle/>
           <a:p>
-            <a:pPr algn="ctr" indent="0" marL="0">
+            <a:pPr marL="0" indent="0" algn="ctr">
               <a:buNone/>
             </a:pPr>
             <a:r>
@@ -14841,7 +14820,7 @@
             <a:endParaRPr lang="en-US" sz="1600" dirty="0"/>
           </a:p>
           <a:p>
-            <a:pPr algn="ctr" indent="0" marL="0">
+            <a:pPr marL="0" indent="0" algn="ctr">
               <a:buNone/>
             </a:pPr>
             <a:r>
@@ -14904,7 +14883,7 @@
           <a:bodyPr wrap="square" lIns="1016" tIns="1016" rIns="1016" bIns="1016" rtlCol="0" anchor="ctr"/>
           <a:lstStyle/>
           <a:p>
-            <a:pPr algn="ctr" indent="0" marL="0">
+            <a:pPr marL="0" indent="0" algn="ctr">
               <a:buNone/>
             </a:pPr>
             <a:r>
@@ -14918,7 +14897,7 @@
             <a:endParaRPr lang="en-US" sz="1600" dirty="0"/>
           </a:p>
           <a:p>
-            <a:pPr algn="ctr" indent="0" marL="0">
+            <a:pPr marL="0" indent="0" algn="ctr">
               <a:buNone/>
             </a:pPr>
             <a:r>
@@ -14981,7 +14960,7 @@
           <a:bodyPr wrap="square" lIns="1016" tIns="1016" rIns="1016" bIns="1016" rtlCol="0" anchor="ctr"/>
           <a:lstStyle/>
           <a:p>
-            <a:pPr algn="ctr" indent="0" marL="0">
+            <a:pPr marL="0" indent="0" algn="ctr">
               <a:buNone/>
             </a:pPr>
             <a:r>
@@ -14995,7 +14974,7 @@
             <a:endParaRPr lang="en-US" sz="1600" dirty="0"/>
           </a:p>
           <a:p>
-            <a:pPr algn="ctr" indent="0" marL="0">
+            <a:pPr marL="0" indent="0" algn="ctr">
               <a:buNone/>
             </a:pPr>
             <a:r>
@@ -15058,7 +15037,7 @@
           <a:bodyPr wrap="square" lIns="1016" tIns="1016" rIns="1016" bIns="1016" rtlCol="0" anchor="ctr"/>
           <a:lstStyle/>
           <a:p>
-            <a:pPr algn="ctr" indent="0" marL="0">
+            <a:pPr marL="0" indent="0" algn="ctr">
               <a:buNone/>
             </a:pPr>
             <a:r>
@@ -15072,7 +15051,7 @@
             <a:endParaRPr lang="en-US" sz="1600" dirty="0"/>
           </a:p>
           <a:p>
-            <a:pPr algn="ctr" indent="0" marL="0">
+            <a:pPr marL="0" indent="0" algn="ctr">
               <a:buNone/>
             </a:pPr>
             <a:r>
@@ -15180,7 +15159,7 @@
           <a:bodyPr wrap="square" lIns="0" tIns="0" rIns="0" bIns="0" rtlCol="0" anchor="t"/>
           <a:lstStyle/>
           <a:p>
-            <a:pPr algn="ctr" indent="0" marL="0">
+            <a:pPr marL="0" indent="0" algn="ctr">
               <a:buNone/>
             </a:pPr>
             <a:r>
@@ -15216,7 +15195,7 @@
           <a:bodyPr wrap="square" lIns="0" tIns="0" rIns="0" bIns="0" rtlCol="0" anchor="t"/>
           <a:lstStyle/>
           <a:p>
-            <a:pPr algn="ctr" indent="0" marL="0">
+            <a:pPr marL="0" indent="0" algn="ctr">
               <a:buNone/>
             </a:pPr>
             <a:r>
@@ -15252,7 +15231,7 @@
           <a:bodyPr wrap="square" lIns="0" tIns="0" rIns="0" bIns="0" rtlCol="0" anchor="t"/>
           <a:lstStyle/>
           <a:p>
-            <a:pPr algn="ctr" indent="0" marL="0">
+            <a:pPr marL="0" indent="0" algn="ctr">
               <a:buNone/>
             </a:pPr>
             <a:r>
@@ -15336,7 +15315,7 @@
           <a:bodyPr wrap="square" lIns="0" tIns="0" rIns="0" bIns="0" rtlCol="0" anchor="t"/>
           <a:lstStyle/>
           <a:p>
-            <a:pPr algn="r" indent="0" marL="0">
+            <a:pPr marL="0" indent="0" algn="r">
               <a:buNone/>
             </a:pPr>
             <a:r>
@@ -15372,7 +15351,7 @@
           <a:bodyPr wrap="square" lIns="0" tIns="0" rIns="0" bIns="0" rtlCol="0" anchor="t"/>
           <a:lstStyle/>
           <a:p>
-            <a:pPr indent="0" marL="0">
+            <a:pPr marL="0" indent="0">
               <a:buNone/>
             </a:pPr>
             <a:r>
@@ -15435,7 +15414,7 @@
           <a:bodyPr wrap="square" lIns="0" tIns="0" rIns="0" bIns="0" rtlCol="0" anchor="t"/>
           <a:lstStyle/>
           <a:p>
-            <a:pPr indent="0" marL="0">
+            <a:pPr marL="0" indent="0">
               <a:spcAft>
                 <a:spcPts val="800"/>
               </a:spcAft>
@@ -15452,7 +15431,7 @@
             <a:endParaRPr lang="en-US" sz="1400" dirty="0"/>
           </a:p>
           <a:p>
-            <a:pPr indent="0" marL="0">
+            <a:pPr marL="0" indent="0">
               <a:spcAft>
                 <a:spcPts val="800"/>
               </a:spcAft>
@@ -15472,7 +15451,7 @@
             <a:endParaRPr lang="en-US" sz="1400" dirty="0"/>
           </a:p>
           <a:p>
-            <a:pPr indent="0" marL="0">
+            <a:pPr marL="0" indent="0">
               <a:spcAft>
                 <a:spcPts val="800"/>
               </a:spcAft>
@@ -15492,7 +15471,7 @@
             <a:endParaRPr lang="en-US" sz="1400" dirty="0"/>
           </a:p>
           <a:p>
-            <a:pPr indent="0" marL="0">
+            <a:pPr marL="0" indent="0">
               <a:spcAft>
                 <a:spcPts val="800"/>
               </a:spcAft>
@@ -15515,7 +15494,7 @@
       </p:sp>
       <p:sp>
         <p:nvSpPr>
-          <p:cNvPr id="25" name="Slide Number Placeholder 0"/>
+          <p:cNvPr id="3" name="Slide Number Placeholder 0"/>
           <p:cNvSpPr>
             <a:spLocks noGrp="1"/>
           </p:cNvSpPr>
@@ -15533,7 +15512,7 @@
           </a:prstGeom>
           <a:extLst>
             <a:ext uri="{C572A759-6A51-4108-AA02-DFA0A04FC94B}">
-              <ma14:wrappingTextBoxFlag xmlns:ma14="http://schemas.microsoft.com/office/mac/drawingml/2011/main" val="0"/>
+              <ma14:wrappingTextBoxFlag xmlns:ma14="http://schemas.microsoft.com/office/mac/drawingml/2011/main" xmlns="" val="0"/>
             </a:ext>
           </a:extLst>
         </p:spPr>
@@ -15551,7 +15530,7 @@
           <a:p>
             <a:pPr algn="r"/>
             <a:fld id="{F7021451-1387-4CA6-816F-3879F97B5CBC}" type="slidenum">
-              <a:rPr b="0" lang="en-US"/>
+              <a:rPr lang="en-US" b="0"/>
               <a:t>7</a:t>
             </a:fld>
             <a:endParaRPr lang="en-US"/>
@@ -15586,9 +15565,11 @@
       <p:sp>
         <p:nvSpPr>
           <p:cNvPr id="2" name="Text 0"/>
-          <p:cNvSpPr/>
+          <p:cNvSpPr>
+            <a:spLocks noGrp="1"/>
+          </p:cNvSpPr>
           <p:nvPr>
-            <p:ph idx="100" type="title" hasCustomPrompt="1"/>
+            <p:ph type="title" idx="100" hasCustomPrompt="1"/>
           </p:nvPr>
         </p:nvSpPr>
         <p:spPr>
@@ -15606,7 +15587,7 @@
           <a:bodyPr wrap="square" lIns="0" tIns="0" rIns="0" bIns="0" rtlCol="0" anchor="ctr"/>
           <a:lstStyle/>
           <a:p>
-            <a:pPr indent="0" marL="0">
+            <a:pPr marL="0" indent="0">
               <a:buNone/>
             </a:pPr>
             <a:r>
@@ -15649,7 +15630,10 @@
         </p:spPr>
         <p:txBody>
           <a:bodyPr/>
-          <a:p/>
+          <a:lstStyle/>
+          <a:p>
+            <a:endParaRPr/>
+          </a:p>
         </p:txBody>
       </p:sp>
       <p:sp>
@@ -15673,7 +15657,7 @@
           <a:bodyPr wrap="square" lIns="0" tIns="0" rIns="0" bIns="0" rtlCol="0" anchor="ctr"/>
           <a:lstStyle/>
           <a:p>
-            <a:pPr indent="0" marL="0">
+            <a:pPr marL="0" indent="0">
               <a:buNone/>
             </a:pPr>
             <a:r>
@@ -15716,7 +15700,10 @@
         </p:spPr>
         <p:txBody>
           <a:bodyPr/>
-          <a:p/>
+          <a:lstStyle/>
+          <a:p>
+            <a:endParaRPr/>
+          </a:p>
         </p:txBody>
       </p:sp>
       <p:sp>
@@ -15740,7 +15727,7 @@
           <a:bodyPr wrap="square" lIns="0" tIns="0" rIns="0" bIns="0" rtlCol="0" anchor="ctr"/>
           <a:lstStyle/>
           <a:p>
-            <a:pPr indent="0" marL="0">
+            <a:pPr marL="0" indent="0">
               <a:buNone/>
             </a:pPr>
             <a:r>
@@ -15776,7 +15763,7 @@
           <a:bodyPr wrap="square" lIns="0" tIns="0" rIns="0" bIns="0" rtlCol="0" anchor="ctr"/>
           <a:lstStyle/>
           <a:p>
-            <a:pPr indent="0" marL="0">
+            <a:pPr marL="0" indent="0">
               <a:buNone/>
             </a:pPr>
             <a:r>
@@ -15819,7 +15806,10 @@
         </p:spPr>
         <p:txBody>
           <a:bodyPr/>
-          <a:p/>
+          <a:lstStyle/>
+          <a:p>
+            <a:endParaRPr/>
+          </a:p>
         </p:txBody>
       </p:sp>
       <p:sp>
@@ -15843,7 +15833,7 @@
           <a:bodyPr wrap="square" lIns="0" tIns="0" rIns="0" bIns="0" rtlCol="0" anchor="ctr"/>
           <a:lstStyle/>
           <a:p>
-            <a:pPr indent="0" marL="0">
+            <a:pPr marL="0" indent="0">
               <a:buNone/>
             </a:pPr>
             <a:r>
@@ -15879,7 +15869,7 @@
           <a:bodyPr wrap="square" lIns="0" tIns="0" rIns="0" bIns="0" rtlCol="0" anchor="ctr"/>
           <a:lstStyle/>
           <a:p>
-            <a:pPr indent="0" marL="0">
+            <a:pPr marL="0" indent="0">
               <a:buNone/>
             </a:pPr>
             <a:r>
@@ -15922,7 +15912,10 @@
         </p:spPr>
         <p:txBody>
           <a:bodyPr/>
-          <a:p/>
+          <a:lstStyle/>
+          <a:p>
+            <a:endParaRPr/>
+          </a:p>
         </p:txBody>
       </p:sp>
       <p:sp>
@@ -15946,7 +15939,7 @@
           <a:bodyPr wrap="square" lIns="0" tIns="0" rIns="0" bIns="0" rtlCol="0" anchor="ctr"/>
           <a:lstStyle/>
           <a:p>
-            <a:pPr indent="0" marL="0">
+            <a:pPr marL="0" indent="0">
               <a:buNone/>
             </a:pPr>
             <a:r>
@@ -15982,7 +15975,7 @@
           <a:bodyPr wrap="square" lIns="0" tIns="0" rIns="0" bIns="0" rtlCol="0" anchor="ctr"/>
           <a:lstStyle/>
           <a:p>
-            <a:pPr indent="0" marL="0">
+            <a:pPr marL="0" indent="0">
               <a:buNone/>
             </a:pPr>
             <a:r>
@@ -16025,7 +16018,10 @@
         </p:spPr>
         <p:txBody>
           <a:bodyPr/>
-          <a:p/>
+          <a:lstStyle/>
+          <a:p>
+            <a:endParaRPr/>
+          </a:p>
         </p:txBody>
       </p:sp>
       <p:sp>
@@ -16049,7 +16045,7 @@
           <a:bodyPr wrap="square" lIns="0" tIns="0" rIns="0" bIns="0" rtlCol="0" anchor="ctr"/>
           <a:lstStyle/>
           <a:p>
-            <a:pPr indent="0" marL="0">
+            <a:pPr marL="0" indent="0">
               <a:buNone/>
             </a:pPr>
             <a:r>
@@ -16085,7 +16081,7 @@
           <a:bodyPr wrap="square" lIns="0" tIns="0" rIns="0" bIns="0" rtlCol="0" anchor="ctr"/>
           <a:lstStyle/>
           <a:p>
-            <a:pPr indent="0" marL="0">
+            <a:pPr marL="0" indent="0">
               <a:buNone/>
             </a:pPr>
             <a:r>
@@ -16128,7 +16124,10 @@
         </p:spPr>
         <p:txBody>
           <a:bodyPr/>
-          <a:p/>
+          <a:lstStyle/>
+          <a:p>
+            <a:endParaRPr/>
+          </a:p>
         </p:txBody>
       </p:sp>
       <p:sp>
@@ -16152,7 +16151,7 @@
           <a:bodyPr wrap="square" lIns="0" tIns="0" rIns="0" bIns="0" rtlCol="0" anchor="ctr"/>
           <a:lstStyle/>
           <a:p>
-            <a:pPr indent="0" marL="0">
+            <a:pPr marL="0" indent="0">
               <a:buNone/>
             </a:pPr>
             <a:r>
@@ -16188,7 +16187,7 @@
           <a:bodyPr wrap="square" lIns="0" tIns="0" rIns="0" bIns="0" rtlCol="0" anchor="ctr"/>
           <a:lstStyle/>
           <a:p>
-            <a:pPr indent="0" marL="0">
+            <a:pPr marL="0" indent="0">
               <a:buNone/>
             </a:pPr>
             <a:r>
@@ -16231,7 +16230,10 @@
         </p:spPr>
         <p:txBody>
           <a:bodyPr/>
-          <a:p/>
+          <a:lstStyle/>
+          <a:p>
+            <a:endParaRPr/>
+          </a:p>
         </p:txBody>
       </p:sp>
       <p:sp>
@@ -16255,7 +16257,7 @@
           <a:bodyPr wrap="square" lIns="0" tIns="0" rIns="0" bIns="0" rtlCol="0" anchor="ctr"/>
           <a:lstStyle/>
           <a:p>
-            <a:pPr indent="0" marL="0">
+            <a:pPr marL="0" indent="0">
               <a:buNone/>
             </a:pPr>
             <a:r>
@@ -16298,7 +16300,10 @@
         </p:spPr>
         <p:txBody>
           <a:bodyPr/>
-          <a:p/>
+          <a:lstStyle/>
+          <a:p>
+            <a:endParaRPr/>
+          </a:p>
         </p:txBody>
       </p:sp>
       <p:sp>
@@ -16322,7 +16327,7 @@
           <a:bodyPr wrap="square" lIns="0" tIns="0" rIns="0" bIns="0" rtlCol="0" anchor="ctr"/>
           <a:lstStyle/>
           <a:p>
-            <a:pPr indent="0" marL="0">
+            <a:pPr marL="0" indent="0">
               <a:buNone/>
             </a:pPr>
             <a:r>
@@ -16358,7 +16363,7 @@
           <a:bodyPr wrap="square" lIns="0" tIns="0" rIns="0" bIns="0" rtlCol="0" anchor="ctr"/>
           <a:lstStyle/>
           <a:p>
-            <a:pPr indent="0" marL="0">
+            <a:pPr marL="0" indent="0">
               <a:buNone/>
             </a:pPr>
             <a:r>
@@ -16401,7 +16406,10 @@
         </p:spPr>
         <p:txBody>
           <a:bodyPr/>
-          <a:p/>
+          <a:lstStyle/>
+          <a:p>
+            <a:endParaRPr/>
+          </a:p>
         </p:txBody>
       </p:sp>
       <p:sp>
@@ -16425,7 +16433,7 @@
           <a:bodyPr wrap="square" lIns="0" tIns="0" rIns="0" bIns="0" rtlCol="0" anchor="ctr"/>
           <a:lstStyle/>
           <a:p>
-            <a:pPr indent="0" marL="0">
+            <a:pPr marL="0" indent="0">
               <a:buNone/>
             </a:pPr>
             <a:r>
@@ -16461,7 +16469,7 @@
           <a:bodyPr wrap="square" lIns="0" tIns="0" rIns="0" bIns="0" rtlCol="0" anchor="ctr"/>
           <a:lstStyle/>
           <a:p>
-            <a:pPr indent="0" marL="0">
+            <a:pPr marL="0" indent="0">
               <a:buNone/>
             </a:pPr>
             <a:r>
@@ -16504,7 +16512,10 @@
         </p:spPr>
         <p:txBody>
           <a:bodyPr/>
-          <a:p/>
+          <a:lstStyle/>
+          <a:p>
+            <a:endParaRPr/>
+          </a:p>
         </p:txBody>
       </p:sp>
       <p:sp>
@@ -16528,7 +16539,7 @@
           <a:bodyPr wrap="square" lIns="0" tIns="0" rIns="0" bIns="0" rtlCol="0" anchor="ctr"/>
           <a:lstStyle/>
           <a:p>
-            <a:pPr indent="0" marL="0">
+            <a:pPr marL="0" indent="0">
               <a:buNone/>
             </a:pPr>
             <a:r>
@@ -16564,7 +16575,7 @@
           <a:bodyPr wrap="square" lIns="0" tIns="0" rIns="0" bIns="0" rtlCol="0" anchor="ctr"/>
           <a:lstStyle/>
           <a:p>
-            <a:pPr indent="0" marL="0">
+            <a:pPr marL="0" indent="0">
               <a:buNone/>
             </a:pPr>
             <a:r>
@@ -16607,7 +16618,10 @@
         </p:spPr>
         <p:txBody>
           <a:bodyPr/>
-          <a:p/>
+          <a:lstStyle/>
+          <a:p>
+            <a:endParaRPr/>
+          </a:p>
         </p:txBody>
       </p:sp>
       <p:sp>
@@ -16631,7 +16645,7 @@
           <a:bodyPr wrap="square" lIns="0" tIns="0" rIns="0" bIns="0" rtlCol="0" anchor="ctr"/>
           <a:lstStyle/>
           <a:p>
-            <a:pPr indent="0" marL="0">
+            <a:pPr marL="0" indent="0">
               <a:buNone/>
             </a:pPr>
             <a:r>
@@ -16667,7 +16681,7 @@
           <a:bodyPr wrap="square" lIns="0" tIns="0" rIns="0" bIns="0" rtlCol="0" anchor="ctr"/>
           <a:lstStyle/>
           <a:p>
-            <a:pPr indent="0" marL="0">
+            <a:pPr marL="0" indent="0">
               <a:buNone/>
             </a:pPr>
             <a:r>
@@ -16730,7 +16744,7 @@
           <a:bodyPr wrap="square" lIns="0" tIns="0" rIns="0" bIns="0" rtlCol="0" anchor="ctr"/>
           <a:lstStyle/>
           <a:p>
-            <a:pPr indent="0" marL="0">
+            <a:pPr marL="0" indent="0">
               <a:buNone/>
             </a:pPr>
             <a:r>
@@ -16766,7 +16780,7 @@
           <a:bodyPr wrap="square" lIns="0" tIns="0" rIns="0" bIns="0" rtlCol="0" anchor="ctr"/>
           <a:lstStyle/>
           <a:p>
-            <a:pPr indent="0" marL="0">
+            <a:pPr marL="0" indent="0">
               <a:buNone/>
             </a:pPr>
             <a:r>
@@ -16783,7 +16797,7 @@
       </p:sp>
       <p:sp>
         <p:nvSpPr>
-          <p:cNvPr id="25" name="Slide Number Placeholder 0"/>
+          <p:cNvPr id="3" name="Slide Number Placeholder 0"/>
           <p:cNvSpPr>
             <a:spLocks noGrp="1"/>
           </p:cNvSpPr>
@@ -16801,7 +16815,7 @@
           </a:prstGeom>
           <a:extLst>
             <a:ext uri="{C572A759-6A51-4108-AA02-DFA0A04FC94B}">
-              <ma14:wrappingTextBoxFlag xmlns:ma14="http://schemas.microsoft.com/office/mac/drawingml/2011/main" val="0"/>
+              <ma14:wrappingTextBoxFlag xmlns:ma14="http://schemas.microsoft.com/office/mac/drawingml/2011/main" xmlns="" val="0"/>
             </a:ext>
           </a:extLst>
         </p:spPr>
@@ -16819,7 +16833,7 @@
           <a:p>
             <a:pPr algn="r"/>
             <a:fld id="{F7021451-1387-4CA6-816F-3879F97B5CBC}" type="slidenum">
-              <a:rPr b="0" lang="en-US"/>
+              <a:rPr lang="en-US" b="0"/>
               <a:t>8</a:t>
             </a:fld>
             <a:endParaRPr lang="en-US"/>
@@ -16854,9 +16868,11 @@
       <p:sp>
         <p:nvSpPr>
           <p:cNvPr id="2" name="Text 0"/>
-          <p:cNvSpPr/>
+          <p:cNvSpPr>
+            <a:spLocks noGrp="1"/>
+          </p:cNvSpPr>
           <p:nvPr>
-            <p:ph idx="100" type="title" hasCustomPrompt="1"/>
+            <p:ph type="title" idx="100" hasCustomPrompt="1"/>
           </p:nvPr>
         </p:nvSpPr>
         <p:spPr>
@@ -16874,7 +16890,7 @@
           <a:bodyPr wrap="square" lIns="0" tIns="0" rIns="0" bIns="0" rtlCol="0" anchor="ctr"/>
           <a:lstStyle/>
           <a:p>
-            <a:pPr indent="0" marL="0">
+            <a:pPr marL="0" indent="0">
               <a:buNone/>
             </a:pPr>
             <a:r>
@@ -16937,7 +16953,7 @@
           <a:bodyPr wrap="square" lIns="0" tIns="0" rIns="0" bIns="0" rtlCol="0" anchor="t"/>
           <a:lstStyle/>
           <a:p>
-            <a:pPr indent="0" marL="0">
+            <a:pPr marL="0" indent="0">
               <a:buNone/>
             </a:pPr>
             <a:r>
@@ -16973,7 +16989,7 @@
           <a:bodyPr wrap="square" lIns="0" tIns="0" rIns="0" bIns="0" rtlCol="0" anchor="t"/>
           <a:lstStyle/>
           <a:p>
-            <a:pPr indent="0" marL="0">
+            <a:pPr marL="0" indent="0">
               <a:buNone/>
             </a:pPr>
             <a:r>
@@ -17009,7 +17025,7 @@
           <a:bodyPr wrap="square" lIns="0" tIns="0" rIns="0" bIns="0" rtlCol="0" anchor="t"/>
           <a:lstStyle/>
           <a:p>
-            <a:pPr indent="0" marL="0">
+            <a:pPr marL="0" indent="0">
               <a:buNone/>
             </a:pPr>
             <a:r>
@@ -17045,7 +17061,7 @@
           <a:bodyPr wrap="square" lIns="0" tIns="0" rIns="0" bIns="0" rtlCol="0" anchor="t"/>
           <a:lstStyle/>
           <a:p>
-            <a:pPr indent="0" marL="0">
+            <a:pPr marL="0" indent="0">
               <a:buNone/>
             </a:pPr>
             <a:r>
@@ -17132,7 +17148,7 @@
           <a:bodyPr wrap="square" lIns="0" tIns="0" rIns="0" bIns="0" rtlCol="0" anchor="t"/>
           <a:lstStyle/>
           <a:p>
-            <a:pPr indent="0" marL="0">
+            <a:pPr marL="0" indent="0">
               <a:buNone/>
             </a:pPr>
             <a:r>
@@ -17168,7 +17184,7 @@
           <a:bodyPr wrap="square" lIns="0" tIns="0" rIns="0" bIns="0" rtlCol="0" anchor="t"/>
           <a:lstStyle/>
           <a:p>
-            <a:pPr indent="0" marL="0">
+            <a:pPr marL="0" indent="0">
               <a:buNone/>
             </a:pPr>
             <a:r>
@@ -17204,7 +17220,7 @@
           <a:bodyPr wrap="square" lIns="0" tIns="0" rIns="0" bIns="0" rtlCol="0" anchor="t"/>
           <a:lstStyle/>
           <a:p>
-            <a:pPr indent="0" marL="0">
+            <a:pPr marL="0" indent="0">
               <a:buNone/>
             </a:pPr>
             <a:r>
@@ -17240,7 +17256,7 @@
           <a:bodyPr wrap="square" lIns="0" tIns="0" rIns="0" bIns="0" rtlCol="0" anchor="t"/>
           <a:lstStyle/>
           <a:p>
-            <a:pPr indent="0" marL="0">
+            <a:pPr marL="0" indent="0">
               <a:buNone/>
             </a:pPr>
             <a:r>
@@ -17276,7 +17292,7 @@
           <a:bodyPr wrap="square" lIns="0" tIns="0" rIns="0" bIns="0" rtlCol="0" anchor="t"/>
           <a:lstStyle/>
           <a:p>
-            <a:pPr indent="0" marL="0">
+            <a:pPr marL="0" indent="0">
               <a:buNone/>
             </a:pPr>
             <a:r>
@@ -17311,7 +17327,7 @@
           </a:prstGeom>
           <a:extLst>
             <a:ext uri="{C572A759-6A51-4108-AA02-DFA0A04FC94B}">
-              <ma14:wrappingTextBoxFlag xmlns:ma14="http://schemas.microsoft.com/office/mac/drawingml/2011/main" val="0"/>
+              <ma14:wrappingTextBoxFlag xmlns:ma14="http://schemas.microsoft.com/office/mac/drawingml/2011/main" xmlns="" val="0"/>
             </a:ext>
           </a:extLst>
         </p:spPr>
@@ -17329,7 +17345,7 @@
           <a:p>
             <a:pPr algn="r"/>
             <a:fld id="{F7021451-1387-4CA6-816F-3879F97B5CBC}" type="slidenum">
-              <a:rPr b="0" lang="en-US"/>
+              <a:rPr lang="en-US" b="0"/>
               <a:t>9</a:t>
             </a:fld>
             <a:endParaRPr lang="en-US"/>
@@ -17637,4 +17653,299 @@
     </a:ext>
   </a:extLst>
 </a:theme>
+</file>
+
+<file path=ppt/theme/theme2.xml><?xml version="1.0" encoding="utf-8"?>
+<a:theme xmlns:a="http://schemas.openxmlformats.org/drawingml/2006/main" name="Thème Office">
+  <a:themeElements>
+    <a:clrScheme name="Office">
+      <a:dk1>
+        <a:sysClr val="windowText" lastClr="000000"/>
+      </a:dk1>
+      <a:lt1>
+        <a:sysClr val="window" lastClr="FFFFFF"/>
+      </a:lt1>
+      <a:dk2>
+        <a:srgbClr val="44546A"/>
+      </a:dk2>
+      <a:lt2>
+        <a:srgbClr val="E7E6E6"/>
+      </a:lt2>
+      <a:accent1>
+        <a:srgbClr val="4472C4"/>
+      </a:accent1>
+      <a:accent2>
+        <a:srgbClr val="ED7D31"/>
+      </a:accent2>
+      <a:accent3>
+        <a:srgbClr val="A5A5A5"/>
+      </a:accent3>
+      <a:accent4>
+        <a:srgbClr val="FFC000"/>
+      </a:accent4>
+      <a:accent5>
+        <a:srgbClr val="5B9BD5"/>
+      </a:accent5>
+      <a:accent6>
+        <a:srgbClr val="70AD47"/>
+      </a:accent6>
+      <a:hlink>
+        <a:srgbClr val="0563C1"/>
+      </a:hlink>
+      <a:folHlink>
+        <a:srgbClr val="954F72"/>
+      </a:folHlink>
+    </a:clrScheme>
+    <a:fontScheme name="Office">
+      <a:majorFont>
+        <a:latin typeface="Calibri Light" panose="020F0302020204030204"/>
+        <a:ea typeface=""/>
+        <a:cs typeface=""/>
+        <a:font script="Jpan" typeface="游ゴシック Light"/>
+        <a:font script="Hang" typeface="맑은 고딕"/>
+        <a:font script="Hans" typeface="等线 Light"/>
+        <a:font script="Hant" typeface="新細明體"/>
+        <a:font script="Arab" typeface="Times New Roman"/>
+        <a:font script="Hebr" typeface="Times New Roman"/>
+        <a:font script="Thai" typeface="Angsana New"/>
+        <a:font script="Ethi" typeface="Nyala"/>
+        <a:font script="Beng" typeface="Vrinda"/>
+        <a:font script="Gujr" typeface="Shruti"/>
+        <a:font script="Khmr" typeface="MoolBoran"/>
+        <a:font script="Knda" typeface="Tunga"/>
+        <a:font script="Guru" typeface="Raavi"/>
+        <a:font script="Cans" typeface="Euphemia"/>
+        <a:font script="Cher" typeface="Plantagenet Cherokee"/>
+        <a:font script="Yiii" typeface="Microsoft Yi Baiti"/>
+        <a:font script="Tibt" typeface="Microsoft Himalaya"/>
+        <a:font script="Thaa" typeface="MV Boli"/>
+        <a:font script="Deva" typeface="Mangal"/>
+        <a:font script="Telu" typeface="Gautami"/>
+        <a:font script="Taml" typeface="Latha"/>
+        <a:font script="Syrc" typeface="Estrangelo Edessa"/>
+        <a:font script="Orya" typeface="Kalinga"/>
+        <a:font script="Mlym" typeface="Kartika"/>
+        <a:font script="Laoo" typeface="DokChampa"/>
+        <a:font script="Sinh" typeface="Iskoola Pota"/>
+        <a:font script="Mong" typeface="Mongolian Baiti"/>
+        <a:font script="Viet" typeface="Times New Roman"/>
+        <a:font script="Uigh" typeface="Microsoft Uighur"/>
+        <a:font script="Geor" typeface="Sylfaen"/>
+        <a:font script="Armn" typeface="Arial"/>
+        <a:font script="Bugi" typeface="Leelawadee UI"/>
+        <a:font script="Bopo" typeface="Microsoft JhengHei"/>
+        <a:font script="Java" typeface="Javanese Text"/>
+        <a:font script="Lisu" typeface="Segoe UI"/>
+        <a:font script="Mymr" typeface="Myanmar Text"/>
+        <a:font script="Nkoo" typeface="Ebrima"/>
+        <a:font script="Olck" typeface="Nirmala UI"/>
+        <a:font script="Osma" typeface="Ebrima"/>
+        <a:font script="Phag" typeface="Phagspa"/>
+        <a:font script="Syrn" typeface="Estrangelo Edessa"/>
+        <a:font script="Syrj" typeface="Estrangelo Edessa"/>
+        <a:font script="Syre" typeface="Estrangelo Edessa"/>
+        <a:font script="Sora" typeface="Nirmala UI"/>
+        <a:font script="Tale" typeface="Microsoft Tai Le"/>
+        <a:font script="Talu" typeface="Microsoft New Tai Lue"/>
+        <a:font script="Tfng" typeface="Ebrima"/>
+      </a:majorFont>
+      <a:minorFont>
+        <a:latin typeface="Calibri" panose="020F0502020204030204"/>
+        <a:ea typeface=""/>
+        <a:cs typeface=""/>
+        <a:font script="Jpan" typeface="游ゴシック"/>
+        <a:font script="Hang" typeface="맑은 고딕"/>
+        <a:font script="Hans" typeface="等线"/>
+        <a:font script="Hant" typeface="新細明體"/>
+        <a:font script="Arab" typeface="Arial"/>
+        <a:font script="Hebr" typeface="Arial"/>
+        <a:font script="Thai" typeface="Cordia New"/>
+        <a:font script="Ethi" typeface="Nyala"/>
+        <a:font script="Beng" typeface="Vrinda"/>
+        <a:font script="Gujr" typeface="Shruti"/>
+        <a:font script="Khmr" typeface="DaunPenh"/>
+        <a:font script="Knda" typeface="Tunga"/>
+        <a:font script="Guru" typeface="Raavi"/>
+        <a:font script="Cans" typeface="Euphemia"/>
+        <a:font script="Cher" typeface="Plantagenet Cherokee"/>
+        <a:font script="Yiii" typeface="Microsoft Yi Baiti"/>
+        <a:font script="Tibt" typeface="Microsoft Himalaya"/>
+        <a:font script="Thaa" typeface="MV Boli"/>
+        <a:font script="Deva" typeface="Mangal"/>
+        <a:font script="Telu" typeface="Gautami"/>
+        <a:font script="Taml" typeface="Latha"/>
+        <a:font script="Syrc" typeface="Estrangelo Edessa"/>
+        <a:font script="Orya" typeface="Kalinga"/>
+        <a:font script="Mlym" typeface="Kartika"/>
+        <a:font script="Laoo" typeface="DokChampa"/>
+        <a:font script="Sinh" typeface="Iskoola Pota"/>
+        <a:font script="Mong" typeface="Mongolian Baiti"/>
+        <a:font script="Viet" typeface="Arial"/>
+        <a:font script="Uigh" typeface="Microsoft Uighur"/>
+        <a:font script="Geor" typeface="Sylfaen"/>
+        <a:font script="Armn" typeface="Arial"/>
+        <a:font script="Bugi" typeface="Leelawadee UI"/>
+        <a:font script="Bopo" typeface="Microsoft JhengHei"/>
+        <a:font script="Java" typeface="Javanese Text"/>
+        <a:font script="Lisu" typeface="Segoe UI"/>
+        <a:font script="Mymr" typeface="Myanmar Text"/>
+        <a:font script="Nkoo" typeface="Ebrima"/>
+        <a:font script="Olck" typeface="Nirmala UI"/>
+        <a:font script="Osma" typeface="Ebrima"/>
+        <a:font script="Phag" typeface="Phagspa"/>
+        <a:font script="Syrn" typeface="Estrangelo Edessa"/>
+        <a:font script="Syrj" typeface="Estrangelo Edessa"/>
+        <a:font script="Syre" typeface="Estrangelo Edessa"/>
+        <a:font script="Sora" typeface="Nirmala UI"/>
+        <a:font script="Tale" typeface="Microsoft Tai Le"/>
+        <a:font script="Talu" typeface="Microsoft New Tai Lue"/>
+        <a:font script="Tfng" typeface="Ebrima"/>
+      </a:minorFont>
+    </a:fontScheme>
+    <a:fmtScheme name="Office">
+      <a:fillStyleLst>
+        <a:solidFill>
+          <a:schemeClr val="phClr"/>
+        </a:solidFill>
+        <a:gradFill rotWithShape="1">
+          <a:gsLst>
+            <a:gs pos="0">
+              <a:schemeClr val="phClr">
+                <a:lumMod val="110000"/>
+                <a:satMod val="105000"/>
+                <a:tint val="67000"/>
+              </a:schemeClr>
+            </a:gs>
+            <a:gs pos="50000">
+              <a:schemeClr val="phClr">
+                <a:lumMod val="105000"/>
+                <a:satMod val="103000"/>
+                <a:tint val="73000"/>
+              </a:schemeClr>
+            </a:gs>
+            <a:gs pos="100000">
+              <a:schemeClr val="phClr">
+                <a:lumMod val="105000"/>
+                <a:satMod val="109000"/>
+                <a:tint val="81000"/>
+              </a:schemeClr>
+            </a:gs>
+          </a:gsLst>
+          <a:lin ang="5400000" scaled="0"/>
+        </a:gradFill>
+        <a:gradFill rotWithShape="1">
+          <a:gsLst>
+            <a:gs pos="0">
+              <a:schemeClr val="phClr">
+                <a:satMod val="103000"/>
+                <a:lumMod val="102000"/>
+                <a:tint val="94000"/>
+              </a:schemeClr>
+            </a:gs>
+            <a:gs pos="50000">
+              <a:schemeClr val="phClr">
+                <a:satMod val="110000"/>
+                <a:lumMod val="100000"/>
+                <a:shade val="100000"/>
+              </a:schemeClr>
+            </a:gs>
+            <a:gs pos="100000">
+              <a:schemeClr val="phClr">
+                <a:lumMod val="99000"/>
+                <a:satMod val="120000"/>
+                <a:shade val="78000"/>
+              </a:schemeClr>
+            </a:gs>
+          </a:gsLst>
+          <a:lin ang="5400000" scaled="0"/>
+        </a:gradFill>
+      </a:fillStyleLst>
+      <a:lnStyleLst>
+        <a:ln w="6350" cap="flat" cmpd="sng" algn="ctr">
+          <a:solidFill>
+            <a:schemeClr val="phClr"/>
+          </a:solidFill>
+          <a:prstDash val="solid"/>
+          <a:miter lim="800000"/>
+        </a:ln>
+        <a:ln w="12700" cap="flat" cmpd="sng" algn="ctr">
+          <a:solidFill>
+            <a:schemeClr val="phClr"/>
+          </a:solidFill>
+          <a:prstDash val="solid"/>
+          <a:miter lim="800000"/>
+        </a:ln>
+        <a:ln w="19050" cap="flat" cmpd="sng" algn="ctr">
+          <a:solidFill>
+            <a:schemeClr val="phClr"/>
+          </a:solidFill>
+          <a:prstDash val="solid"/>
+          <a:miter lim="800000"/>
+        </a:ln>
+      </a:lnStyleLst>
+      <a:effectStyleLst>
+        <a:effectStyle>
+          <a:effectLst/>
+        </a:effectStyle>
+        <a:effectStyle>
+          <a:effectLst/>
+        </a:effectStyle>
+        <a:effectStyle>
+          <a:effectLst>
+            <a:outerShdw blurRad="57150" dist="19050" dir="5400000" algn="ctr" rotWithShape="0">
+              <a:srgbClr val="000000">
+                <a:alpha val="63000"/>
+              </a:srgbClr>
+            </a:outerShdw>
+          </a:effectLst>
+        </a:effectStyle>
+      </a:effectStyleLst>
+      <a:bgFillStyleLst>
+        <a:solidFill>
+          <a:schemeClr val="phClr"/>
+        </a:solidFill>
+        <a:solidFill>
+          <a:schemeClr val="phClr">
+            <a:tint val="95000"/>
+            <a:satMod val="170000"/>
+          </a:schemeClr>
+        </a:solidFill>
+        <a:gradFill rotWithShape="1">
+          <a:gsLst>
+            <a:gs pos="0">
+              <a:schemeClr val="phClr">
+                <a:tint val="93000"/>
+                <a:satMod val="150000"/>
+                <a:shade val="98000"/>
+                <a:lumMod val="102000"/>
+              </a:schemeClr>
+            </a:gs>
+            <a:gs pos="50000">
+              <a:schemeClr val="phClr">
+                <a:tint val="98000"/>
+                <a:satMod val="130000"/>
+                <a:shade val="90000"/>
+                <a:lumMod val="103000"/>
+              </a:schemeClr>
+            </a:gs>
+            <a:gs pos="100000">
+              <a:schemeClr val="phClr">
+                <a:shade val="63000"/>
+                <a:satMod val="120000"/>
+              </a:schemeClr>
+            </a:gs>
+          </a:gsLst>
+          <a:lin ang="5400000" scaled="0"/>
+        </a:gradFill>
+      </a:bgFillStyleLst>
+    </a:fmtScheme>
+  </a:themeElements>
+  <a:objectDefaults/>
+  <a:extraClrSchemeLst/>
+  <a:extLst>
+    <a:ext uri="{05A4C25C-085E-4340-85A3-A5531E510DB2}">
+      <thm15:themeFamily xmlns:thm15="http://schemas.microsoft.com/office/thememl/2012/main" name="Office Theme" id="{62F939B6-93AF-4DB8-9C6B-D6C7DFDC589F}" vid="{4A3C46E8-61CC-4603-A589-7422A47A8E4A}"/>
+    </a:ext>
+  </a:extLst>
+</a:theme>
 </file>
</xml_diff>